<commit_message>
Lamina 2 mejorada: texto de contexto + 4 tarjetas verticales con iconos (estilo cuadros adjuntos)
</commit_message>
<xml_diff>
--- a/Transformacion_Omnicanal_Ultima_Milla.pptx
+++ b/Transformacion_Omnicanal_Ultima_Milla.pptx
@@ -938,7 +938,7 @@
                 <a:latin typeface="Calibri"/>
                 <a:cs typeface="Calibri"/>
               </a:rPr>
-              <a:t>PRINCIPALES DESAFIOS IDENTIFICADOS</a:t>
+              <a:t>EL DESAFIO DE CAV</a:t>
             </a:r>
           </a:p>
         </p:txBody>
@@ -1055,14 +1055,84 @@
       </p:sp>
       <p:sp>
         <p:nvSpPr>
-          <p:cNvPr id="9" name="card"/>
-          <p:cNvSpPr/>
-          <p:nvPr/>
-        </p:nvSpPr>
-        <p:spPr>
-          <a:xfrm>
-            <a:off x="566928" y="1691640"/>
-            <a:ext cx="5413248" cy="2212848"/>
+          <p:cNvPr id="9" name="introtab"/>
+          <p:cNvSpPr/>
+          <p:nvPr/>
+        </p:nvSpPr>
+        <p:spPr>
+          <a:xfrm>
+            <a:off x="566928" y="1417320"/>
+            <a:ext cx="91440" cy="914400"/>
+          </a:xfrm>
+          <a:prstGeom prst="rect">
+            <a:avLst/>
+          </a:prstGeom>
+          <a:solidFill>
+            <a:srgbClr val="E8711E"/>
+          </a:solidFill>
+          <a:ln>
+            <a:noFill/>
+          </a:ln>
+        </p:spPr>
+        <p:txBody>
+          <a:bodyPr/>
+          <a:lstStyle/>
+          <a:p>
+            <a:endParaRPr lang="es-ES"/>
+          </a:p>
+        </p:txBody>
+      </p:sp>
+      <p:sp>
+        <p:nvSpPr>
+          <p:cNvPr id="10" name="tb"/>
+          <p:cNvSpPr txBox="1"/>
+          <p:nvPr/>
+        </p:nvSpPr>
+        <p:spPr>
+          <a:xfrm>
+            <a:off x="777240" y="1371600"/>
+            <a:ext cx="10881360" cy="1005840"/>
+          </a:xfrm>
+          <a:prstGeom prst="rect">
+            <a:avLst/>
+          </a:prstGeom>
+          <a:noFill/>
+        </p:spPr>
+        <p:txBody>
+          <a:bodyPr wrap="square" anchor="t" lIns="73152" tIns="36576" rIns="73152" bIns="36576">
+            <a:normAutofit/>
+          </a:bodyPr>
+          <a:lstStyle/>
+          <a:p>
+            <a:pPr marL="0" indent="0" lvl="0" algn="l">
+              <a:lnSpc>
+                <a:spcPct val="112000"/>
+              </a:lnSpc>
+              <a:buNone/>
+            </a:pPr>
+            <a:r>
+              <a:rPr lang="es-ES" sz="1400" b="0" i="0" dirty="0">
+                <a:solidFill>
+                  <a:srgbClr val="333333"/>
+                </a:solidFill>
+                <a:latin typeface="Calibri"/>
+                <a:cs typeface="Calibri"/>
+              </a:rPr>
+              <a:t>El Club de Amantes del Vino (CAV) enfrenta desafios criticos en su operacion logistica y comercial: direcciones de clientes inexactas que derivan en entregas fallidas, tiempos de despacho elevados en la Region Metropolitana y canales de venta que operan de forma aislada. Este programa aborda estos retos de manera integral, bajo una unica estrategia omnicanal.</a:t>
+            </a:r>
+          </a:p>
+        </p:txBody>
+      </p:sp>
+      <p:sp>
+        <p:nvSpPr>
+          <p:cNvPr id="11" name="card"/>
+          <p:cNvSpPr/>
+          <p:nvPr/>
+        </p:nvSpPr>
+        <p:spPr>
+          <a:xfrm>
+            <a:off x="566928" y="2514600"/>
+            <a:ext cx="2628900" cy="3657600"/>
           </a:xfrm>
           <a:prstGeom prst="roundRect">
             <a:avLst/>
@@ -1093,16 +1163,16 @@
       </p:sp>
       <p:sp>
         <p:nvSpPr>
-          <p:cNvPr id="10" name="tab"/>
-          <p:cNvSpPr/>
-          <p:nvPr/>
-        </p:nvSpPr>
-        <p:spPr>
-          <a:xfrm>
-            <a:off x="566928" y="1691640"/>
-            <a:ext cx="109728" cy="2212848"/>
-          </a:xfrm>
-          <a:prstGeom prst="rect">
+          <p:cNvPr id="12" name="badge"/>
+          <p:cNvSpPr/>
+          <p:nvPr/>
+        </p:nvSpPr>
+        <p:spPr>
+          <a:xfrm>
+            <a:off x="1287018" y="2788920"/>
+            <a:ext cx="1188720" cy="1188720"/>
+          </a:xfrm>
+          <a:prstGeom prst="ellipse">
             <a:avLst/>
           </a:prstGeom>
           <a:solidFill>
@@ -1111,25 +1181,61 @@
           <a:ln>
             <a:noFill/>
           </a:ln>
-        </p:spPr>
-        <p:txBody>
-          <a:bodyPr/>
-          <a:lstStyle/>
-          <a:p>
-            <a:endParaRPr lang="es-ES"/>
-          </a:p>
-        </p:txBody>
-      </p:sp>
-      <p:sp>
-        <p:nvSpPr>
-          <p:cNvPr id="11" name="tb"/>
+          <a:effectLst>
+            <a:outerShdw blurRad="50000" dist="25000" dir="5400000" rotWithShape="0">
+              <a:srgbClr val="000000">
+                <a:alpha val="20000"/>
+              </a:srgbClr>
+            </a:outerShdw>
+          </a:effectLst>
+        </p:spPr>
+        <p:txBody>
+          <a:bodyPr/>
+          <a:lstStyle/>
+          <a:p>
+            <a:endParaRPr lang="es-ES"/>
+          </a:p>
+        </p:txBody>
+      </p:sp>
+      <p:sp>
+        <p:nvSpPr>
+          <p:cNvPr id="13" name="db"/>
+          <p:cNvSpPr/>
+          <p:nvPr/>
+        </p:nvSpPr>
+        <p:spPr>
+          <a:xfrm>
+            <a:off x="1671066" y="3108960"/>
+            <a:ext cx="420624" cy="548640"/>
+          </a:xfrm>
+          <a:prstGeom prst="can">
+            <a:avLst/>
+          </a:prstGeom>
+          <a:noFill/>
+          <a:ln w="19050">
+            <a:solidFill>
+              <a:srgbClr val="FFFFFF"/>
+            </a:solidFill>
+          </a:ln>
+        </p:spPr>
+        <p:txBody>
+          <a:bodyPr/>
+          <a:lstStyle/>
+          <a:p>
+            <a:endParaRPr lang="es-ES"/>
+          </a:p>
+        </p:txBody>
+      </p:sp>
+      <p:sp>
+        <p:nvSpPr>
+          <p:cNvPr id="14" name="tb"/>
           <p:cNvSpPr txBox="1"/>
           <p:nvPr/>
         </p:nvSpPr>
         <p:spPr>
           <a:xfrm>
-            <a:off x="859536" y="1856232"/>
-            <a:ext cx="4956048" cy="502920"/>
+            <a:off x="658368" y="4114800"/>
+            <a:ext cx="2446020" cy="640080"/>
           </a:xfrm>
           <a:prstGeom prst="rect">
             <a:avLst/>
@@ -1142,11 +1248,14 @@
           </a:bodyPr>
           <a:lstStyle/>
           <a:p>
-            <a:pPr marL="0" indent="0" lvl="0" algn="l">
-              <a:buNone/>
-            </a:pPr>
-            <a:r>
-              <a:rPr lang="es-ES" sz="1750" b="1" i="0" dirty="0">
+            <a:pPr marL="0" indent="0" lvl="0" algn="ctr">
+              <a:lnSpc>
+                <a:spcPct val="96000"/>
+              </a:lnSpc>
+              <a:buNone/>
+            </a:pPr>
+            <a:r>
+              <a:rPr lang="es-ES" sz="1500" b="1" i="0" dirty="0">
                 <a:solidFill>
                   <a:srgbClr val="123A5E"/>
                 </a:solidFill>
@@ -1160,14 +1269,43 @@
       </p:sp>
       <p:sp>
         <p:nvSpPr>
-          <p:cNvPr id="12" name="tb"/>
+          <p:cNvPr id="15" name="uline"/>
+          <p:cNvSpPr/>
+          <p:nvPr/>
+        </p:nvSpPr>
+        <p:spPr>
+          <a:xfrm>
+            <a:off x="1561338" y="4727448"/>
+            <a:ext cx="640080" cy="36576"/>
+          </a:xfrm>
+          <a:prstGeom prst="rect">
+            <a:avLst/>
+          </a:prstGeom>
+          <a:solidFill>
+            <a:srgbClr val="123A5E"/>
+          </a:solidFill>
+          <a:ln>
+            <a:noFill/>
+          </a:ln>
+        </p:spPr>
+        <p:txBody>
+          <a:bodyPr/>
+          <a:lstStyle/>
+          <a:p>
+            <a:endParaRPr lang="es-ES"/>
+          </a:p>
+        </p:txBody>
+      </p:sp>
+      <p:sp>
+        <p:nvSpPr>
+          <p:cNvPr id="16" name="tb"/>
           <p:cNvSpPr txBox="1"/>
           <p:nvPr/>
         </p:nvSpPr>
         <p:spPr>
           <a:xfrm>
-            <a:off x="841248" y="2404872"/>
-            <a:ext cx="4910328" cy="1389888"/>
+            <a:off x="768096" y="4910328"/>
+            <a:ext cx="2263140" cy="1143000"/>
           </a:xfrm>
           <a:prstGeom prst="rect">
             <a:avLst/>
@@ -1182,7 +1320,7 @@
           <a:p>
             <a:pPr marL="228600" indent="-228600" lvl="0" algn="l">
               <a:lnSpc>
-                <a:spcPct val="100000"/>
+                <a:spcPct val="104000"/>
               </a:lnSpc>
               <a:spcAft>
                 <a:spcPts val="260"/>
@@ -1194,20 +1332,20 @@
               <a:buChar char="•"/>
             </a:pPr>
             <a:r>
-              <a:rPr lang="es-ES" sz="1300" b="0" i="0" dirty="0">
+              <a:rPr lang="es-ES" sz="1200" b="0" i="0" dirty="0">
                 <a:solidFill>
                   <a:srgbClr val="333333"/>
                 </a:solidFill>
                 <a:latin typeface="Calibri"/>
                 <a:cs typeface="Calibri"/>
               </a:rPr>
-              <a:t>Mas de 35.000 clientes con distintos niveles de calidad en sus direcciones.</a:t>
+              <a:t>Mas de 35.000 clientes con direcciones de calidad dispar.</a:t>
             </a:r>
           </a:p>
           <a:p>
             <a:pPr marL="228600" indent="-228600" lvl="0" algn="l">
               <a:lnSpc>
-                <a:spcPct val="100000"/>
+                <a:spcPct val="104000"/>
               </a:lnSpc>
               <a:spcAft>
                 <a:spcPts val="260"/>
@@ -1219,7 +1357,7 @@
               <a:buChar char="•"/>
             </a:pPr>
             <a:r>
-              <a:rPr lang="es-ES" sz="1300" b="0" i="0" dirty="0">
+              <a:rPr lang="es-ES" sz="1200" b="0" i="0" dirty="0">
                 <a:solidFill>
                   <a:srgbClr val="333333"/>
                 </a:solidFill>
@@ -1233,14 +1371,14 @@
       </p:sp>
       <p:sp>
         <p:nvSpPr>
-          <p:cNvPr id="13" name="card"/>
-          <p:cNvSpPr/>
-          <p:nvPr/>
-        </p:nvSpPr>
-        <p:spPr>
-          <a:xfrm>
-            <a:off x="6217920" y="1691640"/>
-            <a:ext cx="5413248" cy="2212848"/>
+          <p:cNvPr id="17" name="card"/>
+          <p:cNvSpPr/>
+          <p:nvPr/>
+        </p:nvSpPr>
+        <p:spPr>
+          <a:xfrm>
+            <a:off x="3383280" y="2514600"/>
+            <a:ext cx="2628900" cy="3657600"/>
           </a:xfrm>
           <a:prstGeom prst="roundRect">
             <a:avLst/>
@@ -1271,16 +1409,16 @@
       </p:sp>
       <p:sp>
         <p:nvSpPr>
-          <p:cNvPr id="14" name="tab"/>
-          <p:cNvSpPr/>
-          <p:nvPr/>
-        </p:nvSpPr>
-        <p:spPr>
-          <a:xfrm>
-            <a:off x="6217920" y="1691640"/>
-            <a:ext cx="109728" cy="2212848"/>
-          </a:xfrm>
-          <a:prstGeom prst="rect">
+          <p:cNvPr id="18" name="badge"/>
+          <p:cNvSpPr/>
+          <p:nvPr/>
+        </p:nvSpPr>
+        <p:spPr>
+          <a:xfrm>
+            <a:off x="4103370" y="2788920"/>
+            <a:ext cx="1188720" cy="1188720"/>
+          </a:xfrm>
+          <a:prstGeom prst="ellipse">
             <a:avLst/>
           </a:prstGeom>
           <a:solidFill>
@@ -1289,25 +1427,148 @@
           <a:ln>
             <a:noFill/>
           </a:ln>
-        </p:spPr>
-        <p:txBody>
-          <a:bodyPr/>
-          <a:lstStyle/>
-          <a:p>
-            <a:endParaRPr lang="es-ES"/>
-          </a:p>
-        </p:txBody>
-      </p:sp>
-      <p:sp>
-        <p:nvSpPr>
-          <p:cNvPr id="15" name="tb"/>
+          <a:effectLst>
+            <a:outerShdw blurRad="50000" dist="25000" dir="5400000" rotWithShape="0">
+              <a:srgbClr val="000000">
+                <a:alpha val="20000"/>
+              </a:srgbClr>
+            </a:outerShdw>
+          </a:effectLst>
+        </p:spPr>
+        <p:txBody>
+          <a:bodyPr/>
+          <a:lstStyle/>
+          <a:p>
+            <a:endParaRPr lang="es-ES"/>
+          </a:p>
+        </p:txBody>
+      </p:sp>
+      <p:sp>
+        <p:nvSpPr>
+          <p:cNvPr id="19" name="cargo"/>
+          <p:cNvSpPr/>
+          <p:nvPr/>
+        </p:nvSpPr>
+        <p:spPr>
+          <a:xfrm>
+            <a:off x="4295394" y="3182112"/>
+            <a:ext cx="475488" cy="329184"/>
+          </a:xfrm>
+          <a:prstGeom prst="roundRect">
+            <a:avLst/>
+          </a:prstGeom>
+          <a:noFill/>
+          <a:ln w="19050">
+            <a:solidFill>
+              <a:srgbClr val="FFFFFF"/>
+            </a:solidFill>
+          </a:ln>
+        </p:spPr>
+        <p:txBody>
+          <a:bodyPr/>
+          <a:lstStyle/>
+          <a:p>
+            <a:endParaRPr lang="es-ES"/>
+          </a:p>
+        </p:txBody>
+      </p:sp>
+      <p:sp>
+        <p:nvSpPr>
+          <p:cNvPr id="20" name="cab"/>
+          <p:cNvSpPr/>
+          <p:nvPr/>
+        </p:nvSpPr>
+        <p:spPr>
+          <a:xfrm>
+            <a:off x="4789170" y="3346704"/>
+            <a:ext cx="274320" cy="182880"/>
+          </a:xfrm>
+          <a:prstGeom prst="round1Rect">
+            <a:avLst/>
+          </a:prstGeom>
+          <a:noFill/>
+          <a:ln w="19050">
+            <a:solidFill>
+              <a:srgbClr val="FFFFFF"/>
+            </a:solidFill>
+          </a:ln>
+        </p:spPr>
+        <p:txBody>
+          <a:bodyPr/>
+          <a:lstStyle/>
+          <a:p>
+            <a:endParaRPr lang="es-ES"/>
+          </a:p>
+        </p:txBody>
+      </p:sp>
+      <p:sp>
+        <p:nvSpPr>
+          <p:cNvPr id="21" name="wheel"/>
+          <p:cNvSpPr/>
+          <p:nvPr/>
+        </p:nvSpPr>
+        <p:spPr>
+          <a:xfrm>
+            <a:off x="4459986" y="3529584"/>
+            <a:ext cx="155448" cy="155448"/>
+          </a:xfrm>
+          <a:prstGeom prst="ellipse">
+            <a:avLst/>
+          </a:prstGeom>
+          <a:noFill/>
+          <a:ln w="19050">
+            <a:solidFill>
+              <a:srgbClr val="FFFFFF"/>
+            </a:solidFill>
+          </a:ln>
+        </p:spPr>
+        <p:txBody>
+          <a:bodyPr/>
+          <a:lstStyle/>
+          <a:p>
+            <a:endParaRPr lang="es-ES"/>
+          </a:p>
+        </p:txBody>
+      </p:sp>
+      <p:sp>
+        <p:nvSpPr>
+          <p:cNvPr id="22" name="wheel"/>
+          <p:cNvSpPr/>
+          <p:nvPr/>
+        </p:nvSpPr>
+        <p:spPr>
+          <a:xfrm>
+            <a:off x="4862322" y="3529584"/>
+            <a:ext cx="155448" cy="155448"/>
+          </a:xfrm>
+          <a:prstGeom prst="ellipse">
+            <a:avLst/>
+          </a:prstGeom>
+          <a:noFill/>
+          <a:ln w="19050">
+            <a:solidFill>
+              <a:srgbClr val="FFFFFF"/>
+            </a:solidFill>
+          </a:ln>
+        </p:spPr>
+        <p:txBody>
+          <a:bodyPr/>
+          <a:lstStyle/>
+          <a:p>
+            <a:endParaRPr lang="es-ES"/>
+          </a:p>
+        </p:txBody>
+      </p:sp>
+      <p:sp>
+        <p:nvSpPr>
+          <p:cNvPr id="23" name="tb"/>
           <p:cNvSpPr txBox="1"/>
           <p:nvPr/>
         </p:nvSpPr>
         <p:spPr>
           <a:xfrm>
-            <a:off x="6510528" y="1856232"/>
-            <a:ext cx="4956048" cy="502920"/>
+            <a:off x="3474720" y="4114800"/>
+            <a:ext cx="2446020" cy="640080"/>
           </a:xfrm>
           <a:prstGeom prst="rect">
             <a:avLst/>
@@ -1320,11 +1581,14 @@
           </a:bodyPr>
           <a:lstStyle/>
           <a:p>
-            <a:pPr marL="0" indent="0" lvl="0" algn="l">
-              <a:buNone/>
-            </a:pPr>
-            <a:r>
-              <a:rPr lang="es-ES" sz="1750" b="1" i="0" dirty="0">
+            <a:pPr marL="0" indent="0" lvl="0" algn="ctr">
+              <a:lnSpc>
+                <a:spcPct val="96000"/>
+              </a:lnSpc>
+              <a:buNone/>
+            </a:pPr>
+            <a:r>
+              <a:rPr lang="es-ES" sz="1500" b="1" i="0" dirty="0">
                 <a:solidFill>
                   <a:srgbClr val="E8711E"/>
                 </a:solidFill>
@@ -1338,14 +1602,43 @@
       </p:sp>
       <p:sp>
         <p:nvSpPr>
-          <p:cNvPr id="16" name="tb"/>
+          <p:cNvPr id="24" name="uline"/>
+          <p:cNvSpPr/>
+          <p:nvPr/>
+        </p:nvSpPr>
+        <p:spPr>
+          <a:xfrm>
+            <a:off x="4377690" y="4727448"/>
+            <a:ext cx="640080" cy="36576"/>
+          </a:xfrm>
+          <a:prstGeom prst="rect">
+            <a:avLst/>
+          </a:prstGeom>
+          <a:solidFill>
+            <a:srgbClr val="E8711E"/>
+          </a:solidFill>
+          <a:ln>
+            <a:noFill/>
+          </a:ln>
+        </p:spPr>
+        <p:txBody>
+          <a:bodyPr/>
+          <a:lstStyle/>
+          <a:p>
+            <a:endParaRPr lang="es-ES"/>
+          </a:p>
+        </p:txBody>
+      </p:sp>
+      <p:sp>
+        <p:nvSpPr>
+          <p:cNvPr id="25" name="tb"/>
           <p:cNvSpPr txBox="1"/>
           <p:nvPr/>
         </p:nvSpPr>
         <p:spPr>
           <a:xfrm>
-            <a:off x="6492240" y="2404872"/>
-            <a:ext cx="4910328" cy="1389888"/>
+            <a:off x="3584448" y="4910328"/>
+            <a:ext cx="2263140" cy="1143000"/>
           </a:xfrm>
           <a:prstGeom prst="rect">
             <a:avLst/>
@@ -1360,7 +1653,7 @@
           <a:p>
             <a:pPr marL="228600" indent="-228600" lvl="0" algn="l">
               <a:lnSpc>
-                <a:spcPct val="100000"/>
+                <a:spcPct val="104000"/>
               </a:lnSpc>
               <a:spcAft>
                 <a:spcPts val="260"/>
@@ -1372,7 +1665,7 @@
               <a:buChar char="•"/>
             </a:pPr>
             <a:r>
-              <a:rPr lang="es-ES" sz="1300" b="0" i="0" dirty="0">
+              <a:rPr lang="es-ES" sz="1200" b="0" i="0" dirty="0">
                 <a:solidFill>
                   <a:srgbClr val="333333"/>
                 </a:solidFill>
@@ -1385,7 +1678,7 @@
           <a:p>
             <a:pPr marL="228600" indent="-228600" lvl="0" algn="l">
               <a:lnSpc>
-                <a:spcPct val="100000"/>
+                <a:spcPct val="104000"/>
               </a:lnSpc>
               <a:spcAft>
                 <a:spcPts val="260"/>
@@ -1397,20 +1690,578 @@
               <a:buChar char="•"/>
             </a:pPr>
             <a:r>
-              <a:rPr lang="es-ES" sz="1300" b="0" i="0" dirty="0">
+              <a:rPr lang="es-ES" sz="1200" b="0" i="0" dirty="0">
                 <a:solidFill>
                   <a:srgbClr val="333333"/>
                 </a:solidFill>
                 <a:latin typeface="Calibri"/>
                 <a:cs typeface="Calibri"/>
               </a:rPr>
-              <a:t>Reprocesos logisticos.</a:t>
-            </a:r>
-          </a:p>
+              <a:t>Reprocesos y carga retornada al CD.</a:t>
+            </a:r>
+          </a:p>
+        </p:txBody>
+      </p:sp>
+      <p:sp>
+        <p:nvSpPr>
+          <p:cNvPr id="26" name="card"/>
+          <p:cNvSpPr/>
+          <p:nvPr/>
+        </p:nvSpPr>
+        <p:spPr>
+          <a:xfrm>
+            <a:off x="6199632" y="2514600"/>
+            <a:ext cx="2628900" cy="3657600"/>
+          </a:xfrm>
+          <a:prstGeom prst="roundRect">
+            <a:avLst/>
+          </a:prstGeom>
+          <a:solidFill>
+            <a:srgbClr val="FFFFFF"/>
+          </a:solidFill>
+          <a:ln w="9525">
+            <a:solidFill>
+              <a:srgbClr val="DCDCDC"/>
+            </a:solidFill>
+          </a:ln>
+          <a:effectLst>
+            <a:outerShdw blurRad="50000" dist="25000" dir="5400000" rotWithShape="0">
+              <a:srgbClr val="000000">
+                <a:alpha val="20000"/>
+              </a:srgbClr>
+            </a:outerShdw>
+          </a:effectLst>
+        </p:spPr>
+        <p:txBody>
+          <a:bodyPr/>
+          <a:lstStyle/>
+          <a:p>
+            <a:endParaRPr lang="es-ES"/>
+          </a:p>
+        </p:txBody>
+      </p:sp>
+      <p:sp>
+        <p:nvSpPr>
+          <p:cNvPr id="27" name="badge"/>
+          <p:cNvSpPr/>
+          <p:nvPr/>
+        </p:nvSpPr>
+        <p:spPr>
+          <a:xfrm>
+            <a:off x="6919722" y="2788920"/>
+            <a:ext cx="1188720" cy="1188720"/>
+          </a:xfrm>
+          <a:prstGeom prst="ellipse">
+            <a:avLst/>
+          </a:prstGeom>
+          <a:solidFill>
+            <a:srgbClr val="123A5E"/>
+          </a:solidFill>
+          <a:ln>
+            <a:noFill/>
+          </a:ln>
+          <a:effectLst>
+            <a:outerShdw blurRad="50000" dist="25000" dir="5400000" rotWithShape="0">
+              <a:srgbClr val="000000">
+                <a:alpha val="20000"/>
+              </a:srgbClr>
+            </a:outerShdw>
+          </a:effectLst>
+        </p:spPr>
+        <p:txBody>
+          <a:bodyPr/>
+          <a:lstStyle/>
+          <a:p>
+            <a:endParaRPr lang="es-ES"/>
+          </a:p>
+        </p:txBody>
+      </p:sp>
+      <p:sp>
+        <p:nvSpPr>
+          <p:cNvPr id="28" name="head"/>
+          <p:cNvSpPr/>
+          <p:nvPr/>
+        </p:nvSpPr>
+        <p:spPr>
+          <a:xfrm>
+            <a:off x="7367778" y="3054096"/>
+            <a:ext cx="274320" cy="274320"/>
+          </a:xfrm>
+          <a:prstGeom prst="ellipse">
+            <a:avLst/>
+          </a:prstGeom>
+          <a:noFill/>
+          <a:ln w="19050">
+            <a:solidFill>
+              <a:srgbClr val="FFFFFF"/>
+            </a:solidFill>
+          </a:ln>
+        </p:spPr>
+        <p:txBody>
+          <a:bodyPr/>
+          <a:lstStyle/>
+          <a:p>
+            <a:endParaRPr lang="es-ES"/>
+          </a:p>
+        </p:txBody>
+      </p:sp>
+      <p:sp>
+        <p:nvSpPr>
+          <p:cNvPr id="29" name="body"/>
+          <p:cNvSpPr/>
+          <p:nvPr/>
+        </p:nvSpPr>
+        <p:spPr>
+          <a:xfrm>
+            <a:off x="7239762" y="3383280"/>
+            <a:ext cx="530352" cy="310896"/>
+          </a:xfrm>
+          <a:prstGeom prst="trapezoid">
+            <a:avLst/>
+          </a:prstGeom>
+          <a:noFill/>
+          <a:ln w="19050">
+            <a:solidFill>
+              <a:srgbClr val="FFFFFF"/>
+            </a:solidFill>
+          </a:ln>
+        </p:spPr>
+        <p:txBody>
+          <a:bodyPr/>
+          <a:lstStyle/>
+          <a:p>
+            <a:endParaRPr lang="es-ES"/>
+          </a:p>
+        </p:txBody>
+      </p:sp>
+      <p:sp>
+        <p:nvSpPr>
+          <p:cNvPr id="30" name="heart"/>
+          <p:cNvSpPr/>
+          <p:nvPr/>
+        </p:nvSpPr>
+        <p:spPr>
+          <a:xfrm>
+            <a:off x="7623810" y="2999232"/>
+            <a:ext cx="219456" cy="201168"/>
+          </a:xfrm>
+          <a:prstGeom prst="heart">
+            <a:avLst/>
+          </a:prstGeom>
+          <a:solidFill>
+            <a:srgbClr val="E8711E"/>
+          </a:solidFill>
+          <a:ln>
+            <a:noFill/>
+          </a:ln>
+        </p:spPr>
+        <p:txBody>
+          <a:bodyPr/>
+          <a:lstStyle/>
+          <a:p>
+            <a:endParaRPr lang="es-ES"/>
+          </a:p>
+        </p:txBody>
+      </p:sp>
+      <p:sp>
+        <p:nvSpPr>
+          <p:cNvPr id="31" name="tb"/>
+          <p:cNvSpPr txBox="1"/>
+          <p:nvPr/>
+        </p:nvSpPr>
+        <p:spPr>
+          <a:xfrm>
+            <a:off x="6291072" y="4114800"/>
+            <a:ext cx="2446020" cy="640080"/>
+          </a:xfrm>
+          <a:prstGeom prst="rect">
+            <a:avLst/>
+          </a:prstGeom>
+          <a:noFill/>
+        </p:spPr>
+        <p:txBody>
+          <a:bodyPr wrap="square" anchor="t" lIns="73152" tIns="36576" rIns="73152" bIns="36576">
+            <a:normAutofit/>
+          </a:bodyPr>
+          <a:lstStyle/>
+          <a:p>
+            <a:pPr marL="0" indent="0" lvl="0" algn="ctr">
+              <a:lnSpc>
+                <a:spcPct val="96000"/>
+              </a:lnSpc>
+              <a:buNone/>
+            </a:pPr>
+            <a:r>
+              <a:rPr lang="es-ES" sz="1500" b="1" i="0" dirty="0">
+                <a:solidFill>
+                  <a:srgbClr val="123A5E"/>
+                </a:solidFill>
+                <a:latin typeface="Calibri"/>
+                <a:cs typeface="Calibri"/>
+              </a:rPr>
+              <a:t>Experiencia Cliente</a:t>
+            </a:r>
+          </a:p>
+        </p:txBody>
+      </p:sp>
+      <p:sp>
+        <p:nvSpPr>
+          <p:cNvPr id="32" name="uline"/>
+          <p:cNvSpPr/>
+          <p:nvPr/>
+        </p:nvSpPr>
+        <p:spPr>
+          <a:xfrm>
+            <a:off x="7194042" y="4727448"/>
+            <a:ext cx="640080" cy="36576"/>
+          </a:xfrm>
+          <a:prstGeom prst="rect">
+            <a:avLst/>
+          </a:prstGeom>
+          <a:solidFill>
+            <a:srgbClr val="123A5E"/>
+          </a:solidFill>
+          <a:ln>
+            <a:noFill/>
+          </a:ln>
+        </p:spPr>
+        <p:txBody>
+          <a:bodyPr/>
+          <a:lstStyle/>
+          <a:p>
+            <a:endParaRPr lang="es-ES"/>
+          </a:p>
+        </p:txBody>
+      </p:sp>
+      <p:sp>
+        <p:nvSpPr>
+          <p:cNvPr id="33" name="tb"/>
+          <p:cNvSpPr txBox="1"/>
+          <p:nvPr/>
+        </p:nvSpPr>
+        <p:spPr>
+          <a:xfrm>
+            <a:off x="6400800" y="4910328"/>
+            <a:ext cx="2263140" cy="1143000"/>
+          </a:xfrm>
+          <a:prstGeom prst="rect">
+            <a:avLst/>
+          </a:prstGeom>
+          <a:noFill/>
+        </p:spPr>
+        <p:txBody>
+          <a:bodyPr wrap="square" anchor="t" lIns="73152" tIns="36576" rIns="73152" bIns="36576">
+            <a:normAutofit/>
+          </a:bodyPr>
+          <a:lstStyle/>
           <a:p>
             <a:pPr marL="228600" indent="-228600" lvl="0" algn="l">
               <a:lnSpc>
-                <a:spcPct val="100000"/>
+                <a:spcPct val="104000"/>
+              </a:lnSpc>
+              <a:spcAft>
+                <a:spcPts val="260"/>
+              </a:spcAft>
+              <a:buClr>
+                <a:srgbClr val="123A5E"/>
+              </a:buClr>
+              <a:buFont typeface="Arial"/>
+              <a:buChar char="•"/>
+            </a:pPr>
+            <a:r>
+              <a:rPr lang="es-ES" sz="1200" b="0" i="0" dirty="0">
+                <a:solidFill>
+                  <a:srgbClr val="333333"/>
+                </a:solidFill>
+                <a:latin typeface="Calibri"/>
+                <a:cs typeface="Calibri"/>
+              </a:rPr>
+              <a:t>Retrasos en las entregas.</a:t>
+            </a:r>
+          </a:p>
+          <a:p>
+            <a:pPr marL="228600" indent="-228600" lvl="0" algn="l">
+              <a:lnSpc>
+                <a:spcPct val="104000"/>
+              </a:lnSpc>
+              <a:spcAft>
+                <a:spcPts val="260"/>
+              </a:spcAft>
+              <a:buClr>
+                <a:srgbClr val="123A5E"/>
+              </a:buClr>
+              <a:buFont typeface="Arial"/>
+              <a:buChar char="•"/>
+            </a:pPr>
+            <a:r>
+              <a:rPr lang="es-ES" sz="1200" b="0" i="0" dirty="0">
+                <a:solidFill>
+                  <a:srgbClr val="333333"/>
+                </a:solidFill>
+                <a:latin typeface="Calibri"/>
+                <a:cs typeface="Calibri"/>
+              </a:rPr>
+              <a:t>Falta de entregas same day en la RM.</a:t>
+            </a:r>
+          </a:p>
+        </p:txBody>
+      </p:sp>
+      <p:sp>
+        <p:nvSpPr>
+          <p:cNvPr id="34" name="card"/>
+          <p:cNvSpPr/>
+          <p:nvPr/>
+        </p:nvSpPr>
+        <p:spPr>
+          <a:xfrm>
+            <a:off x="9015984" y="2514600"/>
+            <a:ext cx="2628900" cy="3657600"/>
+          </a:xfrm>
+          <a:prstGeom prst="roundRect">
+            <a:avLst/>
+          </a:prstGeom>
+          <a:solidFill>
+            <a:srgbClr val="FFFFFF"/>
+          </a:solidFill>
+          <a:ln w="9525">
+            <a:solidFill>
+              <a:srgbClr val="DCDCDC"/>
+            </a:solidFill>
+          </a:ln>
+          <a:effectLst>
+            <a:outerShdw blurRad="50000" dist="25000" dir="5400000" rotWithShape="0">
+              <a:srgbClr val="000000">
+                <a:alpha val="20000"/>
+              </a:srgbClr>
+            </a:outerShdw>
+          </a:effectLst>
+        </p:spPr>
+        <p:txBody>
+          <a:bodyPr/>
+          <a:lstStyle/>
+          <a:p>
+            <a:endParaRPr lang="es-ES"/>
+          </a:p>
+        </p:txBody>
+      </p:sp>
+      <p:sp>
+        <p:nvSpPr>
+          <p:cNvPr id="35" name="badge"/>
+          <p:cNvSpPr/>
+          <p:nvPr/>
+        </p:nvSpPr>
+        <p:spPr>
+          <a:xfrm>
+            <a:off x="9736074" y="2788920"/>
+            <a:ext cx="1188720" cy="1188720"/>
+          </a:xfrm>
+          <a:prstGeom prst="ellipse">
+            <a:avLst/>
+          </a:prstGeom>
+          <a:solidFill>
+            <a:srgbClr val="E8711E"/>
+          </a:solidFill>
+          <a:ln>
+            <a:noFill/>
+          </a:ln>
+          <a:effectLst>
+            <a:outerShdw blurRad="50000" dist="25000" dir="5400000" rotWithShape="0">
+              <a:srgbClr val="000000">
+                <a:alpha val="20000"/>
+              </a:srgbClr>
+            </a:outerShdw>
+          </a:effectLst>
+        </p:spPr>
+        <p:txBody>
+          <a:bodyPr/>
+          <a:lstStyle/>
+          <a:p>
+            <a:endParaRPr lang="es-ES"/>
+          </a:p>
+        </p:txBody>
+      </p:sp>
+      <p:sp>
+        <p:nvSpPr>
+          <p:cNvPr id="36" name="awning"/>
+          <p:cNvSpPr/>
+          <p:nvPr/>
+        </p:nvSpPr>
+        <p:spPr>
+          <a:xfrm flipV="1">
+            <a:off x="10001250" y="3072384"/>
+            <a:ext cx="658368" cy="164592"/>
+          </a:xfrm>
+          <a:prstGeom prst="trapezoid">
+            <a:avLst/>
+          </a:prstGeom>
+          <a:noFill/>
+          <a:ln w="19050">
+            <a:solidFill>
+              <a:srgbClr val="FFFFFF"/>
+            </a:solidFill>
+          </a:ln>
+        </p:spPr>
+        <p:txBody>
+          <a:bodyPr/>
+          <a:lstStyle/>
+          <a:p>
+            <a:endParaRPr lang="es-ES"/>
+          </a:p>
+        </p:txBody>
+      </p:sp>
+      <p:sp>
+        <p:nvSpPr>
+          <p:cNvPr id="37" name="store"/>
+          <p:cNvSpPr/>
+          <p:nvPr/>
+        </p:nvSpPr>
+        <p:spPr>
+          <a:xfrm>
+            <a:off x="10074402" y="3236976"/>
+            <a:ext cx="512064" cy="457200"/>
+          </a:xfrm>
+          <a:prstGeom prst="rect">
+            <a:avLst/>
+          </a:prstGeom>
+          <a:noFill/>
+          <a:ln w="19050">
+            <a:solidFill>
+              <a:srgbClr val="FFFFFF"/>
+            </a:solidFill>
+          </a:ln>
+        </p:spPr>
+        <p:txBody>
+          <a:bodyPr/>
+          <a:lstStyle/>
+          <a:p>
+            <a:endParaRPr lang="es-ES"/>
+          </a:p>
+        </p:txBody>
+      </p:sp>
+      <p:sp>
+        <p:nvSpPr>
+          <p:cNvPr id="38" name="door"/>
+          <p:cNvSpPr/>
+          <p:nvPr/>
+        </p:nvSpPr>
+        <p:spPr>
+          <a:xfrm>
+            <a:off x="10248138" y="3429000"/>
+            <a:ext cx="164592" cy="265176"/>
+          </a:xfrm>
+          <a:prstGeom prst="rect">
+            <a:avLst/>
+          </a:prstGeom>
+          <a:noFill/>
+          <a:ln w="19050">
+            <a:solidFill>
+              <a:srgbClr val="FFFFFF"/>
+            </a:solidFill>
+          </a:ln>
+        </p:spPr>
+        <p:txBody>
+          <a:bodyPr/>
+          <a:lstStyle/>
+          <a:p>
+            <a:endParaRPr lang="es-ES"/>
+          </a:p>
+        </p:txBody>
+      </p:sp>
+      <p:sp>
+        <p:nvSpPr>
+          <p:cNvPr id="39" name="tb"/>
+          <p:cNvSpPr txBox="1"/>
+          <p:nvPr/>
+        </p:nvSpPr>
+        <p:spPr>
+          <a:xfrm>
+            <a:off x="9107424" y="4114800"/>
+            <a:ext cx="2446020" cy="640080"/>
+          </a:xfrm>
+          <a:prstGeom prst="rect">
+            <a:avLst/>
+          </a:prstGeom>
+          <a:noFill/>
+        </p:spPr>
+        <p:txBody>
+          <a:bodyPr wrap="square" anchor="t" lIns="73152" tIns="36576" rIns="73152" bIns="36576">
+            <a:normAutofit/>
+          </a:bodyPr>
+          <a:lstStyle/>
+          <a:p>
+            <a:pPr marL="0" indent="0" lvl="0" algn="ctr">
+              <a:lnSpc>
+                <a:spcPct val="96000"/>
+              </a:lnSpc>
+              <a:buNone/>
+            </a:pPr>
+            <a:r>
+              <a:rPr lang="es-ES" sz="1500" b="1" i="0" dirty="0">
+                <a:solidFill>
+                  <a:srgbClr val="E8711E"/>
+                </a:solidFill>
+                <a:latin typeface="Calibri"/>
+                <a:cs typeface="Calibri"/>
+              </a:rPr>
+              <a:t>Retail</a:t>
+            </a:r>
+          </a:p>
+        </p:txBody>
+      </p:sp>
+      <p:sp>
+        <p:nvSpPr>
+          <p:cNvPr id="40" name="uline"/>
+          <p:cNvSpPr/>
+          <p:nvPr/>
+        </p:nvSpPr>
+        <p:spPr>
+          <a:xfrm>
+            <a:off x="10010394" y="4727448"/>
+            <a:ext cx="640080" cy="36576"/>
+          </a:xfrm>
+          <a:prstGeom prst="rect">
+            <a:avLst/>
+          </a:prstGeom>
+          <a:solidFill>
+            <a:srgbClr val="E8711E"/>
+          </a:solidFill>
+          <a:ln>
+            <a:noFill/>
+          </a:ln>
+        </p:spPr>
+        <p:txBody>
+          <a:bodyPr/>
+          <a:lstStyle/>
+          <a:p>
+            <a:endParaRPr lang="es-ES"/>
+          </a:p>
+        </p:txBody>
+      </p:sp>
+      <p:sp>
+        <p:nvSpPr>
+          <p:cNvPr id="41" name="tb"/>
+          <p:cNvSpPr txBox="1"/>
+          <p:nvPr/>
+        </p:nvSpPr>
+        <p:spPr>
+          <a:xfrm>
+            <a:off x="9217152" y="4910328"/>
+            <a:ext cx="2263140" cy="1143000"/>
+          </a:xfrm>
+          <a:prstGeom prst="rect">
+            <a:avLst/>
+          </a:prstGeom>
+          <a:noFill/>
+        </p:spPr>
+        <p:txBody>
+          <a:bodyPr wrap="square" anchor="t" lIns="73152" tIns="36576" rIns="73152" bIns="36576">
+            <a:normAutofit/>
+          </a:bodyPr>
+          <a:lstStyle/>
+          <a:p>
+            <a:pPr marL="228600" indent="-228600" lvl="0" algn="l">
+              <a:lnSpc>
+                <a:spcPct val="104000"/>
               </a:lnSpc>
               <a:spcAft>
                 <a:spcPts val="260"/>
@@ -1422,408 +2273,39 @@
               <a:buChar char="•"/>
             </a:pPr>
             <a:r>
-              <a:rPr lang="es-ES" sz="1300" b="0" i="0" dirty="0">
+              <a:rPr lang="es-ES" sz="1200" b="0" i="0" dirty="0">
                 <a:solidFill>
                   <a:srgbClr val="333333"/>
                 </a:solidFill>
                 <a:latin typeface="Calibri"/>
                 <a:cs typeface="Calibri"/>
               </a:rPr>
-              <a:t>Carga retornada al CD.</a:t>
-            </a:r>
-          </a:p>
-        </p:txBody>
-      </p:sp>
-      <p:sp>
-        <p:nvSpPr>
-          <p:cNvPr id="17" name="card"/>
-          <p:cNvSpPr/>
-          <p:nvPr/>
-        </p:nvSpPr>
-        <p:spPr>
-          <a:xfrm>
-            <a:off x="566928" y="4123944"/>
-            <a:ext cx="5413248" cy="2212848"/>
-          </a:xfrm>
-          <a:prstGeom prst="roundRect">
-            <a:avLst/>
-          </a:prstGeom>
-          <a:solidFill>
-            <a:srgbClr val="FFFFFF"/>
-          </a:solidFill>
-          <a:ln w="9525">
-            <a:solidFill>
-              <a:srgbClr val="DCDCDC"/>
-            </a:solidFill>
-          </a:ln>
-          <a:effectLst>
-            <a:outerShdw blurRad="50000" dist="25000" dir="5400000" rotWithShape="0">
-              <a:srgbClr val="000000">
-                <a:alpha val="20000"/>
-              </a:srgbClr>
-            </a:outerShdw>
-          </a:effectLst>
-        </p:spPr>
-        <p:txBody>
-          <a:bodyPr/>
-          <a:lstStyle/>
-          <a:p>
-            <a:endParaRPr lang="es-ES"/>
-          </a:p>
-        </p:txBody>
-      </p:sp>
-      <p:sp>
-        <p:nvSpPr>
-          <p:cNvPr id="18" name="tab"/>
-          <p:cNvSpPr/>
-          <p:nvPr/>
-        </p:nvSpPr>
-        <p:spPr>
-          <a:xfrm>
-            <a:off x="566928" y="4123944"/>
-            <a:ext cx="109728" cy="2212848"/>
-          </a:xfrm>
-          <a:prstGeom prst="rect">
-            <a:avLst/>
-          </a:prstGeom>
-          <a:solidFill>
-            <a:srgbClr val="1C5A8C"/>
-          </a:solidFill>
-          <a:ln>
-            <a:noFill/>
-          </a:ln>
-        </p:spPr>
-        <p:txBody>
-          <a:bodyPr/>
-          <a:lstStyle/>
-          <a:p>
-            <a:endParaRPr lang="es-ES"/>
-          </a:p>
-        </p:txBody>
-      </p:sp>
-      <p:sp>
-        <p:nvSpPr>
-          <p:cNvPr id="19" name="tb"/>
-          <p:cNvSpPr txBox="1"/>
-          <p:nvPr/>
-        </p:nvSpPr>
-        <p:spPr>
-          <a:xfrm>
-            <a:off x="859536" y="4288536"/>
-            <a:ext cx="4956048" cy="502920"/>
-          </a:xfrm>
-          <a:prstGeom prst="rect">
-            <a:avLst/>
-          </a:prstGeom>
-          <a:noFill/>
-        </p:spPr>
-        <p:txBody>
-          <a:bodyPr wrap="square" anchor="t" lIns="73152" tIns="36576" rIns="73152" bIns="36576">
-            <a:normAutofit/>
-          </a:bodyPr>
-          <a:lstStyle/>
-          <a:p>
-            <a:pPr marL="0" indent="0" lvl="0" algn="l">
-              <a:buNone/>
-            </a:pPr>
-            <a:r>
-              <a:rPr lang="es-ES" sz="1750" b="1" i="0" dirty="0">
-                <a:solidFill>
-                  <a:srgbClr val="1C5A8C"/>
-                </a:solidFill>
-                <a:latin typeface="Calibri"/>
-                <a:cs typeface="Calibri"/>
-              </a:rPr>
-              <a:t>Experiencia Cliente</a:t>
-            </a:r>
-          </a:p>
-        </p:txBody>
-      </p:sp>
-      <p:sp>
-        <p:nvSpPr>
-          <p:cNvPr id="20" name="tb"/>
-          <p:cNvSpPr txBox="1"/>
-          <p:nvPr/>
-        </p:nvSpPr>
-        <p:spPr>
-          <a:xfrm>
-            <a:off x="841248" y="4837176"/>
-            <a:ext cx="4910328" cy="1389888"/>
-          </a:xfrm>
-          <a:prstGeom prst="rect">
-            <a:avLst/>
-          </a:prstGeom>
-          <a:noFill/>
-        </p:spPr>
-        <p:txBody>
-          <a:bodyPr wrap="square" anchor="t" lIns="73152" tIns="36576" rIns="73152" bIns="36576">
-            <a:normAutofit/>
-          </a:bodyPr>
-          <a:lstStyle/>
+              <a:t>Venta limitada al stock de cada tienda.</a:t>
+            </a:r>
+          </a:p>
           <a:p>
             <a:pPr marL="228600" indent="-228600" lvl="0" algn="l">
               <a:lnSpc>
-                <a:spcPct val="100000"/>
+                <a:spcPct val="104000"/>
               </a:lnSpc>
               <a:spcAft>
                 <a:spcPts val="260"/>
               </a:spcAft>
               <a:buClr>
-                <a:srgbClr val="1C5A8C"/>
+                <a:srgbClr val="E8711E"/>
               </a:buClr>
               <a:buFont typeface="Arial"/>
               <a:buChar char="•"/>
             </a:pPr>
             <a:r>
-              <a:rPr lang="es-ES" sz="1300" b="0" i="0" dirty="0">
+              <a:rPr lang="es-ES" sz="1200" b="0" i="0" dirty="0">
                 <a:solidFill>
                   <a:srgbClr val="333333"/>
                 </a:solidFill>
                 <a:latin typeface="Calibri"/>
                 <a:cs typeface="Calibri"/>
               </a:rPr>
-              <a:t>Retrasos en entregas.</a:t>
-            </a:r>
-          </a:p>
-          <a:p>
-            <a:pPr marL="228600" indent="-228600" lvl="0" algn="l">
-              <a:lnSpc>
-                <a:spcPct val="100000"/>
-              </a:lnSpc>
-              <a:spcAft>
-                <a:spcPts val="260"/>
-              </a:spcAft>
-              <a:buClr>
-                <a:srgbClr val="1C5A8C"/>
-              </a:buClr>
-              <a:buFont typeface="Arial"/>
-              <a:buChar char="•"/>
-            </a:pPr>
-            <a:r>
-              <a:rPr lang="es-ES" sz="1300" b="0" i="0" dirty="0">
-                <a:solidFill>
-                  <a:srgbClr val="333333"/>
-                </a:solidFill>
-                <a:latin typeface="Calibri"/>
-                <a:cs typeface="Calibri"/>
-              </a:rPr>
-              <a:t>Necesidad de aumentar entregas same day en RM.</a:t>
-            </a:r>
-          </a:p>
-        </p:txBody>
-      </p:sp>
-      <p:sp>
-        <p:nvSpPr>
-          <p:cNvPr id="21" name="card"/>
-          <p:cNvSpPr/>
-          <p:nvPr/>
-        </p:nvSpPr>
-        <p:spPr>
-          <a:xfrm>
-            <a:off x="6217920" y="4123944"/>
-            <a:ext cx="5413248" cy="2212848"/>
-          </a:xfrm>
-          <a:prstGeom prst="roundRect">
-            <a:avLst/>
-          </a:prstGeom>
-          <a:solidFill>
-            <a:srgbClr val="FFFFFF"/>
-          </a:solidFill>
-          <a:ln w="9525">
-            <a:solidFill>
-              <a:srgbClr val="DCDCDC"/>
-            </a:solidFill>
-          </a:ln>
-          <a:effectLst>
-            <a:outerShdw blurRad="50000" dist="25000" dir="5400000" rotWithShape="0">
-              <a:srgbClr val="000000">
-                <a:alpha val="20000"/>
-              </a:srgbClr>
-            </a:outerShdw>
-          </a:effectLst>
-        </p:spPr>
-        <p:txBody>
-          <a:bodyPr/>
-          <a:lstStyle/>
-          <a:p>
-            <a:endParaRPr lang="es-ES"/>
-          </a:p>
-        </p:txBody>
-      </p:sp>
-      <p:sp>
-        <p:nvSpPr>
-          <p:cNvPr id="22" name="tab"/>
-          <p:cNvSpPr/>
-          <p:nvPr/>
-        </p:nvSpPr>
-        <p:spPr>
-          <a:xfrm>
-            <a:off x="6217920" y="4123944"/>
-            <a:ext cx="109728" cy="2212848"/>
-          </a:xfrm>
-          <a:prstGeom prst="rect">
-            <a:avLst/>
-          </a:prstGeom>
-          <a:solidFill>
-            <a:srgbClr val="123A5E"/>
-          </a:solidFill>
-          <a:ln>
-            <a:noFill/>
-          </a:ln>
-        </p:spPr>
-        <p:txBody>
-          <a:bodyPr/>
-          <a:lstStyle/>
-          <a:p>
-            <a:endParaRPr lang="es-ES"/>
-          </a:p>
-        </p:txBody>
-      </p:sp>
-      <p:sp>
-        <p:nvSpPr>
-          <p:cNvPr id="23" name="tb"/>
-          <p:cNvSpPr txBox="1"/>
-          <p:nvPr/>
-        </p:nvSpPr>
-        <p:spPr>
-          <a:xfrm>
-            <a:off x="6510528" y="4288536"/>
-            <a:ext cx="4956048" cy="502920"/>
-          </a:xfrm>
-          <a:prstGeom prst="rect">
-            <a:avLst/>
-          </a:prstGeom>
-          <a:noFill/>
-        </p:spPr>
-        <p:txBody>
-          <a:bodyPr wrap="square" anchor="t" lIns="73152" tIns="36576" rIns="73152" bIns="36576">
-            <a:normAutofit/>
-          </a:bodyPr>
-          <a:lstStyle/>
-          <a:p>
-            <a:pPr marL="0" indent="0" lvl="0" algn="l">
-              <a:buNone/>
-            </a:pPr>
-            <a:r>
-              <a:rPr lang="es-ES" sz="1750" b="1" i="0" dirty="0">
-                <a:solidFill>
-                  <a:srgbClr val="123A5E"/>
-                </a:solidFill>
-                <a:latin typeface="Calibri"/>
-                <a:cs typeface="Calibri"/>
-              </a:rPr>
-              <a:t>Retail</a:t>
-            </a:r>
-          </a:p>
-        </p:txBody>
-      </p:sp>
-      <p:sp>
-        <p:nvSpPr>
-          <p:cNvPr id="24" name="tb"/>
-          <p:cNvSpPr txBox="1"/>
-          <p:nvPr/>
-        </p:nvSpPr>
-        <p:spPr>
-          <a:xfrm>
-            <a:off x="6492240" y="4837176"/>
-            <a:ext cx="4910328" cy="1389888"/>
-          </a:xfrm>
-          <a:prstGeom prst="rect">
-            <a:avLst/>
-          </a:prstGeom>
-          <a:noFill/>
-        </p:spPr>
-        <p:txBody>
-          <a:bodyPr wrap="square" anchor="t" lIns="73152" tIns="36576" rIns="73152" bIns="36576">
-            <a:normAutofit/>
-          </a:bodyPr>
-          <a:lstStyle/>
-          <a:p>
-            <a:pPr marL="228600" indent="-228600" lvl="0" algn="l">
-              <a:lnSpc>
-                <a:spcPct val="100000"/>
-              </a:lnSpc>
-              <a:spcAft>
-                <a:spcPts val="260"/>
-              </a:spcAft>
-              <a:buClr>
-                <a:srgbClr val="123A5E"/>
-              </a:buClr>
-              <a:buFont typeface="Arial"/>
-              <a:buChar char="•"/>
-            </a:pPr>
-            <a:r>
-              <a:rPr lang="es-ES" sz="1300" b="0" i="0" dirty="0">
-                <a:solidFill>
-                  <a:srgbClr val="333333"/>
-                </a:solidFill>
-                <a:latin typeface="Calibri"/>
-                <a:cs typeface="Calibri"/>
-              </a:rPr>
-              <a:t>Venta limitada al stock disponible en cada tienda.</a:t>
-            </a:r>
-          </a:p>
-          <a:p>
-            <a:pPr marL="228600" indent="-228600" lvl="0" algn="l">
-              <a:lnSpc>
-                <a:spcPct val="100000"/>
-              </a:lnSpc>
-              <a:spcAft>
-                <a:spcPts val="260"/>
-              </a:spcAft>
-              <a:buClr>
-                <a:srgbClr val="123A5E"/>
-              </a:buClr>
-              <a:buFont typeface="Arial"/>
-              <a:buChar char="•"/>
-            </a:pPr>
-            <a:r>
-              <a:rPr lang="es-ES" sz="1300" b="0" i="0" dirty="0">
-                <a:solidFill>
-                  <a:srgbClr val="333333"/>
-                </a:solidFill>
-                <a:latin typeface="Calibri"/>
-                <a:cs typeface="Calibri"/>
-              </a:rPr>
-              <a:t>Falta de visibilidad del inventario de toda la red.</a:t>
-            </a:r>
-          </a:p>
-        </p:txBody>
-      </p:sp>
-      <p:sp>
-        <p:nvSpPr>
-          <p:cNvPr id="25" name="tb"/>
-          <p:cNvSpPr txBox="1"/>
-          <p:nvPr/>
-        </p:nvSpPr>
-        <p:spPr>
-          <a:xfrm>
-            <a:off x="548640" y="6400800"/>
-            <a:ext cx="10058400" cy="365760"/>
-          </a:xfrm>
-          <a:prstGeom prst="rect">
-            <a:avLst/>
-          </a:prstGeom>
-          <a:noFill/>
-        </p:spPr>
-        <p:txBody>
-          <a:bodyPr wrap="square" anchor="t" lIns="73152" tIns="36576" rIns="73152" bIns="36576">
-            <a:normAutofit/>
-          </a:bodyPr>
-          <a:lstStyle/>
-          <a:p>
-            <a:pPr marL="0" indent="0" lvl="0" algn="l">
-              <a:buNone/>
-            </a:pPr>
-            <a:r>
-              <a:rPr lang="es-ES" sz="900" b="0" i="0" dirty="0">
-                <a:solidFill>
-                  <a:srgbClr val="6B6B6B"/>
-                </a:solidFill>
-                <a:latin typeface="Calibri"/>
-                <a:cs typeface="Calibri"/>
-              </a:rPr>
-              <a:t>CAV  |  Programa de Transformacion Omnicanal y Ultima Milla</a:t>
+              <a:t>Sin visibilidad del inventario de la red.</a:t>
             </a:r>
           </a:p>
         </p:txBody>

</xml_diff>

<commit_message>
Lamina 2: tarjetas mas dinamicas con insignias naranjas, halo y marcos de color
</commit_message>
<xml_diff>
--- a/Transformacion_Omnicanal_Ultima_Milla.pptx
+++ b/Transformacion_Omnicanal_Ultima_Milla.pptx
@@ -1131,8 +1131,8 @@
         </p:nvSpPr>
         <p:spPr>
           <a:xfrm>
-            <a:off x="566928" y="2514600"/>
-            <a:ext cx="2628900" cy="3657600"/>
+            <a:off x="566928" y="2468880"/>
+            <a:ext cx="2628900" cy="3703320"/>
           </a:xfrm>
           <a:prstGeom prst="roundRect">
             <a:avLst/>
@@ -1163,7 +1163,94 @@
       </p:sp>
       <p:sp>
         <p:nvSpPr>
-          <p:cNvPr id="12" name="badge"/>
+          <p:cNvPr id="12" name="top"/>
+          <p:cNvSpPr/>
+          <p:nvPr/>
+        </p:nvSpPr>
+        <p:spPr>
+          <a:xfrm>
+            <a:off x="566928" y="2468880"/>
+            <a:ext cx="2628900" cy="146304"/>
+          </a:xfrm>
+          <a:prstGeom prst="round2SameRect">
+            <a:avLst/>
+          </a:prstGeom>
+          <a:solidFill>
+            <a:srgbClr val="123A5E"/>
+          </a:solidFill>
+          <a:ln>
+            <a:noFill/>
+          </a:ln>
+        </p:spPr>
+        <p:txBody>
+          <a:bodyPr/>
+          <a:lstStyle/>
+          <a:p>
+            <a:endParaRPr lang="es-ES"/>
+          </a:p>
+        </p:txBody>
+      </p:sp>
+      <p:sp>
+        <p:nvSpPr>
+          <p:cNvPr id="13" name="bot"/>
+          <p:cNvSpPr/>
+          <p:nvPr/>
+        </p:nvSpPr>
+        <p:spPr>
+          <a:xfrm flipV="1">
+            <a:off x="566928" y="6025896"/>
+            <a:ext cx="2628900" cy="146304"/>
+          </a:xfrm>
+          <a:prstGeom prst="round2SameRect">
+            <a:avLst/>
+          </a:prstGeom>
+          <a:solidFill>
+            <a:srgbClr val="E8711E"/>
+          </a:solidFill>
+          <a:ln>
+            <a:noFill/>
+          </a:ln>
+        </p:spPr>
+        <p:txBody>
+          <a:bodyPr/>
+          <a:lstStyle/>
+          <a:p>
+            <a:endParaRPr lang="es-ES"/>
+          </a:p>
+        </p:txBody>
+      </p:sp>
+      <p:sp>
+        <p:nvSpPr>
+          <p:cNvPr id="14" name="halo"/>
+          <p:cNvSpPr/>
+          <p:nvPr/>
+        </p:nvSpPr>
+        <p:spPr>
+          <a:xfrm>
+            <a:off x="1149858" y="2651760"/>
+            <a:ext cx="1463040" cy="1463040"/>
+          </a:xfrm>
+          <a:prstGeom prst="ellipse">
+            <a:avLst/>
+          </a:prstGeom>
+          <a:solidFill>
+            <a:srgbClr val="FBE2CB"/>
+          </a:solidFill>
+          <a:ln>
+            <a:noFill/>
+          </a:ln>
+        </p:spPr>
+        <p:txBody>
+          <a:bodyPr/>
+          <a:lstStyle/>
+          <a:p>
+            <a:endParaRPr lang="es-ES"/>
+          </a:p>
+        </p:txBody>
+      </p:sp>
+      <p:sp>
+        <p:nvSpPr>
+          <p:cNvPr id="15" name="badge"/>
           <p:cNvSpPr/>
           <p:nvPr/>
         </p:nvSpPr>
@@ -1176,7 +1263,7 @@
             <a:avLst/>
           </a:prstGeom>
           <a:solidFill>
-            <a:srgbClr val="123A5E"/>
+            <a:srgbClr val="E8711E"/>
           </a:solidFill>
           <a:ln>
             <a:noFill/>
@@ -1199,7 +1286,7 @@
       </p:sp>
       <p:sp>
         <p:nvSpPr>
-          <p:cNvPr id="13" name="db"/>
+          <p:cNvPr id="16" name="db"/>
           <p:cNvSpPr/>
           <p:nvPr/>
         </p:nvSpPr>
@@ -1228,13 +1315,13 @@
       </p:sp>
       <p:sp>
         <p:nvSpPr>
-          <p:cNvPr id="14" name="tb"/>
+          <p:cNvPr id="17" name="tb"/>
           <p:cNvSpPr txBox="1"/>
           <p:nvPr/>
         </p:nvSpPr>
         <p:spPr>
           <a:xfrm>
-            <a:off x="658368" y="4114800"/>
+            <a:off x="658368" y="4096512"/>
             <a:ext cx="2446020" cy="640080"/>
           </a:xfrm>
           <a:prstGeom prst="rect">
@@ -1269,376 +1356,43 @@
       </p:sp>
       <p:sp>
         <p:nvSpPr>
-          <p:cNvPr id="15" name="uline"/>
-          <p:cNvSpPr/>
-          <p:nvPr/>
-        </p:nvSpPr>
-        <p:spPr>
-          <a:xfrm>
-            <a:off x="1561338" y="4727448"/>
-            <a:ext cx="640080" cy="36576"/>
-          </a:xfrm>
-          <a:prstGeom prst="rect">
-            <a:avLst/>
-          </a:prstGeom>
-          <a:solidFill>
-            <a:srgbClr val="123A5E"/>
-          </a:solidFill>
-          <a:ln>
-            <a:noFill/>
-          </a:ln>
-        </p:spPr>
-        <p:txBody>
-          <a:bodyPr/>
-          <a:lstStyle/>
-          <a:p>
-            <a:endParaRPr lang="es-ES"/>
-          </a:p>
-        </p:txBody>
-      </p:sp>
-      <p:sp>
-        <p:nvSpPr>
-          <p:cNvPr id="16" name="tb"/>
+          <p:cNvPr id="18" name="uline"/>
+          <p:cNvSpPr/>
+          <p:nvPr/>
+        </p:nvSpPr>
+        <p:spPr>
+          <a:xfrm>
+            <a:off x="1588770" y="4681728"/>
+            <a:ext cx="585216" cy="54864"/>
+          </a:xfrm>
+          <a:prstGeom prst="roundRect">
+            <a:avLst/>
+          </a:prstGeom>
+          <a:solidFill>
+            <a:srgbClr val="E8711E"/>
+          </a:solidFill>
+          <a:ln>
+            <a:noFill/>
+          </a:ln>
+        </p:spPr>
+        <p:txBody>
+          <a:bodyPr/>
+          <a:lstStyle/>
+          <a:p>
+            <a:endParaRPr lang="es-ES"/>
+          </a:p>
+        </p:txBody>
+      </p:sp>
+      <p:sp>
+        <p:nvSpPr>
+          <p:cNvPr id="19" name="tb"/>
           <p:cNvSpPr txBox="1"/>
           <p:nvPr/>
         </p:nvSpPr>
         <p:spPr>
           <a:xfrm>
-            <a:off x="768096" y="4910328"/>
-            <a:ext cx="2263140" cy="1143000"/>
-          </a:xfrm>
-          <a:prstGeom prst="rect">
-            <a:avLst/>
-          </a:prstGeom>
-          <a:noFill/>
-        </p:spPr>
-        <p:txBody>
-          <a:bodyPr wrap="square" anchor="t" lIns="73152" tIns="36576" rIns="73152" bIns="36576">
-            <a:normAutofit/>
-          </a:bodyPr>
-          <a:lstStyle/>
-          <a:p>
-            <a:pPr marL="228600" indent="-228600" lvl="0" algn="l">
-              <a:lnSpc>
-                <a:spcPct val="104000"/>
-              </a:lnSpc>
-              <a:spcAft>
-                <a:spcPts val="260"/>
-              </a:spcAft>
-              <a:buClr>
-                <a:srgbClr val="123A5E"/>
-              </a:buClr>
-              <a:buFont typeface="Arial"/>
-              <a:buChar char="•"/>
-            </a:pPr>
-            <a:r>
-              <a:rPr lang="es-ES" sz="1200" b="0" i="0" dirty="0">
-                <a:solidFill>
-                  <a:srgbClr val="333333"/>
-                </a:solidFill>
-                <a:latin typeface="Calibri"/>
-                <a:cs typeface="Calibri"/>
-              </a:rPr>
-              <a:t>Mas de 35.000 clientes con direcciones de calidad dispar.</a:t>
-            </a:r>
-          </a:p>
-          <a:p>
-            <a:pPr marL="228600" indent="-228600" lvl="0" algn="l">
-              <a:lnSpc>
-                <a:spcPct val="104000"/>
-              </a:lnSpc>
-              <a:spcAft>
-                <a:spcPts val="260"/>
-              </a:spcAft>
-              <a:buClr>
-                <a:srgbClr val="123A5E"/>
-              </a:buClr>
-              <a:buFont typeface="Arial"/>
-              <a:buChar char="•"/>
-            </a:pPr>
-            <a:r>
-              <a:rPr lang="es-ES" sz="1200" b="0" i="0" dirty="0">
-                <a:solidFill>
-                  <a:srgbClr val="333333"/>
-                </a:solidFill>
-                <a:latin typeface="Calibri"/>
-                <a:cs typeface="Calibri"/>
-              </a:rPr>
-              <a:t>Multiples canales de captura sin estandar unico.</a:t>
-            </a:r>
-          </a:p>
-        </p:txBody>
-      </p:sp>
-      <p:sp>
-        <p:nvSpPr>
-          <p:cNvPr id="17" name="card"/>
-          <p:cNvSpPr/>
-          <p:nvPr/>
-        </p:nvSpPr>
-        <p:spPr>
-          <a:xfrm>
-            <a:off x="3383280" y="2514600"/>
-            <a:ext cx="2628900" cy="3657600"/>
-          </a:xfrm>
-          <a:prstGeom prst="roundRect">
-            <a:avLst/>
-          </a:prstGeom>
-          <a:solidFill>
-            <a:srgbClr val="FFFFFF"/>
-          </a:solidFill>
-          <a:ln w="9525">
-            <a:solidFill>
-              <a:srgbClr val="DCDCDC"/>
-            </a:solidFill>
-          </a:ln>
-          <a:effectLst>
-            <a:outerShdw blurRad="50000" dist="25000" dir="5400000" rotWithShape="0">
-              <a:srgbClr val="000000">
-                <a:alpha val="20000"/>
-              </a:srgbClr>
-            </a:outerShdw>
-          </a:effectLst>
-        </p:spPr>
-        <p:txBody>
-          <a:bodyPr/>
-          <a:lstStyle/>
-          <a:p>
-            <a:endParaRPr lang="es-ES"/>
-          </a:p>
-        </p:txBody>
-      </p:sp>
-      <p:sp>
-        <p:nvSpPr>
-          <p:cNvPr id="18" name="badge"/>
-          <p:cNvSpPr/>
-          <p:nvPr/>
-        </p:nvSpPr>
-        <p:spPr>
-          <a:xfrm>
-            <a:off x="4103370" y="2788920"/>
-            <a:ext cx="1188720" cy="1188720"/>
-          </a:xfrm>
-          <a:prstGeom prst="ellipse">
-            <a:avLst/>
-          </a:prstGeom>
-          <a:solidFill>
-            <a:srgbClr val="E8711E"/>
-          </a:solidFill>
-          <a:ln>
-            <a:noFill/>
-          </a:ln>
-          <a:effectLst>
-            <a:outerShdw blurRad="50000" dist="25000" dir="5400000" rotWithShape="0">
-              <a:srgbClr val="000000">
-                <a:alpha val="20000"/>
-              </a:srgbClr>
-            </a:outerShdw>
-          </a:effectLst>
-        </p:spPr>
-        <p:txBody>
-          <a:bodyPr/>
-          <a:lstStyle/>
-          <a:p>
-            <a:endParaRPr lang="es-ES"/>
-          </a:p>
-        </p:txBody>
-      </p:sp>
-      <p:sp>
-        <p:nvSpPr>
-          <p:cNvPr id="19" name="cargo"/>
-          <p:cNvSpPr/>
-          <p:nvPr/>
-        </p:nvSpPr>
-        <p:spPr>
-          <a:xfrm>
-            <a:off x="4295394" y="3182112"/>
-            <a:ext cx="475488" cy="329184"/>
-          </a:xfrm>
-          <a:prstGeom prst="roundRect">
-            <a:avLst/>
-          </a:prstGeom>
-          <a:noFill/>
-          <a:ln w="19050">
-            <a:solidFill>
-              <a:srgbClr val="FFFFFF"/>
-            </a:solidFill>
-          </a:ln>
-        </p:spPr>
-        <p:txBody>
-          <a:bodyPr/>
-          <a:lstStyle/>
-          <a:p>
-            <a:endParaRPr lang="es-ES"/>
-          </a:p>
-        </p:txBody>
-      </p:sp>
-      <p:sp>
-        <p:nvSpPr>
-          <p:cNvPr id="20" name="cab"/>
-          <p:cNvSpPr/>
-          <p:nvPr/>
-        </p:nvSpPr>
-        <p:spPr>
-          <a:xfrm>
-            <a:off x="4789170" y="3346704"/>
-            <a:ext cx="274320" cy="182880"/>
-          </a:xfrm>
-          <a:prstGeom prst="round1Rect">
-            <a:avLst/>
-          </a:prstGeom>
-          <a:noFill/>
-          <a:ln w="19050">
-            <a:solidFill>
-              <a:srgbClr val="FFFFFF"/>
-            </a:solidFill>
-          </a:ln>
-        </p:spPr>
-        <p:txBody>
-          <a:bodyPr/>
-          <a:lstStyle/>
-          <a:p>
-            <a:endParaRPr lang="es-ES"/>
-          </a:p>
-        </p:txBody>
-      </p:sp>
-      <p:sp>
-        <p:nvSpPr>
-          <p:cNvPr id="21" name="wheel"/>
-          <p:cNvSpPr/>
-          <p:nvPr/>
-        </p:nvSpPr>
-        <p:spPr>
-          <a:xfrm>
-            <a:off x="4459986" y="3529584"/>
-            <a:ext cx="155448" cy="155448"/>
-          </a:xfrm>
-          <a:prstGeom prst="ellipse">
-            <a:avLst/>
-          </a:prstGeom>
-          <a:noFill/>
-          <a:ln w="19050">
-            <a:solidFill>
-              <a:srgbClr val="FFFFFF"/>
-            </a:solidFill>
-          </a:ln>
-        </p:spPr>
-        <p:txBody>
-          <a:bodyPr/>
-          <a:lstStyle/>
-          <a:p>
-            <a:endParaRPr lang="es-ES"/>
-          </a:p>
-        </p:txBody>
-      </p:sp>
-      <p:sp>
-        <p:nvSpPr>
-          <p:cNvPr id="22" name="wheel"/>
-          <p:cNvSpPr/>
-          <p:nvPr/>
-        </p:nvSpPr>
-        <p:spPr>
-          <a:xfrm>
-            <a:off x="4862322" y="3529584"/>
-            <a:ext cx="155448" cy="155448"/>
-          </a:xfrm>
-          <a:prstGeom prst="ellipse">
-            <a:avLst/>
-          </a:prstGeom>
-          <a:noFill/>
-          <a:ln w="19050">
-            <a:solidFill>
-              <a:srgbClr val="FFFFFF"/>
-            </a:solidFill>
-          </a:ln>
-        </p:spPr>
-        <p:txBody>
-          <a:bodyPr/>
-          <a:lstStyle/>
-          <a:p>
-            <a:endParaRPr lang="es-ES"/>
-          </a:p>
-        </p:txBody>
-      </p:sp>
-      <p:sp>
-        <p:nvSpPr>
-          <p:cNvPr id="23" name="tb"/>
-          <p:cNvSpPr txBox="1"/>
-          <p:nvPr/>
-        </p:nvSpPr>
-        <p:spPr>
-          <a:xfrm>
-            <a:off x="3474720" y="4114800"/>
-            <a:ext cx="2446020" cy="640080"/>
-          </a:xfrm>
-          <a:prstGeom prst="rect">
-            <a:avLst/>
-          </a:prstGeom>
-          <a:noFill/>
-        </p:spPr>
-        <p:txBody>
-          <a:bodyPr wrap="square" anchor="t" lIns="73152" tIns="36576" rIns="73152" bIns="36576">
-            <a:normAutofit/>
-          </a:bodyPr>
-          <a:lstStyle/>
-          <a:p>
-            <a:pPr marL="0" indent="0" lvl="0" algn="ctr">
-              <a:lnSpc>
-                <a:spcPct val="96000"/>
-              </a:lnSpc>
-              <a:buNone/>
-            </a:pPr>
-            <a:r>
-              <a:rPr lang="es-ES" sz="1500" b="1" i="0" dirty="0">
-                <a:solidFill>
-                  <a:srgbClr val="E8711E"/>
-                </a:solidFill>
-                <a:latin typeface="Calibri"/>
-                <a:cs typeface="Calibri"/>
-              </a:rPr>
-              <a:t>Distribucion</a:t>
-            </a:r>
-          </a:p>
-        </p:txBody>
-      </p:sp>
-      <p:sp>
-        <p:nvSpPr>
-          <p:cNvPr id="24" name="uline"/>
-          <p:cNvSpPr/>
-          <p:nvPr/>
-        </p:nvSpPr>
-        <p:spPr>
-          <a:xfrm>
-            <a:off x="4377690" y="4727448"/>
-            <a:ext cx="640080" cy="36576"/>
-          </a:xfrm>
-          <a:prstGeom prst="rect">
-            <a:avLst/>
-          </a:prstGeom>
-          <a:solidFill>
-            <a:srgbClr val="E8711E"/>
-          </a:solidFill>
-          <a:ln>
-            <a:noFill/>
-          </a:ln>
-        </p:spPr>
-        <p:txBody>
-          <a:bodyPr/>
-          <a:lstStyle/>
-          <a:p>
-            <a:endParaRPr lang="es-ES"/>
-          </a:p>
-        </p:txBody>
-      </p:sp>
-      <p:sp>
-        <p:nvSpPr>
-          <p:cNvPr id="25" name="tb"/>
-          <p:cNvSpPr txBox="1"/>
-          <p:nvPr/>
-        </p:nvSpPr>
-        <p:spPr>
-          <a:xfrm>
-            <a:off x="3584448" y="4910328"/>
-            <a:ext cx="2263140" cy="1143000"/>
+            <a:off x="786384" y="4864608"/>
+            <a:ext cx="2226564" cy="1051560"/>
           </a:xfrm>
           <a:prstGeom prst="rect">
             <a:avLst/>
@@ -1662,7 +1416,7 @@
                 <a:srgbClr val="E8711E"/>
               </a:buClr>
               <a:buFont typeface="Arial"/>
-              <a:buChar char="•"/>
+              <a:buChar char="▸"/>
             </a:pPr>
             <a:r>
               <a:rPr lang="es-ES" sz="1200" b="0" i="0" dirty="0">
@@ -1672,7 +1426,7 @@
                 <a:latin typeface="Calibri"/>
                 <a:cs typeface="Calibri"/>
               </a:rPr>
-              <a:t>Entregas fallidas por errores de direccion.</a:t>
+              <a:t>Mas de 35.000 clientes con direcciones de calidad dispar.</a:t>
             </a:r>
           </a:p>
           <a:p>
@@ -1687,7 +1441,7 @@
                 <a:srgbClr val="E8711E"/>
               </a:buClr>
               <a:buFont typeface="Arial"/>
-              <a:buChar char="•"/>
+              <a:buChar char="▸"/>
             </a:pPr>
             <a:r>
               <a:rPr lang="es-ES" sz="1200" b="0" i="0" dirty="0">
@@ -1697,21 +1451,21 @@
                 <a:latin typeface="Calibri"/>
                 <a:cs typeface="Calibri"/>
               </a:rPr>
-              <a:t>Reprocesos y carga retornada al CD.</a:t>
-            </a:r>
-          </a:p>
-        </p:txBody>
-      </p:sp>
-      <p:sp>
-        <p:nvSpPr>
-          <p:cNvPr id="26" name="card"/>
-          <p:cNvSpPr/>
-          <p:nvPr/>
-        </p:nvSpPr>
-        <p:spPr>
-          <a:xfrm>
-            <a:off x="6199632" y="2514600"/>
-            <a:ext cx="2628900" cy="3657600"/>
+              <a:t>Multiples canales de captura sin estandar unico.</a:t>
+            </a:r>
+          </a:p>
+        </p:txBody>
+      </p:sp>
+      <p:sp>
+        <p:nvSpPr>
+          <p:cNvPr id="20" name="card"/>
+          <p:cNvSpPr/>
+          <p:nvPr/>
+        </p:nvSpPr>
+        <p:spPr>
+          <a:xfrm>
+            <a:off x="3383280" y="2468880"/>
+            <a:ext cx="2628900" cy="3703320"/>
           </a:xfrm>
           <a:prstGeom prst="roundRect">
             <a:avLst/>
@@ -1742,20 +1496,107 @@
       </p:sp>
       <p:sp>
         <p:nvSpPr>
-          <p:cNvPr id="27" name="badge"/>
-          <p:cNvSpPr/>
-          <p:nvPr/>
-        </p:nvSpPr>
-        <p:spPr>
-          <a:xfrm>
-            <a:off x="6919722" y="2788920"/>
+          <p:cNvPr id="21" name="top"/>
+          <p:cNvSpPr/>
+          <p:nvPr/>
+        </p:nvSpPr>
+        <p:spPr>
+          <a:xfrm>
+            <a:off x="3383280" y="2468880"/>
+            <a:ext cx="2628900" cy="146304"/>
+          </a:xfrm>
+          <a:prstGeom prst="round2SameRect">
+            <a:avLst/>
+          </a:prstGeom>
+          <a:solidFill>
+            <a:srgbClr val="123A5E"/>
+          </a:solidFill>
+          <a:ln>
+            <a:noFill/>
+          </a:ln>
+        </p:spPr>
+        <p:txBody>
+          <a:bodyPr/>
+          <a:lstStyle/>
+          <a:p>
+            <a:endParaRPr lang="es-ES"/>
+          </a:p>
+        </p:txBody>
+      </p:sp>
+      <p:sp>
+        <p:nvSpPr>
+          <p:cNvPr id="22" name="bot"/>
+          <p:cNvSpPr/>
+          <p:nvPr/>
+        </p:nvSpPr>
+        <p:spPr>
+          <a:xfrm flipV="1">
+            <a:off x="3383280" y="6025896"/>
+            <a:ext cx="2628900" cy="146304"/>
+          </a:xfrm>
+          <a:prstGeom prst="round2SameRect">
+            <a:avLst/>
+          </a:prstGeom>
+          <a:solidFill>
+            <a:srgbClr val="E8711E"/>
+          </a:solidFill>
+          <a:ln>
+            <a:noFill/>
+          </a:ln>
+        </p:spPr>
+        <p:txBody>
+          <a:bodyPr/>
+          <a:lstStyle/>
+          <a:p>
+            <a:endParaRPr lang="es-ES"/>
+          </a:p>
+        </p:txBody>
+      </p:sp>
+      <p:sp>
+        <p:nvSpPr>
+          <p:cNvPr id="23" name="halo"/>
+          <p:cNvSpPr/>
+          <p:nvPr/>
+        </p:nvSpPr>
+        <p:spPr>
+          <a:xfrm>
+            <a:off x="3966210" y="2651760"/>
+            <a:ext cx="1463040" cy="1463040"/>
+          </a:xfrm>
+          <a:prstGeom prst="ellipse">
+            <a:avLst/>
+          </a:prstGeom>
+          <a:solidFill>
+            <a:srgbClr val="FBE2CB"/>
+          </a:solidFill>
+          <a:ln>
+            <a:noFill/>
+          </a:ln>
+        </p:spPr>
+        <p:txBody>
+          <a:bodyPr/>
+          <a:lstStyle/>
+          <a:p>
+            <a:endParaRPr lang="es-ES"/>
+          </a:p>
+        </p:txBody>
+      </p:sp>
+      <p:sp>
+        <p:nvSpPr>
+          <p:cNvPr id="24" name="badge"/>
+          <p:cNvSpPr/>
+          <p:nvPr/>
+        </p:nvSpPr>
+        <p:spPr>
+          <a:xfrm>
+            <a:off x="4103370" y="2788920"/>
             <a:ext cx="1188720" cy="1188720"/>
           </a:xfrm>
           <a:prstGeom prst="ellipse">
             <a:avLst/>
           </a:prstGeom>
           <a:solidFill>
-            <a:srgbClr val="123A5E"/>
+            <a:srgbClr val="E8711E"/>
           </a:solidFill>
           <a:ln>
             <a:noFill/>
@@ -1778,16 +1619,16 @@
       </p:sp>
       <p:sp>
         <p:nvSpPr>
-          <p:cNvPr id="28" name="head"/>
-          <p:cNvSpPr/>
-          <p:nvPr/>
-        </p:nvSpPr>
-        <p:spPr>
-          <a:xfrm>
-            <a:off x="7367778" y="3054096"/>
-            <a:ext cx="274320" cy="274320"/>
-          </a:xfrm>
-          <a:prstGeom prst="ellipse">
+          <p:cNvPr id="25" name="cargo"/>
+          <p:cNvSpPr/>
+          <p:nvPr/>
+        </p:nvSpPr>
+        <p:spPr>
+          <a:xfrm>
+            <a:off x="4295394" y="3182112"/>
+            <a:ext cx="475488" cy="329184"/>
+          </a:xfrm>
+          <a:prstGeom prst="roundRect">
             <a:avLst/>
           </a:prstGeom>
           <a:noFill/>
@@ -1807,16 +1648,16 @@
       </p:sp>
       <p:sp>
         <p:nvSpPr>
-          <p:cNvPr id="29" name="body"/>
-          <p:cNvSpPr/>
-          <p:nvPr/>
-        </p:nvSpPr>
-        <p:spPr>
-          <a:xfrm>
-            <a:off x="7239762" y="3383280"/>
-            <a:ext cx="530352" cy="310896"/>
-          </a:xfrm>
-          <a:prstGeom prst="trapezoid">
+          <p:cNvPr id="26" name="cab"/>
+          <p:cNvSpPr/>
+          <p:nvPr/>
+        </p:nvSpPr>
+        <p:spPr>
+          <a:xfrm>
+            <a:off x="4789170" y="3346704"/>
+            <a:ext cx="274320" cy="182880"/>
+          </a:xfrm>
+          <a:prstGeom prst="round1Rect">
             <a:avLst/>
           </a:prstGeom>
           <a:noFill/>
@@ -1836,42 +1677,71 @@
       </p:sp>
       <p:sp>
         <p:nvSpPr>
-          <p:cNvPr id="30" name="heart"/>
-          <p:cNvSpPr/>
-          <p:nvPr/>
-        </p:nvSpPr>
-        <p:spPr>
-          <a:xfrm>
-            <a:off x="7623810" y="2999232"/>
-            <a:ext cx="219456" cy="201168"/>
-          </a:xfrm>
-          <a:prstGeom prst="heart">
-            <a:avLst/>
-          </a:prstGeom>
-          <a:solidFill>
-            <a:srgbClr val="E8711E"/>
-          </a:solidFill>
-          <a:ln>
-            <a:noFill/>
-          </a:ln>
-        </p:spPr>
-        <p:txBody>
-          <a:bodyPr/>
-          <a:lstStyle/>
-          <a:p>
-            <a:endParaRPr lang="es-ES"/>
-          </a:p>
-        </p:txBody>
-      </p:sp>
-      <p:sp>
-        <p:nvSpPr>
-          <p:cNvPr id="31" name="tb"/>
+          <p:cNvPr id="27" name="wheel"/>
+          <p:cNvSpPr/>
+          <p:nvPr/>
+        </p:nvSpPr>
+        <p:spPr>
+          <a:xfrm>
+            <a:off x="4459986" y="3529584"/>
+            <a:ext cx="155448" cy="155448"/>
+          </a:xfrm>
+          <a:prstGeom prst="ellipse">
+            <a:avLst/>
+          </a:prstGeom>
+          <a:noFill/>
+          <a:ln w="19050">
+            <a:solidFill>
+              <a:srgbClr val="FFFFFF"/>
+            </a:solidFill>
+          </a:ln>
+        </p:spPr>
+        <p:txBody>
+          <a:bodyPr/>
+          <a:lstStyle/>
+          <a:p>
+            <a:endParaRPr lang="es-ES"/>
+          </a:p>
+        </p:txBody>
+      </p:sp>
+      <p:sp>
+        <p:nvSpPr>
+          <p:cNvPr id="28" name="wheel"/>
+          <p:cNvSpPr/>
+          <p:nvPr/>
+        </p:nvSpPr>
+        <p:spPr>
+          <a:xfrm>
+            <a:off x="4862322" y="3529584"/>
+            <a:ext cx="155448" cy="155448"/>
+          </a:xfrm>
+          <a:prstGeom prst="ellipse">
+            <a:avLst/>
+          </a:prstGeom>
+          <a:noFill/>
+          <a:ln w="19050">
+            <a:solidFill>
+              <a:srgbClr val="FFFFFF"/>
+            </a:solidFill>
+          </a:ln>
+        </p:spPr>
+        <p:txBody>
+          <a:bodyPr/>
+          <a:lstStyle/>
+          <a:p>
+            <a:endParaRPr lang="es-ES"/>
+          </a:p>
+        </p:txBody>
+      </p:sp>
+      <p:sp>
+        <p:nvSpPr>
+          <p:cNvPr id="29" name="tb"/>
           <p:cNvSpPr txBox="1"/>
           <p:nvPr/>
         </p:nvSpPr>
         <p:spPr>
           <a:xfrm>
-            <a:off x="6291072" y="4114800"/>
+            <a:off x="3474720" y="4096512"/>
             <a:ext cx="2446020" cy="640080"/>
           </a:xfrm>
           <a:prstGeom prst="rect">
@@ -1899,354 +1769,50 @@
                 <a:latin typeface="Calibri"/>
                 <a:cs typeface="Calibri"/>
               </a:rPr>
-              <a:t>Experiencia Cliente</a:t>
-            </a:r>
-          </a:p>
-        </p:txBody>
-      </p:sp>
-      <p:sp>
-        <p:nvSpPr>
-          <p:cNvPr id="32" name="uline"/>
-          <p:cNvSpPr/>
-          <p:nvPr/>
-        </p:nvSpPr>
-        <p:spPr>
-          <a:xfrm>
-            <a:off x="7194042" y="4727448"/>
-            <a:ext cx="640080" cy="36576"/>
-          </a:xfrm>
-          <a:prstGeom prst="rect">
-            <a:avLst/>
-          </a:prstGeom>
-          <a:solidFill>
-            <a:srgbClr val="123A5E"/>
-          </a:solidFill>
-          <a:ln>
-            <a:noFill/>
-          </a:ln>
-        </p:spPr>
-        <p:txBody>
-          <a:bodyPr/>
-          <a:lstStyle/>
-          <a:p>
-            <a:endParaRPr lang="es-ES"/>
-          </a:p>
-        </p:txBody>
-      </p:sp>
-      <p:sp>
-        <p:nvSpPr>
-          <p:cNvPr id="33" name="tb"/>
+              <a:t>Distribucion</a:t>
+            </a:r>
+          </a:p>
+        </p:txBody>
+      </p:sp>
+      <p:sp>
+        <p:nvSpPr>
+          <p:cNvPr id="30" name="uline"/>
+          <p:cNvSpPr/>
+          <p:nvPr/>
+        </p:nvSpPr>
+        <p:spPr>
+          <a:xfrm>
+            <a:off x="4405122" y="4681728"/>
+            <a:ext cx="585216" cy="54864"/>
+          </a:xfrm>
+          <a:prstGeom prst="roundRect">
+            <a:avLst/>
+          </a:prstGeom>
+          <a:solidFill>
+            <a:srgbClr val="E8711E"/>
+          </a:solidFill>
+          <a:ln>
+            <a:noFill/>
+          </a:ln>
+        </p:spPr>
+        <p:txBody>
+          <a:bodyPr/>
+          <a:lstStyle/>
+          <a:p>
+            <a:endParaRPr lang="es-ES"/>
+          </a:p>
+        </p:txBody>
+      </p:sp>
+      <p:sp>
+        <p:nvSpPr>
+          <p:cNvPr id="31" name="tb"/>
           <p:cNvSpPr txBox="1"/>
           <p:nvPr/>
         </p:nvSpPr>
         <p:spPr>
           <a:xfrm>
-            <a:off x="6400800" y="4910328"/>
-            <a:ext cx="2263140" cy="1143000"/>
-          </a:xfrm>
-          <a:prstGeom prst="rect">
-            <a:avLst/>
-          </a:prstGeom>
-          <a:noFill/>
-        </p:spPr>
-        <p:txBody>
-          <a:bodyPr wrap="square" anchor="t" lIns="73152" tIns="36576" rIns="73152" bIns="36576">
-            <a:normAutofit/>
-          </a:bodyPr>
-          <a:lstStyle/>
-          <a:p>
-            <a:pPr marL="228600" indent="-228600" lvl="0" algn="l">
-              <a:lnSpc>
-                <a:spcPct val="104000"/>
-              </a:lnSpc>
-              <a:spcAft>
-                <a:spcPts val="260"/>
-              </a:spcAft>
-              <a:buClr>
-                <a:srgbClr val="123A5E"/>
-              </a:buClr>
-              <a:buFont typeface="Arial"/>
-              <a:buChar char="•"/>
-            </a:pPr>
-            <a:r>
-              <a:rPr lang="es-ES" sz="1200" b="0" i="0" dirty="0">
-                <a:solidFill>
-                  <a:srgbClr val="333333"/>
-                </a:solidFill>
-                <a:latin typeface="Calibri"/>
-                <a:cs typeface="Calibri"/>
-              </a:rPr>
-              <a:t>Retrasos en las entregas.</a:t>
-            </a:r>
-          </a:p>
-          <a:p>
-            <a:pPr marL="228600" indent="-228600" lvl="0" algn="l">
-              <a:lnSpc>
-                <a:spcPct val="104000"/>
-              </a:lnSpc>
-              <a:spcAft>
-                <a:spcPts val="260"/>
-              </a:spcAft>
-              <a:buClr>
-                <a:srgbClr val="123A5E"/>
-              </a:buClr>
-              <a:buFont typeface="Arial"/>
-              <a:buChar char="•"/>
-            </a:pPr>
-            <a:r>
-              <a:rPr lang="es-ES" sz="1200" b="0" i="0" dirty="0">
-                <a:solidFill>
-                  <a:srgbClr val="333333"/>
-                </a:solidFill>
-                <a:latin typeface="Calibri"/>
-                <a:cs typeface="Calibri"/>
-              </a:rPr>
-              <a:t>Falta de entregas same day en la RM.</a:t>
-            </a:r>
-          </a:p>
-        </p:txBody>
-      </p:sp>
-      <p:sp>
-        <p:nvSpPr>
-          <p:cNvPr id="34" name="card"/>
-          <p:cNvSpPr/>
-          <p:nvPr/>
-        </p:nvSpPr>
-        <p:spPr>
-          <a:xfrm>
-            <a:off x="9015984" y="2514600"/>
-            <a:ext cx="2628900" cy="3657600"/>
-          </a:xfrm>
-          <a:prstGeom prst="roundRect">
-            <a:avLst/>
-          </a:prstGeom>
-          <a:solidFill>
-            <a:srgbClr val="FFFFFF"/>
-          </a:solidFill>
-          <a:ln w="9525">
-            <a:solidFill>
-              <a:srgbClr val="DCDCDC"/>
-            </a:solidFill>
-          </a:ln>
-          <a:effectLst>
-            <a:outerShdw blurRad="50000" dist="25000" dir="5400000" rotWithShape="0">
-              <a:srgbClr val="000000">
-                <a:alpha val="20000"/>
-              </a:srgbClr>
-            </a:outerShdw>
-          </a:effectLst>
-        </p:spPr>
-        <p:txBody>
-          <a:bodyPr/>
-          <a:lstStyle/>
-          <a:p>
-            <a:endParaRPr lang="es-ES"/>
-          </a:p>
-        </p:txBody>
-      </p:sp>
-      <p:sp>
-        <p:nvSpPr>
-          <p:cNvPr id="35" name="badge"/>
-          <p:cNvSpPr/>
-          <p:nvPr/>
-        </p:nvSpPr>
-        <p:spPr>
-          <a:xfrm>
-            <a:off x="9736074" y="2788920"/>
-            <a:ext cx="1188720" cy="1188720"/>
-          </a:xfrm>
-          <a:prstGeom prst="ellipse">
-            <a:avLst/>
-          </a:prstGeom>
-          <a:solidFill>
-            <a:srgbClr val="E8711E"/>
-          </a:solidFill>
-          <a:ln>
-            <a:noFill/>
-          </a:ln>
-          <a:effectLst>
-            <a:outerShdw blurRad="50000" dist="25000" dir="5400000" rotWithShape="0">
-              <a:srgbClr val="000000">
-                <a:alpha val="20000"/>
-              </a:srgbClr>
-            </a:outerShdw>
-          </a:effectLst>
-        </p:spPr>
-        <p:txBody>
-          <a:bodyPr/>
-          <a:lstStyle/>
-          <a:p>
-            <a:endParaRPr lang="es-ES"/>
-          </a:p>
-        </p:txBody>
-      </p:sp>
-      <p:sp>
-        <p:nvSpPr>
-          <p:cNvPr id="36" name="awning"/>
-          <p:cNvSpPr/>
-          <p:nvPr/>
-        </p:nvSpPr>
-        <p:spPr>
-          <a:xfrm flipV="1">
-            <a:off x="10001250" y="3072384"/>
-            <a:ext cx="658368" cy="164592"/>
-          </a:xfrm>
-          <a:prstGeom prst="trapezoid">
-            <a:avLst/>
-          </a:prstGeom>
-          <a:noFill/>
-          <a:ln w="19050">
-            <a:solidFill>
-              <a:srgbClr val="FFFFFF"/>
-            </a:solidFill>
-          </a:ln>
-        </p:spPr>
-        <p:txBody>
-          <a:bodyPr/>
-          <a:lstStyle/>
-          <a:p>
-            <a:endParaRPr lang="es-ES"/>
-          </a:p>
-        </p:txBody>
-      </p:sp>
-      <p:sp>
-        <p:nvSpPr>
-          <p:cNvPr id="37" name="store"/>
-          <p:cNvSpPr/>
-          <p:nvPr/>
-        </p:nvSpPr>
-        <p:spPr>
-          <a:xfrm>
-            <a:off x="10074402" y="3236976"/>
-            <a:ext cx="512064" cy="457200"/>
-          </a:xfrm>
-          <a:prstGeom prst="rect">
-            <a:avLst/>
-          </a:prstGeom>
-          <a:noFill/>
-          <a:ln w="19050">
-            <a:solidFill>
-              <a:srgbClr val="FFFFFF"/>
-            </a:solidFill>
-          </a:ln>
-        </p:spPr>
-        <p:txBody>
-          <a:bodyPr/>
-          <a:lstStyle/>
-          <a:p>
-            <a:endParaRPr lang="es-ES"/>
-          </a:p>
-        </p:txBody>
-      </p:sp>
-      <p:sp>
-        <p:nvSpPr>
-          <p:cNvPr id="38" name="door"/>
-          <p:cNvSpPr/>
-          <p:nvPr/>
-        </p:nvSpPr>
-        <p:spPr>
-          <a:xfrm>
-            <a:off x="10248138" y="3429000"/>
-            <a:ext cx="164592" cy="265176"/>
-          </a:xfrm>
-          <a:prstGeom prst="rect">
-            <a:avLst/>
-          </a:prstGeom>
-          <a:noFill/>
-          <a:ln w="19050">
-            <a:solidFill>
-              <a:srgbClr val="FFFFFF"/>
-            </a:solidFill>
-          </a:ln>
-        </p:spPr>
-        <p:txBody>
-          <a:bodyPr/>
-          <a:lstStyle/>
-          <a:p>
-            <a:endParaRPr lang="es-ES"/>
-          </a:p>
-        </p:txBody>
-      </p:sp>
-      <p:sp>
-        <p:nvSpPr>
-          <p:cNvPr id="39" name="tb"/>
-          <p:cNvSpPr txBox="1"/>
-          <p:nvPr/>
-        </p:nvSpPr>
-        <p:spPr>
-          <a:xfrm>
-            <a:off x="9107424" y="4114800"/>
-            <a:ext cx="2446020" cy="640080"/>
-          </a:xfrm>
-          <a:prstGeom prst="rect">
-            <a:avLst/>
-          </a:prstGeom>
-          <a:noFill/>
-        </p:spPr>
-        <p:txBody>
-          <a:bodyPr wrap="square" anchor="t" lIns="73152" tIns="36576" rIns="73152" bIns="36576">
-            <a:normAutofit/>
-          </a:bodyPr>
-          <a:lstStyle/>
-          <a:p>
-            <a:pPr marL="0" indent="0" lvl="0" algn="ctr">
-              <a:lnSpc>
-                <a:spcPct val="96000"/>
-              </a:lnSpc>
-              <a:buNone/>
-            </a:pPr>
-            <a:r>
-              <a:rPr lang="es-ES" sz="1500" b="1" i="0" dirty="0">
-                <a:solidFill>
-                  <a:srgbClr val="E8711E"/>
-                </a:solidFill>
-                <a:latin typeface="Calibri"/>
-                <a:cs typeface="Calibri"/>
-              </a:rPr>
-              <a:t>Retail</a:t>
-            </a:r>
-          </a:p>
-        </p:txBody>
-      </p:sp>
-      <p:sp>
-        <p:nvSpPr>
-          <p:cNvPr id="40" name="uline"/>
-          <p:cNvSpPr/>
-          <p:nvPr/>
-        </p:nvSpPr>
-        <p:spPr>
-          <a:xfrm>
-            <a:off x="10010394" y="4727448"/>
-            <a:ext cx="640080" cy="36576"/>
-          </a:xfrm>
-          <a:prstGeom prst="rect">
-            <a:avLst/>
-          </a:prstGeom>
-          <a:solidFill>
-            <a:srgbClr val="E8711E"/>
-          </a:solidFill>
-          <a:ln>
-            <a:noFill/>
-          </a:ln>
-        </p:spPr>
-        <p:txBody>
-          <a:bodyPr/>
-          <a:lstStyle/>
-          <a:p>
-            <a:endParaRPr lang="es-ES"/>
-          </a:p>
-        </p:txBody>
-      </p:sp>
-      <p:sp>
-        <p:nvSpPr>
-          <p:cNvPr id="41" name="tb"/>
-          <p:cNvSpPr txBox="1"/>
-          <p:nvPr/>
-        </p:nvSpPr>
-        <p:spPr>
-          <a:xfrm>
-            <a:off x="9217152" y="4910328"/>
-            <a:ext cx="2263140" cy="1143000"/>
+            <a:off x="3602736" y="4864608"/>
+            <a:ext cx="2226564" cy="1051560"/>
           </a:xfrm>
           <a:prstGeom prst="rect">
             <a:avLst/>
@@ -2270,7 +1836,7 @@
                 <a:srgbClr val="E8711E"/>
               </a:buClr>
               <a:buFont typeface="Arial"/>
-              <a:buChar char="•"/>
+              <a:buChar char="▸"/>
             </a:pPr>
             <a:r>
               <a:rPr lang="es-ES" sz="1200" b="0" i="0" dirty="0">
@@ -2280,7 +1846,7 @@
                 <a:latin typeface="Calibri"/>
                 <a:cs typeface="Calibri"/>
               </a:rPr>
-              <a:t>Venta limitada al stock de cada tienda.</a:t>
+              <a:t>Entregas fallidas por errores de direccion.</a:t>
             </a:r>
           </a:p>
           <a:p>
@@ -2295,7 +1861,789 @@
                 <a:srgbClr val="E8711E"/>
               </a:buClr>
               <a:buFont typeface="Arial"/>
-              <a:buChar char="•"/>
+              <a:buChar char="▸"/>
+            </a:pPr>
+            <a:r>
+              <a:rPr lang="es-ES" sz="1200" b="0" i="0" dirty="0">
+                <a:solidFill>
+                  <a:srgbClr val="333333"/>
+                </a:solidFill>
+                <a:latin typeface="Calibri"/>
+                <a:cs typeface="Calibri"/>
+              </a:rPr>
+              <a:t>Reprocesos y carga retornada al CD.</a:t>
+            </a:r>
+          </a:p>
+        </p:txBody>
+      </p:sp>
+      <p:sp>
+        <p:nvSpPr>
+          <p:cNvPr id="32" name="card"/>
+          <p:cNvSpPr/>
+          <p:nvPr/>
+        </p:nvSpPr>
+        <p:spPr>
+          <a:xfrm>
+            <a:off x="6199632" y="2468880"/>
+            <a:ext cx="2628900" cy="3703320"/>
+          </a:xfrm>
+          <a:prstGeom prst="roundRect">
+            <a:avLst/>
+          </a:prstGeom>
+          <a:solidFill>
+            <a:srgbClr val="FFFFFF"/>
+          </a:solidFill>
+          <a:ln w="9525">
+            <a:solidFill>
+              <a:srgbClr val="DCDCDC"/>
+            </a:solidFill>
+          </a:ln>
+          <a:effectLst>
+            <a:outerShdw blurRad="50000" dist="25000" dir="5400000" rotWithShape="0">
+              <a:srgbClr val="000000">
+                <a:alpha val="20000"/>
+              </a:srgbClr>
+            </a:outerShdw>
+          </a:effectLst>
+        </p:spPr>
+        <p:txBody>
+          <a:bodyPr/>
+          <a:lstStyle/>
+          <a:p>
+            <a:endParaRPr lang="es-ES"/>
+          </a:p>
+        </p:txBody>
+      </p:sp>
+      <p:sp>
+        <p:nvSpPr>
+          <p:cNvPr id="33" name="top"/>
+          <p:cNvSpPr/>
+          <p:nvPr/>
+        </p:nvSpPr>
+        <p:spPr>
+          <a:xfrm>
+            <a:off x="6199632" y="2468880"/>
+            <a:ext cx="2628900" cy="146304"/>
+          </a:xfrm>
+          <a:prstGeom prst="round2SameRect">
+            <a:avLst/>
+          </a:prstGeom>
+          <a:solidFill>
+            <a:srgbClr val="123A5E"/>
+          </a:solidFill>
+          <a:ln>
+            <a:noFill/>
+          </a:ln>
+        </p:spPr>
+        <p:txBody>
+          <a:bodyPr/>
+          <a:lstStyle/>
+          <a:p>
+            <a:endParaRPr lang="es-ES"/>
+          </a:p>
+        </p:txBody>
+      </p:sp>
+      <p:sp>
+        <p:nvSpPr>
+          <p:cNvPr id="34" name="bot"/>
+          <p:cNvSpPr/>
+          <p:nvPr/>
+        </p:nvSpPr>
+        <p:spPr>
+          <a:xfrm flipV="1">
+            <a:off x="6199632" y="6025896"/>
+            <a:ext cx="2628900" cy="146304"/>
+          </a:xfrm>
+          <a:prstGeom prst="round2SameRect">
+            <a:avLst/>
+          </a:prstGeom>
+          <a:solidFill>
+            <a:srgbClr val="E8711E"/>
+          </a:solidFill>
+          <a:ln>
+            <a:noFill/>
+          </a:ln>
+        </p:spPr>
+        <p:txBody>
+          <a:bodyPr/>
+          <a:lstStyle/>
+          <a:p>
+            <a:endParaRPr lang="es-ES"/>
+          </a:p>
+        </p:txBody>
+      </p:sp>
+      <p:sp>
+        <p:nvSpPr>
+          <p:cNvPr id="35" name="halo"/>
+          <p:cNvSpPr/>
+          <p:nvPr/>
+        </p:nvSpPr>
+        <p:spPr>
+          <a:xfrm>
+            <a:off x="6782562" y="2651760"/>
+            <a:ext cx="1463040" cy="1463040"/>
+          </a:xfrm>
+          <a:prstGeom prst="ellipse">
+            <a:avLst/>
+          </a:prstGeom>
+          <a:solidFill>
+            <a:srgbClr val="FBE2CB"/>
+          </a:solidFill>
+          <a:ln>
+            <a:noFill/>
+          </a:ln>
+        </p:spPr>
+        <p:txBody>
+          <a:bodyPr/>
+          <a:lstStyle/>
+          <a:p>
+            <a:endParaRPr lang="es-ES"/>
+          </a:p>
+        </p:txBody>
+      </p:sp>
+      <p:sp>
+        <p:nvSpPr>
+          <p:cNvPr id="36" name="badge"/>
+          <p:cNvSpPr/>
+          <p:nvPr/>
+        </p:nvSpPr>
+        <p:spPr>
+          <a:xfrm>
+            <a:off x="6919722" y="2788920"/>
+            <a:ext cx="1188720" cy="1188720"/>
+          </a:xfrm>
+          <a:prstGeom prst="ellipse">
+            <a:avLst/>
+          </a:prstGeom>
+          <a:solidFill>
+            <a:srgbClr val="E8711E"/>
+          </a:solidFill>
+          <a:ln>
+            <a:noFill/>
+          </a:ln>
+          <a:effectLst>
+            <a:outerShdw blurRad="50000" dist="25000" dir="5400000" rotWithShape="0">
+              <a:srgbClr val="000000">
+                <a:alpha val="20000"/>
+              </a:srgbClr>
+            </a:outerShdw>
+          </a:effectLst>
+        </p:spPr>
+        <p:txBody>
+          <a:bodyPr/>
+          <a:lstStyle/>
+          <a:p>
+            <a:endParaRPr lang="es-ES"/>
+          </a:p>
+        </p:txBody>
+      </p:sp>
+      <p:sp>
+        <p:nvSpPr>
+          <p:cNvPr id="37" name="head"/>
+          <p:cNvSpPr/>
+          <p:nvPr/>
+        </p:nvSpPr>
+        <p:spPr>
+          <a:xfrm>
+            <a:off x="7367778" y="3054096"/>
+            <a:ext cx="274320" cy="274320"/>
+          </a:xfrm>
+          <a:prstGeom prst="ellipse">
+            <a:avLst/>
+          </a:prstGeom>
+          <a:noFill/>
+          <a:ln w="19050">
+            <a:solidFill>
+              <a:srgbClr val="FFFFFF"/>
+            </a:solidFill>
+          </a:ln>
+        </p:spPr>
+        <p:txBody>
+          <a:bodyPr/>
+          <a:lstStyle/>
+          <a:p>
+            <a:endParaRPr lang="es-ES"/>
+          </a:p>
+        </p:txBody>
+      </p:sp>
+      <p:sp>
+        <p:nvSpPr>
+          <p:cNvPr id="38" name="body"/>
+          <p:cNvSpPr/>
+          <p:nvPr/>
+        </p:nvSpPr>
+        <p:spPr>
+          <a:xfrm>
+            <a:off x="7239762" y="3383280"/>
+            <a:ext cx="530352" cy="310896"/>
+          </a:xfrm>
+          <a:prstGeom prst="trapezoid">
+            <a:avLst/>
+          </a:prstGeom>
+          <a:noFill/>
+          <a:ln w="19050">
+            <a:solidFill>
+              <a:srgbClr val="FFFFFF"/>
+            </a:solidFill>
+          </a:ln>
+        </p:spPr>
+        <p:txBody>
+          <a:bodyPr/>
+          <a:lstStyle/>
+          <a:p>
+            <a:endParaRPr lang="es-ES"/>
+          </a:p>
+        </p:txBody>
+      </p:sp>
+      <p:sp>
+        <p:nvSpPr>
+          <p:cNvPr id="39" name="heart"/>
+          <p:cNvSpPr/>
+          <p:nvPr/>
+        </p:nvSpPr>
+        <p:spPr>
+          <a:xfrm>
+            <a:off x="7623810" y="2999232"/>
+            <a:ext cx="219456" cy="201168"/>
+          </a:xfrm>
+          <a:prstGeom prst="heart">
+            <a:avLst/>
+          </a:prstGeom>
+          <a:solidFill>
+            <a:srgbClr val="FFFFFF"/>
+          </a:solidFill>
+          <a:ln>
+            <a:noFill/>
+          </a:ln>
+        </p:spPr>
+        <p:txBody>
+          <a:bodyPr/>
+          <a:lstStyle/>
+          <a:p>
+            <a:endParaRPr lang="es-ES"/>
+          </a:p>
+        </p:txBody>
+      </p:sp>
+      <p:sp>
+        <p:nvSpPr>
+          <p:cNvPr id="40" name="tb"/>
+          <p:cNvSpPr txBox="1"/>
+          <p:nvPr/>
+        </p:nvSpPr>
+        <p:spPr>
+          <a:xfrm>
+            <a:off x="6291072" y="4096512"/>
+            <a:ext cx="2446020" cy="640080"/>
+          </a:xfrm>
+          <a:prstGeom prst="rect">
+            <a:avLst/>
+          </a:prstGeom>
+          <a:noFill/>
+        </p:spPr>
+        <p:txBody>
+          <a:bodyPr wrap="square" anchor="t" lIns="73152" tIns="36576" rIns="73152" bIns="36576">
+            <a:normAutofit/>
+          </a:bodyPr>
+          <a:lstStyle/>
+          <a:p>
+            <a:pPr marL="0" indent="0" lvl="0" algn="ctr">
+              <a:lnSpc>
+                <a:spcPct val="96000"/>
+              </a:lnSpc>
+              <a:buNone/>
+            </a:pPr>
+            <a:r>
+              <a:rPr lang="es-ES" sz="1500" b="1" i="0" dirty="0">
+                <a:solidFill>
+                  <a:srgbClr val="123A5E"/>
+                </a:solidFill>
+                <a:latin typeface="Calibri"/>
+                <a:cs typeface="Calibri"/>
+              </a:rPr>
+              <a:t>Experiencia Cliente</a:t>
+            </a:r>
+          </a:p>
+        </p:txBody>
+      </p:sp>
+      <p:sp>
+        <p:nvSpPr>
+          <p:cNvPr id="41" name="uline"/>
+          <p:cNvSpPr/>
+          <p:nvPr/>
+        </p:nvSpPr>
+        <p:spPr>
+          <a:xfrm>
+            <a:off x="7221474" y="4681728"/>
+            <a:ext cx="585216" cy="54864"/>
+          </a:xfrm>
+          <a:prstGeom prst="roundRect">
+            <a:avLst/>
+          </a:prstGeom>
+          <a:solidFill>
+            <a:srgbClr val="E8711E"/>
+          </a:solidFill>
+          <a:ln>
+            <a:noFill/>
+          </a:ln>
+        </p:spPr>
+        <p:txBody>
+          <a:bodyPr/>
+          <a:lstStyle/>
+          <a:p>
+            <a:endParaRPr lang="es-ES"/>
+          </a:p>
+        </p:txBody>
+      </p:sp>
+      <p:sp>
+        <p:nvSpPr>
+          <p:cNvPr id="42" name="tb"/>
+          <p:cNvSpPr txBox="1"/>
+          <p:nvPr/>
+        </p:nvSpPr>
+        <p:spPr>
+          <a:xfrm>
+            <a:off x="6419088" y="4864608"/>
+            <a:ext cx="2226564" cy="1051560"/>
+          </a:xfrm>
+          <a:prstGeom prst="rect">
+            <a:avLst/>
+          </a:prstGeom>
+          <a:noFill/>
+        </p:spPr>
+        <p:txBody>
+          <a:bodyPr wrap="square" anchor="t" lIns="73152" tIns="36576" rIns="73152" bIns="36576">
+            <a:normAutofit/>
+          </a:bodyPr>
+          <a:lstStyle/>
+          <a:p>
+            <a:pPr marL="228600" indent="-228600" lvl="0" algn="l">
+              <a:lnSpc>
+                <a:spcPct val="104000"/>
+              </a:lnSpc>
+              <a:spcAft>
+                <a:spcPts val="260"/>
+              </a:spcAft>
+              <a:buClr>
+                <a:srgbClr val="E8711E"/>
+              </a:buClr>
+              <a:buFont typeface="Arial"/>
+              <a:buChar char="▸"/>
+            </a:pPr>
+            <a:r>
+              <a:rPr lang="es-ES" sz="1200" b="0" i="0" dirty="0">
+                <a:solidFill>
+                  <a:srgbClr val="333333"/>
+                </a:solidFill>
+                <a:latin typeface="Calibri"/>
+                <a:cs typeface="Calibri"/>
+              </a:rPr>
+              <a:t>Retrasos en las entregas.</a:t>
+            </a:r>
+          </a:p>
+          <a:p>
+            <a:pPr marL="228600" indent="-228600" lvl="0" algn="l">
+              <a:lnSpc>
+                <a:spcPct val="104000"/>
+              </a:lnSpc>
+              <a:spcAft>
+                <a:spcPts val="260"/>
+              </a:spcAft>
+              <a:buClr>
+                <a:srgbClr val="E8711E"/>
+              </a:buClr>
+              <a:buFont typeface="Arial"/>
+              <a:buChar char="▸"/>
+            </a:pPr>
+            <a:r>
+              <a:rPr lang="es-ES" sz="1200" b="0" i="0" dirty="0">
+                <a:solidFill>
+                  <a:srgbClr val="333333"/>
+                </a:solidFill>
+                <a:latin typeface="Calibri"/>
+                <a:cs typeface="Calibri"/>
+              </a:rPr>
+              <a:t>Falta de entregas same day en la RM.</a:t>
+            </a:r>
+          </a:p>
+        </p:txBody>
+      </p:sp>
+      <p:sp>
+        <p:nvSpPr>
+          <p:cNvPr id="43" name="card"/>
+          <p:cNvSpPr/>
+          <p:nvPr/>
+        </p:nvSpPr>
+        <p:spPr>
+          <a:xfrm>
+            <a:off x="9015984" y="2468880"/>
+            <a:ext cx="2628900" cy="3703320"/>
+          </a:xfrm>
+          <a:prstGeom prst="roundRect">
+            <a:avLst/>
+          </a:prstGeom>
+          <a:solidFill>
+            <a:srgbClr val="FFFFFF"/>
+          </a:solidFill>
+          <a:ln w="9525">
+            <a:solidFill>
+              <a:srgbClr val="DCDCDC"/>
+            </a:solidFill>
+          </a:ln>
+          <a:effectLst>
+            <a:outerShdw blurRad="50000" dist="25000" dir="5400000" rotWithShape="0">
+              <a:srgbClr val="000000">
+                <a:alpha val="20000"/>
+              </a:srgbClr>
+            </a:outerShdw>
+          </a:effectLst>
+        </p:spPr>
+        <p:txBody>
+          <a:bodyPr/>
+          <a:lstStyle/>
+          <a:p>
+            <a:endParaRPr lang="es-ES"/>
+          </a:p>
+        </p:txBody>
+      </p:sp>
+      <p:sp>
+        <p:nvSpPr>
+          <p:cNvPr id="44" name="top"/>
+          <p:cNvSpPr/>
+          <p:nvPr/>
+        </p:nvSpPr>
+        <p:spPr>
+          <a:xfrm>
+            <a:off x="9015984" y="2468880"/>
+            <a:ext cx="2628900" cy="146304"/>
+          </a:xfrm>
+          <a:prstGeom prst="round2SameRect">
+            <a:avLst/>
+          </a:prstGeom>
+          <a:solidFill>
+            <a:srgbClr val="123A5E"/>
+          </a:solidFill>
+          <a:ln>
+            <a:noFill/>
+          </a:ln>
+        </p:spPr>
+        <p:txBody>
+          <a:bodyPr/>
+          <a:lstStyle/>
+          <a:p>
+            <a:endParaRPr lang="es-ES"/>
+          </a:p>
+        </p:txBody>
+      </p:sp>
+      <p:sp>
+        <p:nvSpPr>
+          <p:cNvPr id="45" name="bot"/>
+          <p:cNvSpPr/>
+          <p:nvPr/>
+        </p:nvSpPr>
+        <p:spPr>
+          <a:xfrm flipV="1">
+            <a:off x="9015984" y="6025896"/>
+            <a:ext cx="2628900" cy="146304"/>
+          </a:xfrm>
+          <a:prstGeom prst="round2SameRect">
+            <a:avLst/>
+          </a:prstGeom>
+          <a:solidFill>
+            <a:srgbClr val="E8711E"/>
+          </a:solidFill>
+          <a:ln>
+            <a:noFill/>
+          </a:ln>
+        </p:spPr>
+        <p:txBody>
+          <a:bodyPr/>
+          <a:lstStyle/>
+          <a:p>
+            <a:endParaRPr lang="es-ES"/>
+          </a:p>
+        </p:txBody>
+      </p:sp>
+      <p:sp>
+        <p:nvSpPr>
+          <p:cNvPr id="46" name="halo"/>
+          <p:cNvSpPr/>
+          <p:nvPr/>
+        </p:nvSpPr>
+        <p:spPr>
+          <a:xfrm>
+            <a:off x="9598914" y="2651760"/>
+            <a:ext cx="1463040" cy="1463040"/>
+          </a:xfrm>
+          <a:prstGeom prst="ellipse">
+            <a:avLst/>
+          </a:prstGeom>
+          <a:solidFill>
+            <a:srgbClr val="FBE2CB"/>
+          </a:solidFill>
+          <a:ln>
+            <a:noFill/>
+          </a:ln>
+        </p:spPr>
+        <p:txBody>
+          <a:bodyPr/>
+          <a:lstStyle/>
+          <a:p>
+            <a:endParaRPr lang="es-ES"/>
+          </a:p>
+        </p:txBody>
+      </p:sp>
+      <p:sp>
+        <p:nvSpPr>
+          <p:cNvPr id="47" name="badge"/>
+          <p:cNvSpPr/>
+          <p:nvPr/>
+        </p:nvSpPr>
+        <p:spPr>
+          <a:xfrm>
+            <a:off x="9736074" y="2788920"/>
+            <a:ext cx="1188720" cy="1188720"/>
+          </a:xfrm>
+          <a:prstGeom prst="ellipse">
+            <a:avLst/>
+          </a:prstGeom>
+          <a:solidFill>
+            <a:srgbClr val="E8711E"/>
+          </a:solidFill>
+          <a:ln>
+            <a:noFill/>
+          </a:ln>
+          <a:effectLst>
+            <a:outerShdw blurRad="50000" dist="25000" dir="5400000" rotWithShape="0">
+              <a:srgbClr val="000000">
+                <a:alpha val="20000"/>
+              </a:srgbClr>
+            </a:outerShdw>
+          </a:effectLst>
+        </p:spPr>
+        <p:txBody>
+          <a:bodyPr/>
+          <a:lstStyle/>
+          <a:p>
+            <a:endParaRPr lang="es-ES"/>
+          </a:p>
+        </p:txBody>
+      </p:sp>
+      <p:sp>
+        <p:nvSpPr>
+          <p:cNvPr id="48" name="awning"/>
+          <p:cNvSpPr/>
+          <p:nvPr/>
+        </p:nvSpPr>
+        <p:spPr>
+          <a:xfrm flipV="1">
+            <a:off x="10001250" y="3072384"/>
+            <a:ext cx="658368" cy="164592"/>
+          </a:xfrm>
+          <a:prstGeom prst="trapezoid">
+            <a:avLst/>
+          </a:prstGeom>
+          <a:noFill/>
+          <a:ln w="19050">
+            <a:solidFill>
+              <a:srgbClr val="FFFFFF"/>
+            </a:solidFill>
+          </a:ln>
+        </p:spPr>
+        <p:txBody>
+          <a:bodyPr/>
+          <a:lstStyle/>
+          <a:p>
+            <a:endParaRPr lang="es-ES"/>
+          </a:p>
+        </p:txBody>
+      </p:sp>
+      <p:sp>
+        <p:nvSpPr>
+          <p:cNvPr id="49" name="store"/>
+          <p:cNvSpPr/>
+          <p:nvPr/>
+        </p:nvSpPr>
+        <p:spPr>
+          <a:xfrm>
+            <a:off x="10074402" y="3236976"/>
+            <a:ext cx="512064" cy="457200"/>
+          </a:xfrm>
+          <a:prstGeom prst="rect">
+            <a:avLst/>
+          </a:prstGeom>
+          <a:noFill/>
+          <a:ln w="19050">
+            <a:solidFill>
+              <a:srgbClr val="FFFFFF"/>
+            </a:solidFill>
+          </a:ln>
+        </p:spPr>
+        <p:txBody>
+          <a:bodyPr/>
+          <a:lstStyle/>
+          <a:p>
+            <a:endParaRPr lang="es-ES"/>
+          </a:p>
+        </p:txBody>
+      </p:sp>
+      <p:sp>
+        <p:nvSpPr>
+          <p:cNvPr id="50" name="door"/>
+          <p:cNvSpPr/>
+          <p:nvPr/>
+        </p:nvSpPr>
+        <p:spPr>
+          <a:xfrm>
+            <a:off x="10248138" y="3429000"/>
+            <a:ext cx="164592" cy="265176"/>
+          </a:xfrm>
+          <a:prstGeom prst="rect">
+            <a:avLst/>
+          </a:prstGeom>
+          <a:noFill/>
+          <a:ln w="19050">
+            <a:solidFill>
+              <a:srgbClr val="FFFFFF"/>
+            </a:solidFill>
+          </a:ln>
+        </p:spPr>
+        <p:txBody>
+          <a:bodyPr/>
+          <a:lstStyle/>
+          <a:p>
+            <a:endParaRPr lang="es-ES"/>
+          </a:p>
+        </p:txBody>
+      </p:sp>
+      <p:sp>
+        <p:nvSpPr>
+          <p:cNvPr id="51" name="tb"/>
+          <p:cNvSpPr txBox="1"/>
+          <p:nvPr/>
+        </p:nvSpPr>
+        <p:spPr>
+          <a:xfrm>
+            <a:off x="9107424" y="4096512"/>
+            <a:ext cx="2446020" cy="640080"/>
+          </a:xfrm>
+          <a:prstGeom prst="rect">
+            <a:avLst/>
+          </a:prstGeom>
+          <a:noFill/>
+        </p:spPr>
+        <p:txBody>
+          <a:bodyPr wrap="square" anchor="t" lIns="73152" tIns="36576" rIns="73152" bIns="36576">
+            <a:normAutofit/>
+          </a:bodyPr>
+          <a:lstStyle/>
+          <a:p>
+            <a:pPr marL="0" indent="0" lvl="0" algn="ctr">
+              <a:lnSpc>
+                <a:spcPct val="96000"/>
+              </a:lnSpc>
+              <a:buNone/>
+            </a:pPr>
+            <a:r>
+              <a:rPr lang="es-ES" sz="1500" b="1" i="0" dirty="0">
+                <a:solidFill>
+                  <a:srgbClr val="123A5E"/>
+                </a:solidFill>
+                <a:latin typeface="Calibri"/>
+                <a:cs typeface="Calibri"/>
+              </a:rPr>
+              <a:t>Retail</a:t>
+            </a:r>
+          </a:p>
+        </p:txBody>
+      </p:sp>
+      <p:sp>
+        <p:nvSpPr>
+          <p:cNvPr id="52" name="uline"/>
+          <p:cNvSpPr/>
+          <p:nvPr/>
+        </p:nvSpPr>
+        <p:spPr>
+          <a:xfrm>
+            <a:off x="10037826" y="4681728"/>
+            <a:ext cx="585216" cy="54864"/>
+          </a:xfrm>
+          <a:prstGeom prst="roundRect">
+            <a:avLst/>
+          </a:prstGeom>
+          <a:solidFill>
+            <a:srgbClr val="E8711E"/>
+          </a:solidFill>
+          <a:ln>
+            <a:noFill/>
+          </a:ln>
+        </p:spPr>
+        <p:txBody>
+          <a:bodyPr/>
+          <a:lstStyle/>
+          <a:p>
+            <a:endParaRPr lang="es-ES"/>
+          </a:p>
+        </p:txBody>
+      </p:sp>
+      <p:sp>
+        <p:nvSpPr>
+          <p:cNvPr id="53" name="tb"/>
+          <p:cNvSpPr txBox="1"/>
+          <p:nvPr/>
+        </p:nvSpPr>
+        <p:spPr>
+          <a:xfrm>
+            <a:off x="9235440" y="4864608"/>
+            <a:ext cx="2226564" cy="1051560"/>
+          </a:xfrm>
+          <a:prstGeom prst="rect">
+            <a:avLst/>
+          </a:prstGeom>
+          <a:noFill/>
+        </p:spPr>
+        <p:txBody>
+          <a:bodyPr wrap="square" anchor="t" lIns="73152" tIns="36576" rIns="73152" bIns="36576">
+            <a:normAutofit/>
+          </a:bodyPr>
+          <a:lstStyle/>
+          <a:p>
+            <a:pPr marL="228600" indent="-228600" lvl="0" algn="l">
+              <a:lnSpc>
+                <a:spcPct val="104000"/>
+              </a:lnSpc>
+              <a:spcAft>
+                <a:spcPts val="260"/>
+              </a:spcAft>
+              <a:buClr>
+                <a:srgbClr val="E8711E"/>
+              </a:buClr>
+              <a:buFont typeface="Arial"/>
+              <a:buChar char="▸"/>
+            </a:pPr>
+            <a:r>
+              <a:rPr lang="es-ES" sz="1200" b="0" i="0" dirty="0">
+                <a:solidFill>
+                  <a:srgbClr val="333333"/>
+                </a:solidFill>
+                <a:latin typeface="Calibri"/>
+                <a:cs typeface="Calibri"/>
+              </a:rPr>
+              <a:t>Venta limitada al stock de cada tienda.</a:t>
+            </a:r>
+          </a:p>
+          <a:p>
+            <a:pPr marL="228600" indent="-228600" lvl="0" algn="l">
+              <a:lnSpc>
+                <a:spcPct val="104000"/>
+              </a:lnSpc>
+              <a:spcAft>
+                <a:spcPts val="260"/>
+              </a:spcAft>
+              <a:buClr>
+                <a:srgbClr val="E8711E"/>
+              </a:buClr>
+              <a:buFont typeface="Arial"/>
+              <a:buChar char="▸"/>
             </a:pPr>
             <a:r>
               <a:rPr lang="es-ES" sz="1200" b="0" i="0" dirty="0">

</xml_diff>

<commit_message>
Agrega lamina de Analisis Economico (reprocesos de despacho)
</commit_message>
<xml_diff>
--- a/Transformacion_Omnicanal_Ultima_Milla.pptx
+++ b/Transformacion_Omnicanal_Ultima_Milla.pptx
@@ -11,6 +11,7 @@
     <p:sldId id="259" r:id="rId5"/>
     <p:sldId id="260" r:id="rId6"/>
     <p:sldId id="261" r:id="rId7"/>
+    <p:sldId id="262" r:id="rId8"/>
   </p:sldIdLst>
   <p:sldSz cx="12192000" cy="6858000" type="screen16x9"/>
   <p:notesSz cx="6858000" cy="9144000"/>
@@ -5532,7 +5533,7 @@
                 <a:latin typeface="Calibri"/>
                 <a:cs typeface="Calibri"/>
               </a:rPr>
-              <a:t>HOJA DE RUTA DEL PROGRAMA</a:t>
+              <a:t>BENEFICIO DE LA GESTION CON AGENTE IA</a:t>
             </a:r>
           </a:p>
         </p:txBody>
@@ -5570,7 +5571,7 @@
                 <a:latin typeface="Calibri"/>
                 <a:cs typeface="Calibri"/>
               </a:rPr>
-              <a:t>Roadmap</a:t>
+              <a:t>Analisis Economico  ·  Reprocesos de Despacho</a:t>
             </a:r>
           </a:p>
         </p:txBody>
@@ -5649,20 +5650,20 @@
       </p:sp>
       <p:sp>
         <p:nvSpPr>
-          <p:cNvPr id="9" name="sp"/>
-          <p:cNvSpPr/>
-          <p:nvPr/>
-        </p:nvSpPr>
-        <p:spPr>
-          <a:xfrm>
-            <a:off x="822960" y="3429000"/>
-            <a:ext cx="10515600" cy="45720"/>
-          </a:xfrm>
-          <a:prstGeom prst="rect">
-            <a:avLst/>
-          </a:prstGeom>
-          <a:solidFill>
-            <a:srgbClr val="DCDCDC"/>
+          <p:cNvPr id="9" name="supuestos"/>
+          <p:cNvSpPr/>
+          <p:nvPr/>
+        </p:nvSpPr>
+        <p:spPr>
+          <a:xfrm>
+            <a:off x="566928" y="1371600"/>
+            <a:ext cx="11064240" cy="713232"/>
+          </a:xfrm>
+          <a:prstGeom prst="roundRect">
+            <a:avLst/>
+          </a:prstGeom>
+          <a:solidFill>
+            <a:srgbClr val="262626"/>
           </a:solidFill>
           <a:ln>
             <a:noFill/>
@@ -5684,51 +5685,85 @@
         </p:nvSpPr>
         <p:spPr>
           <a:xfrm>
-            <a:off x="1584960" y="3218688"/>
-            <a:ext cx="457200" cy="457200"/>
-          </a:xfrm>
-          <a:prstGeom prst="ellipse">
-            <a:avLst/>
-          </a:prstGeom>
-          <a:solidFill>
-            <a:srgbClr val="123A5E"/>
+            <a:off x="566928" y="1371600"/>
+            <a:ext cx="109728" cy="713232"/>
+          </a:xfrm>
+          <a:prstGeom prst="rect">
+            <a:avLst/>
+          </a:prstGeom>
+          <a:solidFill>
+            <a:srgbClr val="E8711E"/>
           </a:solidFill>
           <a:ln>
             <a:noFill/>
           </a:ln>
         </p:spPr>
         <p:txBody>
+          <a:bodyPr/>
+          <a:lstStyle/>
+          <a:p>
+            <a:endParaRPr lang="es-ES"/>
+          </a:p>
+        </p:txBody>
+      </p:sp>
+      <p:sp>
+        <p:nvSpPr>
+          <p:cNvPr id="11" name="tb"/>
+          <p:cNvSpPr txBox="1"/>
+          <p:nvPr/>
+        </p:nvSpPr>
+        <p:spPr>
+          <a:xfrm>
+            <a:off x="868680" y="1408176"/>
+            <a:ext cx="10607040" cy="502920"/>
+          </a:xfrm>
+          <a:prstGeom prst="rect">
+            <a:avLst/>
+          </a:prstGeom>
+          <a:noFill/>
+        </p:spPr>
+        <p:txBody>
           <a:bodyPr wrap="square" anchor="ctr" lIns="73152" tIns="36576" rIns="73152" bIns="36576">
             <a:normAutofit/>
           </a:bodyPr>
           <a:lstStyle/>
           <a:p>
-            <a:pPr marL="0" indent="0" lvl="0" algn="ctr">
-              <a:buNone/>
-            </a:pPr>
-            <a:r>
-              <a:rPr lang="es-ES" sz="1500" b="1" i="0" dirty="0">
-                <a:solidFill>
-                  <a:srgbClr val="FFFFFF"/>
-                </a:solidFill>
-                <a:latin typeface="Calibri"/>
-                <a:cs typeface="Calibri"/>
-              </a:rPr>
-              <a:t>✓</a:t>
-            </a:r>
-          </a:p>
-        </p:txBody>
-      </p:sp>
-      <p:sp>
-        <p:nvSpPr>
-          <p:cNvPr id="11" name="sp"/>
-          <p:cNvSpPr/>
-          <p:nvPr/>
-        </p:nvSpPr>
-        <p:spPr>
-          <a:xfrm>
-            <a:off x="1051560" y="1737360"/>
-            <a:ext cx="1524000" cy="1371600"/>
+            <a:pPr marL="0" indent="0" lvl="0" algn="l">
+              <a:buNone/>
+            </a:pPr>
+            <a:r>
+              <a:rPr lang="es-ES" sz="1000" b="1" i="0" spc="120" dirty="0">
+                <a:solidFill>
+                  <a:srgbClr val="E8711E"/>
+                </a:solidFill>
+                <a:latin typeface="Calibri"/>
+                <a:cs typeface="Calibri"/>
+              </a:rPr>
+              <a:t>SUPUESTOS   </a:t>
+            </a:r>
+            <a:r>
+              <a:rPr lang="es-ES" sz="1000" b="0" i="0" dirty="0">
+                <a:solidFill>
+                  <a:srgbClr val="E6EDF3"/>
+                </a:solidFill>
+                <a:latin typeface="Calibri"/>
+                <a:cs typeface="Calibri"/>
+              </a:rPr>
+              <a:t>1.051 despachos fallidos/mes  ·  75% atacable (788/mes)  ·  80% de los retornos genera redespacho  ·  costo redespacho $3.467  ·  TC $950/USD  ·  Agente IA USD 1.500/mes  ·  Normalizacion 40 HHEE x $7.533</a:t>
+            </a:r>
+          </a:p>
+        </p:txBody>
+      </p:sp>
+      <p:sp>
+        <p:nvSpPr>
+          <p:cNvPr id="12" name="sp"/>
+          <p:cNvSpPr/>
+          <p:nvPr/>
+        </p:nvSpPr>
+        <p:spPr>
+          <a:xfrm>
+            <a:off x="566928" y="2212848"/>
+            <a:ext cx="3593592" cy="877824"/>
           </a:xfrm>
           <a:prstGeom prst="roundRect">
             <a:avLst/>
@@ -5759,99 +5794,20 @@
       </p:sp>
       <p:sp>
         <p:nvSpPr>
-          <p:cNvPr id="12" name="tb"/>
-          <p:cNvSpPr txBox="1"/>
-          <p:nvPr/>
-        </p:nvSpPr>
-        <p:spPr>
-          <a:xfrm>
-            <a:off x="1051560" y="1865376"/>
-            <a:ext cx="1524000" cy="365760"/>
-          </a:xfrm>
-          <a:prstGeom prst="rect">
-            <a:avLst/>
-          </a:prstGeom>
-          <a:noFill/>
-        </p:spPr>
-        <p:txBody>
-          <a:bodyPr wrap="square" anchor="t" lIns="73152" tIns="36576" rIns="73152" bIns="36576">
-            <a:normAutofit/>
-          </a:bodyPr>
-          <a:lstStyle/>
-          <a:p>
-            <a:pPr marL="0" indent="0" lvl="0" algn="ctr">
-              <a:buNone/>
-            </a:pPr>
-            <a:r>
-              <a:rPr lang="es-ES" sz="1050" b="1" i="0" dirty="0">
-                <a:solidFill>
-                  <a:srgbClr val="123A5E"/>
-                </a:solidFill>
-                <a:latin typeface="Calibri"/>
-                <a:cs typeface="Calibri"/>
-              </a:rPr>
-              <a:t>MAY - JUN</a:t>
-            </a:r>
-          </a:p>
-        </p:txBody>
-      </p:sp>
-      <p:sp>
-        <p:nvSpPr>
-          <p:cNvPr id="13" name="tb"/>
-          <p:cNvSpPr txBox="1"/>
-          <p:nvPr/>
-        </p:nvSpPr>
-        <p:spPr>
-          <a:xfrm>
-            <a:off x="1106424" y="2212848"/>
-            <a:ext cx="1414272" cy="822960"/>
-          </a:xfrm>
-          <a:prstGeom prst="rect">
-            <a:avLst/>
-          </a:prstGeom>
-          <a:noFill/>
-        </p:spPr>
-        <p:txBody>
-          <a:bodyPr wrap="square" anchor="t" lIns="73152" tIns="36576" rIns="73152" bIns="36576">
-            <a:normAutofit/>
-          </a:bodyPr>
-          <a:lstStyle/>
-          <a:p>
-            <a:pPr marL="0" indent="0" lvl="0" algn="ctr">
-              <a:lnSpc>
-                <a:spcPct val="98000"/>
-              </a:lnSpc>
-              <a:buNone/>
-            </a:pPr>
-            <a:r>
-              <a:rPr lang="es-ES" sz="1150" b="0" i="0" dirty="0">
-                <a:solidFill>
-                  <a:srgbClr val="333333"/>
-                </a:solidFill>
-                <a:latin typeface="Calibri"/>
-                <a:cs typeface="Calibri"/>
-              </a:rPr>
-              <a:t>Evaluacion IA SimpliRoute</a:t>
-            </a:r>
-          </a:p>
-        </p:txBody>
-      </p:sp>
-      <p:sp>
-        <p:nvSpPr>
-          <p:cNvPr id="14" name="sp"/>
-          <p:cNvSpPr/>
-          <p:nvPr/>
-        </p:nvSpPr>
-        <p:spPr>
-          <a:xfrm>
-            <a:off x="1804416" y="3108960"/>
-            <a:ext cx="18288" cy="320040"/>
-          </a:xfrm>
-          <a:prstGeom prst="rect">
-            <a:avLst/>
-          </a:prstGeom>
-          <a:solidFill>
-            <a:srgbClr val="123A5E"/>
+          <p:cNvPr id="13" name="sp"/>
+          <p:cNvSpPr/>
+          <p:nvPr/>
+        </p:nvSpPr>
+        <p:spPr>
+          <a:xfrm>
+            <a:off x="566928" y="2212848"/>
+            <a:ext cx="109728" cy="877824"/>
+          </a:xfrm>
+          <a:prstGeom prst="rect">
+            <a:avLst/>
+          </a:prstGeom>
+          <a:solidFill>
+            <a:srgbClr val="E8711E"/>
           </a:solidFill>
           <a:ln>
             <a:noFill/>
@@ -5867,73 +5823,115 @@
       </p:sp>
       <p:sp>
         <p:nvSpPr>
-          <p:cNvPr id="15" name="sp"/>
-          <p:cNvSpPr/>
-          <p:nvPr/>
-        </p:nvSpPr>
-        <p:spPr>
-          <a:xfrm>
-            <a:off x="3291840" y="3218688"/>
-            <a:ext cx="457200" cy="457200"/>
-          </a:xfrm>
-          <a:prstGeom prst="ellipse">
-            <a:avLst/>
-          </a:prstGeom>
-          <a:solidFill>
-            <a:srgbClr val="123A5E"/>
-          </a:solidFill>
-          <a:ln>
-            <a:noFill/>
-          </a:ln>
-        </p:spPr>
-        <p:txBody>
-          <a:bodyPr wrap="square" anchor="ctr" lIns="73152" tIns="36576" rIns="73152" bIns="36576">
-            <a:normAutofit/>
-          </a:bodyPr>
-          <a:lstStyle/>
-          <a:p>
-            <a:pPr marL="0" indent="0" lvl="0" algn="ctr">
-              <a:buNone/>
-            </a:pPr>
-            <a:r>
-              <a:rPr lang="es-ES" sz="1500" b="1" i="0" dirty="0">
-                <a:solidFill>
-                  <a:srgbClr val="FFFFFF"/>
-                </a:solidFill>
-                <a:latin typeface="Calibri"/>
-                <a:cs typeface="Calibri"/>
-              </a:rPr>
-              <a:t>✓</a:t>
-            </a:r>
-          </a:p>
-        </p:txBody>
-      </p:sp>
-      <p:sp>
-        <p:nvSpPr>
-          <p:cNvPr id="16" name="sp"/>
-          <p:cNvSpPr/>
-          <p:nvPr/>
-        </p:nvSpPr>
-        <p:spPr>
-          <a:xfrm>
-            <a:off x="3511296" y="3429000"/>
-            <a:ext cx="18288" cy="320040"/>
-          </a:xfrm>
-          <a:prstGeom prst="rect">
-            <a:avLst/>
-          </a:prstGeom>
-          <a:solidFill>
-            <a:srgbClr val="123A5E"/>
-          </a:solidFill>
-          <a:ln>
-            <a:noFill/>
-          </a:ln>
-        </p:spPr>
-        <p:txBody>
-          <a:bodyPr/>
-          <a:lstStyle/>
-          <a:p>
-            <a:endParaRPr lang="es-ES"/>
+          <p:cNvPr id="14" name="tb"/>
+          <p:cNvSpPr txBox="1"/>
+          <p:nvPr/>
+        </p:nvSpPr>
+        <p:spPr>
+          <a:xfrm>
+            <a:off x="841248" y="2304288"/>
+            <a:ext cx="3182112" cy="292608"/>
+          </a:xfrm>
+          <a:prstGeom prst="rect">
+            <a:avLst/>
+          </a:prstGeom>
+          <a:noFill/>
+        </p:spPr>
+        <p:txBody>
+          <a:bodyPr wrap="square" anchor="t" lIns="73152" tIns="36576" rIns="73152" bIns="36576">
+            <a:normAutofit/>
+          </a:bodyPr>
+          <a:lstStyle/>
+          <a:p>
+            <a:pPr marL="0" indent="0" lvl="0" algn="l">
+              <a:buNone/>
+            </a:pPr>
+            <a:r>
+              <a:rPr lang="es-ES" sz="900" b="1" i="0" spc="80" dirty="0">
+                <a:solidFill>
+                  <a:srgbClr val="6B6B6B"/>
+                </a:solidFill>
+                <a:latin typeface="Calibri"/>
+                <a:cs typeface="Calibri"/>
+              </a:rPr>
+              <a:t>REDESPACHOS ATACABLES</a:t>
+            </a:r>
+          </a:p>
+        </p:txBody>
+      </p:sp>
+      <p:sp>
+        <p:nvSpPr>
+          <p:cNvPr id="15" name="tb"/>
+          <p:cNvSpPr txBox="1"/>
+          <p:nvPr/>
+        </p:nvSpPr>
+        <p:spPr>
+          <a:xfrm>
+            <a:off x="822960" y="2560320"/>
+            <a:ext cx="3182112" cy="457200"/>
+          </a:xfrm>
+          <a:prstGeom prst="rect">
+            <a:avLst/>
+          </a:prstGeom>
+          <a:noFill/>
+        </p:spPr>
+        <p:txBody>
+          <a:bodyPr wrap="square" anchor="t" lIns="73152" tIns="36576" rIns="73152" bIns="36576">
+            <a:normAutofit/>
+          </a:bodyPr>
+          <a:lstStyle/>
+          <a:p>
+            <a:pPr marL="0" indent="0" lvl="0" algn="l">
+              <a:buNone/>
+            </a:pPr>
+            <a:r>
+              <a:rPr lang="es-ES" sz="2400" b="1" i="0" dirty="0">
+                <a:solidFill>
+                  <a:srgbClr val="E8711E"/>
+                </a:solidFill>
+                <a:latin typeface="Calibri"/>
+                <a:cs typeface="Calibri"/>
+              </a:rPr>
+              <a:t>$26.235.482</a:t>
+            </a:r>
+          </a:p>
+        </p:txBody>
+      </p:sp>
+      <p:sp>
+        <p:nvSpPr>
+          <p:cNvPr id="16" name="tb"/>
+          <p:cNvSpPr txBox="1"/>
+          <p:nvPr/>
+        </p:nvSpPr>
+        <p:spPr>
+          <a:xfrm>
+            <a:off x="859536" y="2926080"/>
+            <a:ext cx="3182112" cy="274320"/>
+          </a:xfrm>
+          <a:prstGeom prst="rect">
+            <a:avLst/>
+          </a:prstGeom>
+          <a:noFill/>
+        </p:spPr>
+        <p:txBody>
+          <a:bodyPr wrap="square" anchor="t" lIns="73152" tIns="36576" rIns="73152" bIns="36576">
+            <a:normAutofit/>
+          </a:bodyPr>
+          <a:lstStyle/>
+          <a:p>
+            <a:pPr marL="0" indent="0" lvl="0" algn="l">
+              <a:buNone/>
+            </a:pPr>
+            <a:r>
+              <a:rPr lang="es-ES" sz="950" b="0" i="0" dirty="0">
+                <a:solidFill>
+                  <a:srgbClr val="333333"/>
+                </a:solidFill>
+                <a:latin typeface="Calibri"/>
+                <a:cs typeface="Calibri"/>
+              </a:rPr>
+              <a:t>CLP / ano (ahorro potencial)</a:t>
+            </a:r>
           </a:p>
         </p:txBody>
       </p:sp>
@@ -5945,8 +5943,8 @@
         </p:nvSpPr>
         <p:spPr>
           <a:xfrm>
-            <a:off x="2758440" y="3749040"/>
-            <a:ext cx="1524000" cy="1371600"/>
+            <a:off x="4347972" y="2212848"/>
+            <a:ext cx="3593592" cy="877824"/>
           </a:xfrm>
           <a:prstGeom prst="roundRect">
             <a:avLst/>
@@ -5977,39 +5975,30 @@
       </p:sp>
       <p:sp>
         <p:nvSpPr>
-          <p:cNvPr id="18" name="tb"/>
-          <p:cNvSpPr txBox="1"/>
-          <p:nvPr/>
-        </p:nvSpPr>
-        <p:spPr>
-          <a:xfrm>
-            <a:off x="2758440" y="3877056"/>
-            <a:ext cx="1524000" cy="365760"/>
-          </a:xfrm>
-          <a:prstGeom prst="rect">
-            <a:avLst/>
-          </a:prstGeom>
-          <a:noFill/>
-        </p:spPr>
-        <p:txBody>
-          <a:bodyPr wrap="square" anchor="t" lIns="73152" tIns="36576" rIns="73152" bIns="36576">
-            <a:normAutofit/>
-          </a:bodyPr>
-          <a:lstStyle/>
-          <a:p>
-            <a:pPr marL="0" indent="0" lvl="0" algn="ctr">
-              <a:buNone/>
-            </a:pPr>
-            <a:r>
-              <a:rPr lang="es-ES" sz="1050" b="1" i="0" dirty="0">
-                <a:solidFill>
-                  <a:srgbClr val="123A5E"/>
-                </a:solidFill>
-                <a:latin typeface="Calibri"/>
-                <a:cs typeface="Calibri"/>
-              </a:rPr>
-              <a:t>JUNIO</a:t>
-            </a:r>
+          <p:cNvPr id="18" name="sp"/>
+          <p:cNvSpPr/>
+          <p:nvPr/>
+        </p:nvSpPr>
+        <p:spPr>
+          <a:xfrm>
+            <a:off x="4347972" y="2212848"/>
+            <a:ext cx="109728" cy="877824"/>
+          </a:xfrm>
+          <a:prstGeom prst="rect">
+            <a:avLst/>
+          </a:prstGeom>
+          <a:solidFill>
+            <a:srgbClr val="123A5E"/>
+          </a:solidFill>
+          <a:ln>
+            <a:noFill/>
+          </a:ln>
+        </p:spPr>
+        <p:txBody>
+          <a:bodyPr/>
+          <a:lstStyle/>
+          <a:p>
+            <a:endParaRPr lang="es-ES"/>
           </a:p>
         </p:txBody>
       </p:sp>
@@ -6021,8 +6010,8 @@
         </p:nvSpPr>
         <p:spPr>
           <a:xfrm>
-            <a:off x="2813304" y="4224528"/>
-            <a:ext cx="1414272" cy="822960"/>
+            <a:off x="4622292" y="2304288"/>
+            <a:ext cx="3182112" cy="292608"/>
           </a:xfrm>
           <a:prstGeom prst="rect">
             <a:avLst/>
@@ -6035,78 +6024,108 @@
           </a:bodyPr>
           <a:lstStyle/>
           <a:p>
-            <a:pPr marL="0" indent="0" lvl="0" algn="ctr">
-              <a:lnSpc>
-                <a:spcPct val="98000"/>
-              </a:lnSpc>
-              <a:buNone/>
-            </a:pPr>
-            <a:r>
-              <a:rPr lang="es-ES" sz="1150" b="0" i="0" dirty="0">
+            <a:pPr marL="0" indent="0" lvl="0" algn="l">
+              <a:buNone/>
+            </a:pPr>
+            <a:r>
+              <a:rPr lang="es-ES" sz="900" b="1" i="0" spc="80" dirty="0">
+                <a:solidFill>
+                  <a:srgbClr val="6B6B6B"/>
+                </a:solidFill>
+                <a:latin typeface="Calibri"/>
+                <a:cs typeface="Calibri"/>
+              </a:rPr>
+              <a:t>INVERSION AGENTE IA</a:t>
+            </a:r>
+          </a:p>
+        </p:txBody>
+      </p:sp>
+      <p:sp>
+        <p:nvSpPr>
+          <p:cNvPr id="20" name="tb"/>
+          <p:cNvSpPr txBox="1"/>
+          <p:nvPr/>
+        </p:nvSpPr>
+        <p:spPr>
+          <a:xfrm>
+            <a:off x="4604004" y="2560320"/>
+            <a:ext cx="3182112" cy="457200"/>
+          </a:xfrm>
+          <a:prstGeom prst="rect">
+            <a:avLst/>
+          </a:prstGeom>
+          <a:noFill/>
+        </p:spPr>
+        <p:txBody>
+          <a:bodyPr wrap="square" anchor="t" lIns="73152" tIns="36576" rIns="73152" bIns="36576">
+            <a:normAutofit/>
+          </a:bodyPr>
+          <a:lstStyle/>
+          <a:p>
+            <a:pPr marL="0" indent="0" lvl="0" algn="l">
+              <a:buNone/>
+            </a:pPr>
+            <a:r>
+              <a:rPr lang="es-ES" sz="2400" b="1" i="0" dirty="0">
+                <a:solidFill>
+                  <a:srgbClr val="123A5E"/>
+                </a:solidFill>
+                <a:latin typeface="Calibri"/>
+                <a:cs typeface="Calibri"/>
+              </a:rPr>
+              <a:t>$17.100.000</a:t>
+            </a:r>
+          </a:p>
+        </p:txBody>
+      </p:sp>
+      <p:sp>
+        <p:nvSpPr>
+          <p:cNvPr id="21" name="tb"/>
+          <p:cNvSpPr txBox="1"/>
+          <p:nvPr/>
+        </p:nvSpPr>
+        <p:spPr>
+          <a:xfrm>
+            <a:off x="4640580" y="2926080"/>
+            <a:ext cx="3182112" cy="274320"/>
+          </a:xfrm>
+          <a:prstGeom prst="rect">
+            <a:avLst/>
+          </a:prstGeom>
+          <a:noFill/>
+        </p:spPr>
+        <p:txBody>
+          <a:bodyPr wrap="square" anchor="t" lIns="73152" tIns="36576" rIns="73152" bIns="36576">
+            <a:normAutofit/>
+          </a:bodyPr>
+          <a:lstStyle/>
+          <a:p>
+            <a:pPr marL="0" indent="0" lvl="0" algn="l">
+              <a:buNone/>
+            </a:pPr>
+            <a:r>
+              <a:rPr lang="es-ES" sz="950" b="0" i="0" dirty="0">
                 <a:solidFill>
                   <a:srgbClr val="333333"/>
                 </a:solidFill>
                 <a:latin typeface="Calibri"/>
                 <a:cs typeface="Calibri"/>
               </a:rPr>
-              <a:t>Correccion masiva base de clientes</a:t>
-            </a:r>
-          </a:p>
-        </p:txBody>
-      </p:sp>
-      <p:sp>
-        <p:nvSpPr>
-          <p:cNvPr id="20" name="sp"/>
-          <p:cNvSpPr/>
-          <p:nvPr/>
-        </p:nvSpPr>
-        <p:spPr>
-          <a:xfrm>
-            <a:off x="4998720" y="3218688"/>
-            <a:ext cx="457200" cy="457200"/>
-          </a:xfrm>
-          <a:prstGeom prst="ellipse">
-            <a:avLst/>
-          </a:prstGeom>
-          <a:solidFill>
-            <a:srgbClr val="1C5A8C"/>
-          </a:solidFill>
-          <a:ln>
-            <a:noFill/>
-          </a:ln>
-        </p:spPr>
-        <p:txBody>
-          <a:bodyPr wrap="square" anchor="ctr" lIns="73152" tIns="36576" rIns="73152" bIns="36576">
-            <a:normAutofit/>
-          </a:bodyPr>
-          <a:lstStyle/>
-          <a:p>
-            <a:pPr marL="0" indent="0" lvl="0" algn="ctr">
-              <a:buNone/>
-            </a:pPr>
-            <a:r>
-              <a:rPr lang="es-ES" sz="1500" b="1" i="0" dirty="0">
-                <a:solidFill>
-                  <a:srgbClr val="FFFFFF"/>
-                </a:solidFill>
-                <a:latin typeface="Calibri"/>
-                <a:cs typeface="Calibri"/>
-              </a:rPr>
-              <a:t>✓</a:t>
-            </a:r>
-          </a:p>
-        </p:txBody>
-      </p:sp>
-      <p:sp>
-        <p:nvSpPr>
-          <p:cNvPr id="21" name="sp"/>
-          <p:cNvSpPr/>
-          <p:nvPr/>
-        </p:nvSpPr>
-        <p:spPr>
-          <a:xfrm>
-            <a:off x="4465320" y="1737360"/>
-            <a:ext cx="1524000" cy="1371600"/>
+              <a:t>CLP / ano (recurrente)</a:t>
+            </a:r>
+          </a:p>
+        </p:txBody>
+      </p:sp>
+      <p:sp>
+        <p:nvSpPr>
+          <p:cNvPr id="22" name="sp"/>
+          <p:cNvSpPr/>
+          <p:nvPr/>
+        </p:nvSpPr>
+        <p:spPr>
+          <a:xfrm>
+            <a:off x="8129016" y="2212848"/>
+            <a:ext cx="3593592" cy="877824"/>
           </a:xfrm>
           <a:prstGeom prst="roundRect">
             <a:avLst/>
@@ -6137,14 +6156,43 @@
       </p:sp>
       <p:sp>
         <p:nvSpPr>
-          <p:cNvPr id="22" name="tb"/>
+          <p:cNvPr id="23" name="sp"/>
+          <p:cNvSpPr/>
+          <p:nvPr/>
+        </p:nvSpPr>
+        <p:spPr>
+          <a:xfrm>
+            <a:off x="8129016" y="2212848"/>
+            <a:ext cx="109728" cy="877824"/>
+          </a:xfrm>
+          <a:prstGeom prst="rect">
+            <a:avLst/>
+          </a:prstGeom>
+          <a:solidFill>
+            <a:srgbClr val="123A5E"/>
+          </a:solidFill>
+          <a:ln>
+            <a:noFill/>
+          </a:ln>
+        </p:spPr>
+        <p:txBody>
+          <a:bodyPr/>
+          <a:lstStyle/>
+          <a:p>
+            <a:endParaRPr lang="es-ES"/>
+          </a:p>
+        </p:txBody>
+      </p:sp>
+      <p:sp>
+        <p:nvSpPr>
+          <p:cNvPr id="24" name="tb"/>
           <p:cNvSpPr txBox="1"/>
           <p:nvPr/>
         </p:nvSpPr>
         <p:spPr>
           <a:xfrm>
-            <a:off x="4465320" y="1865376"/>
-            <a:ext cx="1524000" cy="365760"/>
+            <a:off x="8403336" y="2304288"/>
+            <a:ext cx="3182112" cy="292608"/>
           </a:xfrm>
           <a:prstGeom prst="rect">
             <a:avLst/>
@@ -6157,32 +6205,32 @@
           </a:bodyPr>
           <a:lstStyle/>
           <a:p>
-            <a:pPr marL="0" indent="0" lvl="0" algn="ctr">
-              <a:buNone/>
-            </a:pPr>
-            <a:r>
-              <a:rPr lang="es-ES" sz="1050" b="1" i="0" dirty="0">
-                <a:solidFill>
-                  <a:srgbClr val="1C5A8C"/>
-                </a:solidFill>
-                <a:latin typeface="Calibri"/>
-                <a:cs typeface="Calibri"/>
-              </a:rPr>
-              <a:t>JUN - JUL</a:t>
-            </a:r>
-          </a:p>
-        </p:txBody>
-      </p:sp>
-      <p:sp>
-        <p:nvSpPr>
-          <p:cNvPr id="23" name="tb"/>
+            <a:pPr marL="0" indent="0" lvl="0" algn="l">
+              <a:buNone/>
+            </a:pPr>
+            <a:r>
+              <a:rPr lang="es-ES" sz="900" b="1" i="0" spc="80" dirty="0">
+                <a:solidFill>
+                  <a:srgbClr val="6B6B6B"/>
+                </a:solidFill>
+                <a:latin typeface="Calibri"/>
+                <a:cs typeface="Calibri"/>
+              </a:rPr>
+              <a:t>NORMALIZACION (UNICA)</a:t>
+            </a:r>
+          </a:p>
+        </p:txBody>
+      </p:sp>
+      <p:sp>
+        <p:nvSpPr>
+          <p:cNvPr id="25" name="tb"/>
           <p:cNvSpPr txBox="1"/>
           <p:nvPr/>
         </p:nvSpPr>
         <p:spPr>
           <a:xfrm>
-            <a:off x="4520184" y="2212848"/>
-            <a:ext cx="1414272" cy="822960"/>
+            <a:off x="8385048" y="2560320"/>
+            <a:ext cx="3182112" cy="457200"/>
           </a:xfrm>
           <a:prstGeom prst="rect">
             <a:avLst/>
@@ -6191,77 +6239,219 @@
         </p:spPr>
         <p:txBody>
           <a:bodyPr wrap="square" anchor="t" lIns="73152" tIns="36576" rIns="73152" bIns="36576">
+            <a:normAutofit/>
+          </a:bodyPr>
+          <a:lstStyle/>
+          <a:p>
+            <a:pPr marL="0" indent="0" lvl="0" algn="l">
+              <a:buNone/>
+            </a:pPr>
+            <a:r>
+              <a:rPr lang="es-ES" sz="2400" b="1" i="0" dirty="0">
+                <a:solidFill>
+                  <a:srgbClr val="123A5E"/>
+                </a:solidFill>
+                <a:latin typeface="Calibri"/>
+                <a:cs typeface="Calibri"/>
+              </a:rPr>
+              <a:t>$301.320</a:t>
+            </a:r>
+          </a:p>
+        </p:txBody>
+      </p:sp>
+      <p:sp>
+        <p:nvSpPr>
+          <p:cNvPr id="26" name="tb"/>
+          <p:cNvSpPr txBox="1"/>
+          <p:nvPr/>
+        </p:nvSpPr>
+        <p:spPr>
+          <a:xfrm>
+            <a:off x="8421624" y="2926080"/>
+            <a:ext cx="3182112" cy="274320"/>
+          </a:xfrm>
+          <a:prstGeom prst="rect">
+            <a:avLst/>
+          </a:prstGeom>
+          <a:noFill/>
+        </p:spPr>
+        <p:txBody>
+          <a:bodyPr wrap="square" anchor="t" lIns="73152" tIns="36576" rIns="73152" bIns="36576">
+            <a:normAutofit/>
+          </a:bodyPr>
+          <a:lstStyle/>
+          <a:p>
+            <a:pPr marL="0" indent="0" lvl="0" algn="l">
+              <a:buNone/>
+            </a:pPr>
+            <a:r>
+              <a:rPr lang="es-ES" sz="950" b="0" i="0" dirty="0">
+                <a:solidFill>
+                  <a:srgbClr val="333333"/>
+                </a:solidFill>
+                <a:latin typeface="Calibri"/>
+                <a:cs typeface="Calibri"/>
+              </a:rPr>
+              <a:t>40 HHEE x $7.533</a:t>
+            </a:r>
+          </a:p>
+        </p:txBody>
+      </p:sp>
+      <p:sp>
+        <p:nvSpPr>
+          <p:cNvPr id="27" name="tb"/>
+          <p:cNvSpPr txBox="1"/>
+          <p:nvPr/>
+        </p:nvSpPr>
+        <p:spPr>
+          <a:xfrm>
+            <a:off x="566928" y="3200400"/>
+            <a:ext cx="11064240" cy="320040"/>
+          </a:xfrm>
+          <a:prstGeom prst="rect">
+            <a:avLst/>
+          </a:prstGeom>
+          <a:noFill/>
+        </p:spPr>
+        <p:txBody>
+          <a:bodyPr wrap="square" anchor="t" lIns="73152" tIns="36576" rIns="73152" bIns="36576">
+            <a:normAutofit/>
+          </a:bodyPr>
+          <a:lstStyle/>
+          <a:p>
+            <a:pPr marL="0" indent="0" lvl="0" algn="l">
+              <a:buNone/>
+            </a:pPr>
+            <a:r>
+              <a:rPr lang="es-ES" sz="1300" b="1" i="0" dirty="0">
+                <a:solidFill>
+                  <a:srgbClr val="123A5E"/>
+                </a:solidFill>
+                <a:latin typeface="Calibri"/>
+                <a:cs typeface="Calibri"/>
+              </a:rPr>
+              <a:t>Beneficio economico segun la efectividad del Agente IA (CLP)</a:t>
+            </a:r>
+          </a:p>
+        </p:txBody>
+      </p:sp>
+      <p:sp>
+        <p:nvSpPr>
+          <p:cNvPr id="28" name="th"/>
+          <p:cNvSpPr/>
+          <p:nvPr/>
+        </p:nvSpPr>
+        <p:spPr>
+          <a:xfrm>
+            <a:off x="566928" y="3584448"/>
+            <a:ext cx="2057400" cy="457200"/>
+          </a:xfrm>
+          <a:prstGeom prst="rect">
+            <a:avLst/>
+          </a:prstGeom>
+          <a:solidFill>
+            <a:srgbClr val="123A5E"/>
+          </a:solidFill>
+          <a:ln w="6350">
+            <a:solidFill>
+              <a:srgbClr val="FFFFFF"/>
+            </a:solidFill>
+          </a:ln>
+        </p:spPr>
+        <p:txBody>
+          <a:bodyPr wrap="square" anchor="ctr" lIns="73152" tIns="36576" rIns="73152" bIns="36576">
+            <a:normAutofit/>
+          </a:bodyPr>
+          <a:lstStyle/>
+          <a:p>
+            <a:pPr marL="0" indent="0" lvl="0" algn="l">
+              <a:lnSpc>
+                <a:spcPct val="92000"/>
+              </a:lnSpc>
+              <a:buNone/>
+            </a:pPr>
+            <a:r>
+              <a:rPr lang="es-ES" sz="900" b="1" i="0" dirty="0">
+                <a:solidFill>
+                  <a:srgbClr val="FFFFFF"/>
+                </a:solidFill>
+                <a:latin typeface="Calibri"/>
+                <a:cs typeface="Calibri"/>
+              </a:rPr>
+              <a:t>Escenario</a:t>
+            </a:r>
+          </a:p>
+        </p:txBody>
+      </p:sp>
+      <p:sp>
+        <p:nvSpPr>
+          <p:cNvPr id="29" name="th"/>
+          <p:cNvSpPr/>
+          <p:nvPr/>
+        </p:nvSpPr>
+        <p:spPr>
+          <a:xfrm>
+            <a:off x="2624328" y="3584448"/>
+            <a:ext cx="1417320" cy="457200"/>
+          </a:xfrm>
+          <a:prstGeom prst="rect">
+            <a:avLst/>
+          </a:prstGeom>
+          <a:solidFill>
+            <a:srgbClr val="123A5E"/>
+          </a:solidFill>
+          <a:ln w="6350">
+            <a:solidFill>
+              <a:srgbClr val="FFFFFF"/>
+            </a:solidFill>
+          </a:ln>
+        </p:spPr>
+        <p:txBody>
+          <a:bodyPr wrap="square" anchor="ctr" lIns="73152" tIns="36576" rIns="73152" bIns="36576">
             <a:normAutofit/>
           </a:bodyPr>
           <a:lstStyle/>
           <a:p>
             <a:pPr marL="0" indent="0" lvl="0" algn="ctr">
               <a:lnSpc>
-                <a:spcPct val="98000"/>
+                <a:spcPct val="92000"/>
               </a:lnSpc>
               <a:buNone/>
             </a:pPr>
             <a:r>
-              <a:rPr lang="es-ES" sz="1150" b="0" i="0" dirty="0">
-                <a:solidFill>
-                  <a:srgbClr val="333333"/>
-                </a:solidFill>
-                <a:latin typeface="Calibri"/>
-                <a:cs typeface="Calibri"/>
-              </a:rPr>
-              <a:t>Desarrollo formularios normalizados</a:t>
-            </a:r>
-          </a:p>
-        </p:txBody>
-      </p:sp>
-      <p:sp>
-        <p:nvSpPr>
-          <p:cNvPr id="24" name="sp"/>
-          <p:cNvSpPr/>
-          <p:nvPr/>
-        </p:nvSpPr>
-        <p:spPr>
-          <a:xfrm>
-            <a:off x="5218176" y="3108960"/>
-            <a:ext cx="18288" cy="320040"/>
-          </a:xfrm>
-          <a:prstGeom prst="rect">
-            <a:avLst/>
-          </a:prstGeom>
-          <a:solidFill>
-            <a:srgbClr val="1C5A8C"/>
-          </a:solidFill>
-          <a:ln>
-            <a:noFill/>
-          </a:ln>
-        </p:spPr>
-        <p:txBody>
-          <a:bodyPr/>
-          <a:lstStyle/>
-          <a:p>
-            <a:endParaRPr lang="es-ES"/>
-          </a:p>
-        </p:txBody>
-      </p:sp>
-      <p:sp>
-        <p:nvSpPr>
-          <p:cNvPr id="25" name="sp"/>
-          <p:cNvSpPr/>
-          <p:nvPr/>
-        </p:nvSpPr>
-        <p:spPr>
-          <a:xfrm>
-            <a:off x="6705600" y="3218688"/>
-            <a:ext cx="457200" cy="457200"/>
-          </a:xfrm>
-          <a:prstGeom prst="ellipse">
-            <a:avLst/>
-          </a:prstGeom>
-          <a:solidFill>
-            <a:srgbClr val="1C5A8C"/>
-          </a:solidFill>
-          <a:ln>
-            <a:noFill/>
+              <a:rPr lang="es-ES" sz="900" b="1" i="0" dirty="0">
+                <a:solidFill>
+                  <a:srgbClr val="FFFFFF"/>
+                </a:solidFill>
+                <a:latin typeface="Calibri"/>
+                <a:cs typeface="Calibri"/>
+              </a:rPr>
+              <a:t>Casos resueltos/mes</a:t>
+            </a:r>
+          </a:p>
+        </p:txBody>
+      </p:sp>
+      <p:sp>
+        <p:nvSpPr>
+          <p:cNvPr id="30" name="th"/>
+          <p:cNvSpPr/>
+          <p:nvPr/>
+        </p:nvSpPr>
+        <p:spPr>
+          <a:xfrm>
+            <a:off x="4041648" y="3584448"/>
+            <a:ext cx="1600200" cy="457200"/>
+          </a:xfrm>
+          <a:prstGeom prst="rect">
+            <a:avLst/>
+          </a:prstGeom>
+          <a:solidFill>
+            <a:srgbClr val="123A5E"/>
+          </a:solidFill>
+          <a:ln w="6350">
+            <a:solidFill>
+              <a:srgbClr val="FFFFFF"/>
+            </a:solidFill>
           </a:ln>
         </p:spPr>
         <p:txBody>
@@ -6271,71 +6461,1272 @@
           <a:lstStyle/>
           <a:p>
             <a:pPr marL="0" indent="0" lvl="0" algn="ctr">
-              <a:buNone/>
-            </a:pPr>
-            <a:r>
-              <a:rPr lang="es-ES" sz="1500" b="1" i="0" dirty="0">
+              <a:lnSpc>
+                <a:spcPct val="92000"/>
+              </a:lnSpc>
+              <a:buNone/>
+            </a:pPr>
+            <a:r>
+              <a:rPr lang="es-ES" sz="900" b="1" i="0" dirty="0">
                 <a:solidFill>
                   <a:srgbClr val="FFFFFF"/>
                 </a:solidFill>
                 <a:latin typeface="Calibri"/>
                 <a:cs typeface="Calibri"/>
               </a:rPr>
-              <a:t>✓</a:t>
-            </a:r>
-          </a:p>
-        </p:txBody>
-      </p:sp>
-      <p:sp>
-        <p:nvSpPr>
-          <p:cNvPr id="26" name="sp"/>
-          <p:cNvSpPr/>
-          <p:nvPr/>
-        </p:nvSpPr>
-        <p:spPr>
-          <a:xfrm>
-            <a:off x="6925056" y="3429000"/>
-            <a:ext cx="18288" cy="320040"/>
-          </a:xfrm>
-          <a:prstGeom prst="rect">
-            <a:avLst/>
-          </a:prstGeom>
-          <a:solidFill>
-            <a:srgbClr val="1C5A8C"/>
-          </a:solidFill>
-          <a:ln>
-            <a:noFill/>
-          </a:ln>
-        </p:spPr>
-        <p:txBody>
-          <a:bodyPr/>
-          <a:lstStyle/>
-          <a:p>
-            <a:endParaRPr lang="es-ES"/>
-          </a:p>
-        </p:txBody>
-      </p:sp>
-      <p:sp>
-        <p:nvSpPr>
-          <p:cNvPr id="27" name="sp"/>
-          <p:cNvSpPr/>
-          <p:nvPr/>
-        </p:nvSpPr>
-        <p:spPr>
-          <a:xfrm>
-            <a:off x="6172200" y="3749040"/>
-            <a:ext cx="1524000" cy="1371600"/>
-          </a:xfrm>
-          <a:prstGeom prst="roundRect">
+              <a:t>Ahorro mensual</a:t>
+            </a:r>
+          </a:p>
+        </p:txBody>
+      </p:sp>
+      <p:sp>
+        <p:nvSpPr>
+          <p:cNvPr id="31" name="th"/>
+          <p:cNvSpPr/>
+          <p:nvPr/>
+        </p:nvSpPr>
+        <p:spPr>
+          <a:xfrm>
+            <a:off x="5641848" y="3584448"/>
+            <a:ext cx="1691640" cy="457200"/>
+          </a:xfrm>
+          <a:prstGeom prst="rect">
+            <a:avLst/>
+          </a:prstGeom>
+          <a:solidFill>
+            <a:srgbClr val="123A5E"/>
+          </a:solidFill>
+          <a:ln w="6350">
+            <a:solidFill>
+              <a:srgbClr val="FFFFFF"/>
+            </a:solidFill>
+          </a:ln>
+        </p:spPr>
+        <p:txBody>
+          <a:bodyPr wrap="square" anchor="ctr" lIns="73152" tIns="36576" rIns="73152" bIns="36576">
+            <a:normAutofit/>
+          </a:bodyPr>
+          <a:lstStyle/>
+          <a:p>
+            <a:pPr marL="0" indent="0" lvl="0" algn="ctr">
+              <a:lnSpc>
+                <a:spcPct val="92000"/>
+              </a:lnSpc>
+              <a:buNone/>
+            </a:pPr>
+            <a:r>
+              <a:rPr lang="es-ES" sz="900" b="1" i="0" dirty="0">
+                <a:solidFill>
+                  <a:srgbClr val="FFFFFF"/>
+                </a:solidFill>
+                <a:latin typeface="Calibri"/>
+                <a:cs typeface="Calibri"/>
+              </a:rPr>
+              <a:t>Ahorro anual</a:t>
+            </a:r>
+          </a:p>
+        </p:txBody>
+      </p:sp>
+      <p:sp>
+        <p:nvSpPr>
+          <p:cNvPr id="32" name="th"/>
+          <p:cNvSpPr/>
+          <p:nvPr/>
+        </p:nvSpPr>
+        <p:spPr>
+          <a:xfrm>
+            <a:off x="7333488" y="3584448"/>
+            <a:ext cx="1463040" cy="457200"/>
+          </a:xfrm>
+          <a:prstGeom prst="rect">
+            <a:avLst/>
+          </a:prstGeom>
+          <a:solidFill>
+            <a:srgbClr val="123A5E"/>
+          </a:solidFill>
+          <a:ln w="6350">
+            <a:solidFill>
+              <a:srgbClr val="FFFFFF"/>
+            </a:solidFill>
+          </a:ln>
+        </p:spPr>
+        <p:txBody>
+          <a:bodyPr wrap="square" anchor="ctr" lIns="73152" tIns="36576" rIns="73152" bIns="36576">
+            <a:normAutofit/>
+          </a:bodyPr>
+          <a:lstStyle/>
+          <a:p>
+            <a:pPr marL="0" indent="0" lvl="0" algn="ctr">
+              <a:lnSpc>
+                <a:spcPct val="92000"/>
+              </a:lnSpc>
+              <a:buNone/>
+            </a:pPr>
+            <a:r>
+              <a:rPr lang="es-ES" sz="900" b="1" i="0" dirty="0">
+                <a:solidFill>
+                  <a:srgbClr val="FFFFFF"/>
+                </a:solidFill>
+                <a:latin typeface="Calibri"/>
+                <a:cs typeface="Calibri"/>
+              </a:rPr>
+              <a:t>Costo IA anual</a:t>
+            </a:r>
+          </a:p>
+        </p:txBody>
+      </p:sp>
+      <p:sp>
+        <p:nvSpPr>
+          <p:cNvPr id="33" name="th"/>
+          <p:cNvSpPr/>
+          <p:nvPr/>
+        </p:nvSpPr>
+        <p:spPr>
+          <a:xfrm>
+            <a:off x="8796528" y="3584448"/>
+            <a:ext cx="1737360" cy="457200"/>
+          </a:xfrm>
+          <a:prstGeom prst="rect">
+            <a:avLst/>
+          </a:prstGeom>
+          <a:solidFill>
+            <a:srgbClr val="123A5E"/>
+          </a:solidFill>
+          <a:ln w="6350">
+            <a:solidFill>
+              <a:srgbClr val="FFFFFF"/>
+            </a:solidFill>
+          </a:ln>
+        </p:spPr>
+        <p:txBody>
+          <a:bodyPr wrap="square" anchor="ctr" lIns="73152" tIns="36576" rIns="73152" bIns="36576">
+            <a:normAutofit/>
+          </a:bodyPr>
+          <a:lstStyle/>
+          <a:p>
+            <a:pPr marL="0" indent="0" lvl="0" algn="ctr">
+              <a:lnSpc>
+                <a:spcPct val="92000"/>
+              </a:lnSpc>
+              <a:buNone/>
+            </a:pPr>
+            <a:r>
+              <a:rPr lang="es-ES" sz="900" b="1" i="0" dirty="0">
+                <a:solidFill>
+                  <a:srgbClr val="FFFFFF"/>
+                </a:solidFill>
+                <a:latin typeface="Calibri"/>
+                <a:cs typeface="Calibri"/>
+              </a:rPr>
+              <a:t>Beneficio neto anual</a:t>
+            </a:r>
+          </a:p>
+        </p:txBody>
+      </p:sp>
+      <p:sp>
+        <p:nvSpPr>
+          <p:cNvPr id="34" name="th"/>
+          <p:cNvSpPr/>
+          <p:nvPr/>
+        </p:nvSpPr>
+        <p:spPr>
+          <a:xfrm>
+            <a:off x="10533888" y="3584448"/>
+            <a:ext cx="960120" cy="457200"/>
+          </a:xfrm>
+          <a:prstGeom prst="rect">
+            <a:avLst/>
+          </a:prstGeom>
+          <a:solidFill>
+            <a:srgbClr val="123A5E"/>
+          </a:solidFill>
+          <a:ln w="6350">
+            <a:solidFill>
+              <a:srgbClr val="FFFFFF"/>
+            </a:solidFill>
+          </a:ln>
+        </p:spPr>
+        <p:txBody>
+          <a:bodyPr wrap="square" anchor="ctr" lIns="73152" tIns="36576" rIns="73152" bIns="36576">
+            <a:normAutofit/>
+          </a:bodyPr>
+          <a:lstStyle/>
+          <a:p>
+            <a:pPr marL="0" indent="0" lvl="0" algn="ctr">
+              <a:lnSpc>
+                <a:spcPct val="92000"/>
+              </a:lnSpc>
+              <a:buNone/>
+            </a:pPr>
+            <a:r>
+              <a:rPr lang="es-ES" sz="900" b="1" i="0" dirty="0">
+                <a:solidFill>
+                  <a:srgbClr val="FFFFFF"/>
+                </a:solidFill>
+                <a:latin typeface="Calibri"/>
+                <a:cs typeface="Calibri"/>
+              </a:rPr>
+              <a:t>ROI</a:t>
+            </a:r>
+          </a:p>
+        </p:txBody>
+      </p:sp>
+      <p:sp>
+        <p:nvSpPr>
+          <p:cNvPr id="35" name="td"/>
+          <p:cNvSpPr/>
+          <p:nvPr/>
+        </p:nvSpPr>
+        <p:spPr>
+          <a:xfrm>
+            <a:off x="566928" y="4041648"/>
+            <a:ext cx="2057400" cy="548640"/>
+          </a:xfrm>
+          <a:prstGeom prst="rect">
             <a:avLst/>
           </a:prstGeom>
           <a:solidFill>
             <a:srgbClr val="FFFFFF"/>
           </a:solidFill>
-          <a:ln w="9525">
+          <a:ln w="6350">
             <a:solidFill>
               <a:srgbClr val="DCDCDC"/>
             </a:solidFill>
+          </a:ln>
+        </p:spPr>
+        <p:txBody>
+          <a:bodyPr wrap="square" anchor="ctr" lIns="73152" tIns="36576" rIns="73152" bIns="36576">
+            <a:normAutofit/>
+          </a:bodyPr>
+          <a:lstStyle/>
+          <a:p>
+            <a:pPr marL="0" indent="0" lvl="0" algn="l">
+              <a:lnSpc>
+                <a:spcPct val="92000"/>
+              </a:lnSpc>
+              <a:buNone/>
+            </a:pPr>
+            <a:r>
+              <a:rPr lang="es-ES" sz="1000" b="1" i="0" dirty="0">
+                <a:solidFill>
+                  <a:srgbClr val="D71920"/>
+                </a:solidFill>
+                <a:latin typeface="Calibri"/>
+                <a:cs typeface="Calibri"/>
+              </a:rPr>
+              <a:t>Conservador (50%)</a:t>
+            </a:r>
+          </a:p>
+        </p:txBody>
+      </p:sp>
+      <p:sp>
+        <p:nvSpPr>
+          <p:cNvPr id="36" name="td"/>
+          <p:cNvSpPr/>
+          <p:nvPr/>
+        </p:nvSpPr>
+        <p:spPr>
+          <a:xfrm>
+            <a:off x="2624328" y="4041648"/>
+            <a:ext cx="1417320" cy="548640"/>
+          </a:xfrm>
+          <a:prstGeom prst="rect">
+            <a:avLst/>
+          </a:prstGeom>
+          <a:solidFill>
+            <a:srgbClr val="FFFFFF"/>
+          </a:solidFill>
+          <a:ln w="6350">
+            <a:solidFill>
+              <a:srgbClr val="DCDCDC"/>
+            </a:solidFill>
+          </a:ln>
+        </p:spPr>
+        <p:txBody>
+          <a:bodyPr wrap="square" anchor="ctr" lIns="73152" tIns="36576" rIns="73152" bIns="36576">
+            <a:normAutofit/>
+          </a:bodyPr>
+          <a:lstStyle/>
+          <a:p>
+            <a:pPr marL="0" indent="0" lvl="0" algn="ctr">
+              <a:lnSpc>
+                <a:spcPct val="92000"/>
+              </a:lnSpc>
+              <a:buNone/>
+            </a:pPr>
+            <a:r>
+              <a:rPr lang="es-ES" sz="1000" b="0" i="0" dirty="0">
+                <a:solidFill>
+                  <a:srgbClr val="333333"/>
+                </a:solidFill>
+                <a:latin typeface="Calibri"/>
+                <a:cs typeface="Calibri"/>
+              </a:rPr>
+              <a:t>394</a:t>
+            </a:r>
+          </a:p>
+        </p:txBody>
+      </p:sp>
+      <p:sp>
+        <p:nvSpPr>
+          <p:cNvPr id="37" name="td"/>
+          <p:cNvSpPr/>
+          <p:nvPr/>
+        </p:nvSpPr>
+        <p:spPr>
+          <a:xfrm>
+            <a:off x="4041648" y="4041648"/>
+            <a:ext cx="1600200" cy="548640"/>
+          </a:xfrm>
+          <a:prstGeom prst="rect">
+            <a:avLst/>
+          </a:prstGeom>
+          <a:solidFill>
+            <a:srgbClr val="FFFFFF"/>
+          </a:solidFill>
+          <a:ln w="6350">
+            <a:solidFill>
+              <a:srgbClr val="DCDCDC"/>
+            </a:solidFill>
+          </a:ln>
+        </p:spPr>
+        <p:txBody>
+          <a:bodyPr wrap="square" anchor="ctr" lIns="73152" tIns="36576" rIns="73152" bIns="36576">
+            <a:normAutofit/>
+          </a:bodyPr>
+          <a:lstStyle/>
+          <a:p>
+            <a:pPr marL="0" indent="0" lvl="0" algn="ctr">
+              <a:lnSpc>
+                <a:spcPct val="92000"/>
+              </a:lnSpc>
+              <a:buNone/>
+            </a:pPr>
+            <a:r>
+              <a:rPr lang="es-ES" sz="1000" b="0" i="0" dirty="0">
+                <a:solidFill>
+                  <a:srgbClr val="333333"/>
+                </a:solidFill>
+                <a:latin typeface="Calibri"/>
+                <a:cs typeface="Calibri"/>
+              </a:rPr>
+              <a:t>$1.093.145</a:t>
+            </a:r>
+          </a:p>
+        </p:txBody>
+      </p:sp>
+      <p:sp>
+        <p:nvSpPr>
+          <p:cNvPr id="38" name="td"/>
+          <p:cNvSpPr/>
+          <p:nvPr/>
+        </p:nvSpPr>
+        <p:spPr>
+          <a:xfrm>
+            <a:off x="5641848" y="4041648"/>
+            <a:ext cx="1691640" cy="548640"/>
+          </a:xfrm>
+          <a:prstGeom prst="rect">
+            <a:avLst/>
+          </a:prstGeom>
+          <a:solidFill>
+            <a:srgbClr val="FFFFFF"/>
+          </a:solidFill>
+          <a:ln w="6350">
+            <a:solidFill>
+              <a:srgbClr val="DCDCDC"/>
+            </a:solidFill>
+          </a:ln>
+        </p:spPr>
+        <p:txBody>
+          <a:bodyPr wrap="square" anchor="ctr" lIns="73152" tIns="36576" rIns="73152" bIns="36576">
+            <a:normAutofit/>
+          </a:bodyPr>
+          <a:lstStyle/>
+          <a:p>
+            <a:pPr marL="0" indent="0" lvl="0" algn="ctr">
+              <a:lnSpc>
+                <a:spcPct val="92000"/>
+              </a:lnSpc>
+              <a:buNone/>
+            </a:pPr>
+            <a:r>
+              <a:rPr lang="es-ES" sz="1000" b="1" i="0" dirty="0">
+                <a:solidFill>
+                  <a:srgbClr val="333333"/>
+                </a:solidFill>
+                <a:latin typeface="Calibri"/>
+                <a:cs typeface="Calibri"/>
+              </a:rPr>
+              <a:t>$13.117.741</a:t>
+            </a:r>
+          </a:p>
+        </p:txBody>
+      </p:sp>
+      <p:sp>
+        <p:nvSpPr>
+          <p:cNvPr id="39" name="td"/>
+          <p:cNvSpPr/>
+          <p:nvPr/>
+        </p:nvSpPr>
+        <p:spPr>
+          <a:xfrm>
+            <a:off x="7333488" y="4041648"/>
+            <a:ext cx="1463040" cy="548640"/>
+          </a:xfrm>
+          <a:prstGeom prst="rect">
+            <a:avLst/>
+          </a:prstGeom>
+          <a:solidFill>
+            <a:srgbClr val="FFFFFF"/>
+          </a:solidFill>
+          <a:ln w="6350">
+            <a:solidFill>
+              <a:srgbClr val="DCDCDC"/>
+            </a:solidFill>
+          </a:ln>
+        </p:spPr>
+        <p:txBody>
+          <a:bodyPr wrap="square" anchor="ctr" lIns="73152" tIns="36576" rIns="73152" bIns="36576">
+            <a:normAutofit/>
+          </a:bodyPr>
+          <a:lstStyle/>
+          <a:p>
+            <a:pPr marL="0" indent="0" lvl="0" algn="ctr">
+              <a:lnSpc>
+                <a:spcPct val="92000"/>
+              </a:lnSpc>
+              <a:buNone/>
+            </a:pPr>
+            <a:r>
+              <a:rPr lang="es-ES" sz="1000" b="0" i="0" dirty="0">
+                <a:solidFill>
+                  <a:srgbClr val="6B6B6B"/>
+                </a:solidFill>
+                <a:latin typeface="Calibri"/>
+                <a:cs typeface="Calibri"/>
+              </a:rPr>
+              <a:t>$17.100.000</a:t>
+            </a:r>
+          </a:p>
+        </p:txBody>
+      </p:sp>
+      <p:sp>
+        <p:nvSpPr>
+          <p:cNvPr id="40" name="td"/>
+          <p:cNvSpPr/>
+          <p:nvPr/>
+        </p:nvSpPr>
+        <p:spPr>
+          <a:xfrm>
+            <a:off x="8796528" y="4041648"/>
+            <a:ext cx="1737360" cy="548640"/>
+          </a:xfrm>
+          <a:prstGeom prst="rect">
+            <a:avLst/>
+          </a:prstGeom>
+          <a:solidFill>
+            <a:srgbClr val="FFFFFF"/>
+          </a:solidFill>
+          <a:ln w="6350">
+            <a:solidFill>
+              <a:srgbClr val="DCDCDC"/>
+            </a:solidFill>
+          </a:ln>
+        </p:spPr>
+        <p:txBody>
+          <a:bodyPr wrap="square" anchor="ctr" lIns="73152" tIns="36576" rIns="73152" bIns="36576">
+            <a:normAutofit/>
+          </a:bodyPr>
+          <a:lstStyle/>
+          <a:p>
+            <a:pPr marL="0" indent="0" lvl="0" algn="ctr">
+              <a:lnSpc>
+                <a:spcPct val="92000"/>
+              </a:lnSpc>
+              <a:buNone/>
+            </a:pPr>
+            <a:r>
+              <a:rPr lang="es-ES" sz="1000" b="1" i="0" dirty="0">
+                <a:solidFill>
+                  <a:srgbClr val="D71920"/>
+                </a:solidFill>
+                <a:latin typeface="Calibri"/>
+                <a:cs typeface="Calibri"/>
+              </a:rPr>
+              <a:t>-$3.982.259</a:t>
+            </a:r>
+          </a:p>
+        </p:txBody>
+      </p:sp>
+      <p:sp>
+        <p:nvSpPr>
+          <p:cNvPr id="41" name="td"/>
+          <p:cNvSpPr/>
+          <p:nvPr/>
+        </p:nvSpPr>
+        <p:spPr>
+          <a:xfrm>
+            <a:off x="10533888" y="4041648"/>
+            <a:ext cx="960120" cy="548640"/>
+          </a:xfrm>
+          <a:prstGeom prst="rect">
+            <a:avLst/>
+          </a:prstGeom>
+          <a:solidFill>
+            <a:srgbClr val="FFFFFF"/>
+          </a:solidFill>
+          <a:ln w="6350">
+            <a:solidFill>
+              <a:srgbClr val="DCDCDC"/>
+            </a:solidFill>
+          </a:ln>
+        </p:spPr>
+        <p:txBody>
+          <a:bodyPr wrap="square" anchor="ctr" lIns="73152" tIns="36576" rIns="73152" bIns="36576">
+            <a:normAutofit/>
+          </a:bodyPr>
+          <a:lstStyle/>
+          <a:p>
+            <a:pPr marL="0" indent="0" lvl="0" algn="ctr">
+              <a:lnSpc>
+                <a:spcPct val="92000"/>
+              </a:lnSpc>
+              <a:buNone/>
+            </a:pPr>
+            <a:r>
+              <a:rPr lang="es-ES" sz="1000" b="1" i="0" dirty="0">
+                <a:solidFill>
+                  <a:srgbClr val="D71920"/>
+                </a:solidFill>
+                <a:latin typeface="Calibri"/>
+                <a:cs typeface="Calibri"/>
+              </a:rPr>
+              <a:t>-23%</a:t>
+            </a:r>
+          </a:p>
+        </p:txBody>
+      </p:sp>
+      <p:sp>
+        <p:nvSpPr>
+          <p:cNvPr id="42" name="td"/>
+          <p:cNvSpPr/>
+          <p:nvPr/>
+        </p:nvSpPr>
+        <p:spPr>
+          <a:xfrm>
+            <a:off x="566928" y="4590288"/>
+            <a:ext cx="2057400" cy="548640"/>
+          </a:xfrm>
+          <a:prstGeom prst="rect">
+            <a:avLst/>
+          </a:prstGeom>
+          <a:solidFill>
+            <a:srgbClr val="FCE9D6"/>
+          </a:solidFill>
+          <a:ln w="6350">
+            <a:solidFill>
+              <a:srgbClr val="DCDCDC"/>
+            </a:solidFill>
+          </a:ln>
+        </p:spPr>
+        <p:txBody>
+          <a:bodyPr wrap="square" anchor="ctr" lIns="73152" tIns="36576" rIns="73152" bIns="36576">
+            <a:normAutofit/>
+          </a:bodyPr>
+          <a:lstStyle/>
+          <a:p>
+            <a:pPr marL="0" indent="0" lvl="0" algn="l">
+              <a:lnSpc>
+                <a:spcPct val="92000"/>
+              </a:lnSpc>
+              <a:buNone/>
+            </a:pPr>
+            <a:r>
+              <a:rPr lang="es-ES" sz="1000" b="1" i="0" dirty="0">
+                <a:solidFill>
+                  <a:srgbClr val="E8711E"/>
+                </a:solidFill>
+                <a:latin typeface="Calibri"/>
+                <a:cs typeface="Calibri"/>
+              </a:rPr>
+              <a:t>Moderado (70%)</a:t>
+            </a:r>
+          </a:p>
+        </p:txBody>
+      </p:sp>
+      <p:sp>
+        <p:nvSpPr>
+          <p:cNvPr id="43" name="td"/>
+          <p:cNvSpPr/>
+          <p:nvPr/>
+        </p:nvSpPr>
+        <p:spPr>
+          <a:xfrm>
+            <a:off x="2624328" y="4590288"/>
+            <a:ext cx="1417320" cy="548640"/>
+          </a:xfrm>
+          <a:prstGeom prst="rect">
+            <a:avLst/>
+          </a:prstGeom>
+          <a:solidFill>
+            <a:srgbClr val="FCE9D6"/>
+          </a:solidFill>
+          <a:ln w="6350">
+            <a:solidFill>
+              <a:srgbClr val="DCDCDC"/>
+            </a:solidFill>
+          </a:ln>
+        </p:spPr>
+        <p:txBody>
+          <a:bodyPr wrap="square" anchor="ctr" lIns="73152" tIns="36576" rIns="73152" bIns="36576">
+            <a:normAutofit/>
+          </a:bodyPr>
+          <a:lstStyle/>
+          <a:p>
+            <a:pPr marL="0" indent="0" lvl="0" algn="ctr">
+              <a:lnSpc>
+                <a:spcPct val="92000"/>
+              </a:lnSpc>
+              <a:buNone/>
+            </a:pPr>
+            <a:r>
+              <a:rPr lang="es-ES" sz="1000" b="0" i="0" dirty="0">
+                <a:solidFill>
+                  <a:srgbClr val="333333"/>
+                </a:solidFill>
+                <a:latin typeface="Calibri"/>
+                <a:cs typeface="Calibri"/>
+              </a:rPr>
+              <a:t>552</a:t>
+            </a:r>
+          </a:p>
+        </p:txBody>
+      </p:sp>
+      <p:sp>
+        <p:nvSpPr>
+          <p:cNvPr id="44" name="td"/>
+          <p:cNvSpPr/>
+          <p:nvPr/>
+        </p:nvSpPr>
+        <p:spPr>
+          <a:xfrm>
+            <a:off x="4041648" y="4590288"/>
+            <a:ext cx="1600200" cy="548640"/>
+          </a:xfrm>
+          <a:prstGeom prst="rect">
+            <a:avLst/>
+          </a:prstGeom>
+          <a:solidFill>
+            <a:srgbClr val="FCE9D6"/>
+          </a:solidFill>
+          <a:ln w="6350">
+            <a:solidFill>
+              <a:srgbClr val="DCDCDC"/>
+            </a:solidFill>
+          </a:ln>
+        </p:spPr>
+        <p:txBody>
+          <a:bodyPr wrap="square" anchor="ctr" lIns="73152" tIns="36576" rIns="73152" bIns="36576">
+            <a:normAutofit/>
+          </a:bodyPr>
+          <a:lstStyle/>
+          <a:p>
+            <a:pPr marL="0" indent="0" lvl="0" algn="ctr">
+              <a:lnSpc>
+                <a:spcPct val="92000"/>
+              </a:lnSpc>
+              <a:buNone/>
+            </a:pPr>
+            <a:r>
+              <a:rPr lang="es-ES" sz="1000" b="0" i="0" dirty="0">
+                <a:solidFill>
+                  <a:srgbClr val="333333"/>
+                </a:solidFill>
+                <a:latin typeface="Calibri"/>
+                <a:cs typeface="Calibri"/>
+              </a:rPr>
+              <a:t>$1.530.403</a:t>
+            </a:r>
+          </a:p>
+        </p:txBody>
+      </p:sp>
+      <p:sp>
+        <p:nvSpPr>
+          <p:cNvPr id="45" name="td"/>
+          <p:cNvSpPr/>
+          <p:nvPr/>
+        </p:nvSpPr>
+        <p:spPr>
+          <a:xfrm>
+            <a:off x="5641848" y="4590288"/>
+            <a:ext cx="1691640" cy="548640"/>
+          </a:xfrm>
+          <a:prstGeom prst="rect">
+            <a:avLst/>
+          </a:prstGeom>
+          <a:solidFill>
+            <a:srgbClr val="FCE9D6"/>
+          </a:solidFill>
+          <a:ln w="6350">
+            <a:solidFill>
+              <a:srgbClr val="DCDCDC"/>
+            </a:solidFill>
+          </a:ln>
+        </p:spPr>
+        <p:txBody>
+          <a:bodyPr wrap="square" anchor="ctr" lIns="73152" tIns="36576" rIns="73152" bIns="36576">
+            <a:normAutofit/>
+          </a:bodyPr>
+          <a:lstStyle/>
+          <a:p>
+            <a:pPr marL="0" indent="0" lvl="0" algn="ctr">
+              <a:lnSpc>
+                <a:spcPct val="92000"/>
+              </a:lnSpc>
+              <a:buNone/>
+            </a:pPr>
+            <a:r>
+              <a:rPr lang="es-ES" sz="1000" b="1" i="0" dirty="0">
+                <a:solidFill>
+                  <a:srgbClr val="333333"/>
+                </a:solidFill>
+                <a:latin typeface="Calibri"/>
+                <a:cs typeface="Calibri"/>
+              </a:rPr>
+              <a:t>$18.364.838</a:t>
+            </a:r>
+          </a:p>
+        </p:txBody>
+      </p:sp>
+      <p:sp>
+        <p:nvSpPr>
+          <p:cNvPr id="46" name="td"/>
+          <p:cNvSpPr/>
+          <p:nvPr/>
+        </p:nvSpPr>
+        <p:spPr>
+          <a:xfrm>
+            <a:off x="7333488" y="4590288"/>
+            <a:ext cx="1463040" cy="548640"/>
+          </a:xfrm>
+          <a:prstGeom prst="rect">
+            <a:avLst/>
+          </a:prstGeom>
+          <a:solidFill>
+            <a:srgbClr val="FCE9D6"/>
+          </a:solidFill>
+          <a:ln w="6350">
+            <a:solidFill>
+              <a:srgbClr val="DCDCDC"/>
+            </a:solidFill>
+          </a:ln>
+        </p:spPr>
+        <p:txBody>
+          <a:bodyPr wrap="square" anchor="ctr" lIns="73152" tIns="36576" rIns="73152" bIns="36576">
+            <a:normAutofit/>
+          </a:bodyPr>
+          <a:lstStyle/>
+          <a:p>
+            <a:pPr marL="0" indent="0" lvl="0" algn="ctr">
+              <a:lnSpc>
+                <a:spcPct val="92000"/>
+              </a:lnSpc>
+              <a:buNone/>
+            </a:pPr>
+            <a:r>
+              <a:rPr lang="es-ES" sz="1000" b="0" i="0" dirty="0">
+                <a:solidFill>
+                  <a:srgbClr val="6B6B6B"/>
+                </a:solidFill>
+                <a:latin typeface="Calibri"/>
+                <a:cs typeface="Calibri"/>
+              </a:rPr>
+              <a:t>$17.100.000</a:t>
+            </a:r>
+          </a:p>
+        </p:txBody>
+      </p:sp>
+      <p:sp>
+        <p:nvSpPr>
+          <p:cNvPr id="47" name="td"/>
+          <p:cNvSpPr/>
+          <p:nvPr/>
+        </p:nvSpPr>
+        <p:spPr>
+          <a:xfrm>
+            <a:off x="8796528" y="4590288"/>
+            <a:ext cx="1737360" cy="548640"/>
+          </a:xfrm>
+          <a:prstGeom prst="rect">
+            <a:avLst/>
+          </a:prstGeom>
+          <a:solidFill>
+            <a:srgbClr val="FCE9D6"/>
+          </a:solidFill>
+          <a:ln w="6350">
+            <a:solidFill>
+              <a:srgbClr val="DCDCDC"/>
+            </a:solidFill>
+          </a:ln>
+        </p:spPr>
+        <p:txBody>
+          <a:bodyPr wrap="square" anchor="ctr" lIns="73152" tIns="36576" rIns="73152" bIns="36576">
+            <a:normAutofit/>
+          </a:bodyPr>
+          <a:lstStyle/>
+          <a:p>
+            <a:pPr marL="0" indent="0" lvl="0" algn="ctr">
+              <a:lnSpc>
+                <a:spcPct val="92000"/>
+              </a:lnSpc>
+              <a:buNone/>
+            </a:pPr>
+            <a:r>
+              <a:rPr lang="es-ES" sz="1000" b="1" i="0" dirty="0">
+                <a:solidFill>
+                  <a:srgbClr val="123A5E"/>
+                </a:solidFill>
+                <a:latin typeface="Calibri"/>
+                <a:cs typeface="Calibri"/>
+              </a:rPr>
+              <a:t>+$1.264.838</a:t>
+            </a:r>
+          </a:p>
+        </p:txBody>
+      </p:sp>
+      <p:sp>
+        <p:nvSpPr>
+          <p:cNvPr id="48" name="td"/>
+          <p:cNvSpPr/>
+          <p:nvPr/>
+        </p:nvSpPr>
+        <p:spPr>
+          <a:xfrm>
+            <a:off x="10533888" y="4590288"/>
+            <a:ext cx="960120" cy="548640"/>
+          </a:xfrm>
+          <a:prstGeom prst="rect">
+            <a:avLst/>
+          </a:prstGeom>
+          <a:solidFill>
+            <a:srgbClr val="FCE9D6"/>
+          </a:solidFill>
+          <a:ln w="6350">
+            <a:solidFill>
+              <a:srgbClr val="DCDCDC"/>
+            </a:solidFill>
+          </a:ln>
+        </p:spPr>
+        <p:txBody>
+          <a:bodyPr wrap="square" anchor="ctr" lIns="73152" tIns="36576" rIns="73152" bIns="36576">
+            <a:normAutofit/>
+          </a:bodyPr>
+          <a:lstStyle/>
+          <a:p>
+            <a:pPr marL="0" indent="0" lvl="0" algn="ctr">
+              <a:lnSpc>
+                <a:spcPct val="92000"/>
+              </a:lnSpc>
+              <a:buNone/>
+            </a:pPr>
+            <a:r>
+              <a:rPr lang="es-ES" sz="1000" b="1" i="0" dirty="0">
+                <a:solidFill>
+                  <a:srgbClr val="123A5E"/>
+                </a:solidFill>
+                <a:latin typeface="Calibri"/>
+                <a:cs typeface="Calibri"/>
+              </a:rPr>
+              <a:t>+7%</a:t>
+            </a:r>
+          </a:p>
+        </p:txBody>
+      </p:sp>
+      <p:sp>
+        <p:nvSpPr>
+          <p:cNvPr id="49" name="td"/>
+          <p:cNvSpPr/>
+          <p:nvPr/>
+        </p:nvSpPr>
+        <p:spPr>
+          <a:xfrm>
+            <a:off x="566928" y="5138928"/>
+            <a:ext cx="2057400" cy="548640"/>
+          </a:xfrm>
+          <a:prstGeom prst="rect">
+            <a:avLst/>
+          </a:prstGeom>
+          <a:solidFill>
+            <a:srgbClr val="FFFFFF"/>
+          </a:solidFill>
+          <a:ln w="6350">
+            <a:solidFill>
+              <a:srgbClr val="DCDCDC"/>
+            </a:solidFill>
+          </a:ln>
+        </p:spPr>
+        <p:txBody>
+          <a:bodyPr wrap="square" anchor="ctr" lIns="73152" tIns="36576" rIns="73152" bIns="36576">
+            <a:normAutofit/>
+          </a:bodyPr>
+          <a:lstStyle/>
+          <a:p>
+            <a:pPr marL="0" indent="0" lvl="0" algn="l">
+              <a:lnSpc>
+                <a:spcPct val="92000"/>
+              </a:lnSpc>
+              <a:buNone/>
+            </a:pPr>
+            <a:r>
+              <a:rPr lang="es-ES" sz="1000" b="1" i="0" dirty="0">
+                <a:solidFill>
+                  <a:srgbClr val="123A5E"/>
+                </a:solidFill>
+                <a:latin typeface="Calibri"/>
+                <a:cs typeface="Calibri"/>
+              </a:rPr>
+              <a:t>Optimista (85%)</a:t>
+            </a:r>
+          </a:p>
+        </p:txBody>
+      </p:sp>
+      <p:sp>
+        <p:nvSpPr>
+          <p:cNvPr id="50" name="td"/>
+          <p:cNvSpPr/>
+          <p:nvPr/>
+        </p:nvSpPr>
+        <p:spPr>
+          <a:xfrm>
+            <a:off x="2624328" y="5138928"/>
+            <a:ext cx="1417320" cy="548640"/>
+          </a:xfrm>
+          <a:prstGeom prst="rect">
+            <a:avLst/>
+          </a:prstGeom>
+          <a:solidFill>
+            <a:srgbClr val="FFFFFF"/>
+          </a:solidFill>
+          <a:ln w="6350">
+            <a:solidFill>
+              <a:srgbClr val="DCDCDC"/>
+            </a:solidFill>
+          </a:ln>
+        </p:spPr>
+        <p:txBody>
+          <a:bodyPr wrap="square" anchor="ctr" lIns="73152" tIns="36576" rIns="73152" bIns="36576">
+            <a:normAutofit/>
+          </a:bodyPr>
+          <a:lstStyle/>
+          <a:p>
+            <a:pPr marL="0" indent="0" lvl="0" algn="ctr">
+              <a:lnSpc>
+                <a:spcPct val="92000"/>
+              </a:lnSpc>
+              <a:buNone/>
+            </a:pPr>
+            <a:r>
+              <a:rPr lang="es-ES" sz="1000" b="0" i="0" dirty="0">
+                <a:solidFill>
+                  <a:srgbClr val="333333"/>
+                </a:solidFill>
+                <a:latin typeface="Calibri"/>
+                <a:cs typeface="Calibri"/>
+              </a:rPr>
+              <a:t>670</a:t>
+            </a:r>
+          </a:p>
+        </p:txBody>
+      </p:sp>
+      <p:sp>
+        <p:nvSpPr>
+          <p:cNvPr id="51" name="td"/>
+          <p:cNvSpPr/>
+          <p:nvPr/>
+        </p:nvSpPr>
+        <p:spPr>
+          <a:xfrm>
+            <a:off x="4041648" y="5138928"/>
+            <a:ext cx="1600200" cy="548640"/>
+          </a:xfrm>
+          <a:prstGeom prst="rect">
+            <a:avLst/>
+          </a:prstGeom>
+          <a:solidFill>
+            <a:srgbClr val="FFFFFF"/>
+          </a:solidFill>
+          <a:ln w="6350">
+            <a:solidFill>
+              <a:srgbClr val="DCDCDC"/>
+            </a:solidFill>
+          </a:ln>
+        </p:spPr>
+        <p:txBody>
+          <a:bodyPr wrap="square" anchor="ctr" lIns="73152" tIns="36576" rIns="73152" bIns="36576">
+            <a:normAutofit/>
+          </a:bodyPr>
+          <a:lstStyle/>
+          <a:p>
+            <a:pPr marL="0" indent="0" lvl="0" algn="ctr">
+              <a:lnSpc>
+                <a:spcPct val="92000"/>
+              </a:lnSpc>
+              <a:buNone/>
+            </a:pPr>
+            <a:r>
+              <a:rPr lang="es-ES" sz="1000" b="0" i="0" dirty="0">
+                <a:solidFill>
+                  <a:srgbClr val="333333"/>
+                </a:solidFill>
+                <a:latin typeface="Calibri"/>
+                <a:cs typeface="Calibri"/>
+              </a:rPr>
+              <a:t>$1.858.347</a:t>
+            </a:r>
+          </a:p>
+        </p:txBody>
+      </p:sp>
+      <p:sp>
+        <p:nvSpPr>
+          <p:cNvPr id="52" name="td"/>
+          <p:cNvSpPr/>
+          <p:nvPr/>
+        </p:nvSpPr>
+        <p:spPr>
+          <a:xfrm>
+            <a:off x="5641848" y="5138928"/>
+            <a:ext cx="1691640" cy="548640"/>
+          </a:xfrm>
+          <a:prstGeom prst="rect">
+            <a:avLst/>
+          </a:prstGeom>
+          <a:solidFill>
+            <a:srgbClr val="FFFFFF"/>
+          </a:solidFill>
+          <a:ln w="6350">
+            <a:solidFill>
+              <a:srgbClr val="DCDCDC"/>
+            </a:solidFill>
+          </a:ln>
+        </p:spPr>
+        <p:txBody>
+          <a:bodyPr wrap="square" anchor="ctr" lIns="73152" tIns="36576" rIns="73152" bIns="36576">
+            <a:normAutofit/>
+          </a:bodyPr>
+          <a:lstStyle/>
+          <a:p>
+            <a:pPr marL="0" indent="0" lvl="0" algn="ctr">
+              <a:lnSpc>
+                <a:spcPct val="92000"/>
+              </a:lnSpc>
+              <a:buNone/>
+            </a:pPr>
+            <a:r>
+              <a:rPr lang="es-ES" sz="1000" b="1" i="0" dirty="0">
+                <a:solidFill>
+                  <a:srgbClr val="333333"/>
+                </a:solidFill>
+                <a:latin typeface="Calibri"/>
+                <a:cs typeface="Calibri"/>
+              </a:rPr>
+              <a:t>$22.300.160</a:t>
+            </a:r>
+          </a:p>
+        </p:txBody>
+      </p:sp>
+      <p:sp>
+        <p:nvSpPr>
+          <p:cNvPr id="53" name="td"/>
+          <p:cNvSpPr/>
+          <p:nvPr/>
+        </p:nvSpPr>
+        <p:spPr>
+          <a:xfrm>
+            <a:off x="7333488" y="5138928"/>
+            <a:ext cx="1463040" cy="548640"/>
+          </a:xfrm>
+          <a:prstGeom prst="rect">
+            <a:avLst/>
+          </a:prstGeom>
+          <a:solidFill>
+            <a:srgbClr val="FFFFFF"/>
+          </a:solidFill>
+          <a:ln w="6350">
+            <a:solidFill>
+              <a:srgbClr val="DCDCDC"/>
+            </a:solidFill>
+          </a:ln>
+        </p:spPr>
+        <p:txBody>
+          <a:bodyPr wrap="square" anchor="ctr" lIns="73152" tIns="36576" rIns="73152" bIns="36576">
+            <a:normAutofit/>
+          </a:bodyPr>
+          <a:lstStyle/>
+          <a:p>
+            <a:pPr marL="0" indent="0" lvl="0" algn="ctr">
+              <a:lnSpc>
+                <a:spcPct val="92000"/>
+              </a:lnSpc>
+              <a:buNone/>
+            </a:pPr>
+            <a:r>
+              <a:rPr lang="es-ES" sz="1000" b="0" i="0" dirty="0">
+                <a:solidFill>
+                  <a:srgbClr val="6B6B6B"/>
+                </a:solidFill>
+                <a:latin typeface="Calibri"/>
+                <a:cs typeface="Calibri"/>
+              </a:rPr>
+              <a:t>$17.100.000</a:t>
+            </a:r>
+          </a:p>
+        </p:txBody>
+      </p:sp>
+      <p:sp>
+        <p:nvSpPr>
+          <p:cNvPr id="54" name="td"/>
+          <p:cNvSpPr/>
+          <p:nvPr/>
+        </p:nvSpPr>
+        <p:spPr>
+          <a:xfrm>
+            <a:off x="8796528" y="5138928"/>
+            <a:ext cx="1737360" cy="548640"/>
+          </a:xfrm>
+          <a:prstGeom prst="rect">
+            <a:avLst/>
+          </a:prstGeom>
+          <a:solidFill>
+            <a:srgbClr val="FFFFFF"/>
+          </a:solidFill>
+          <a:ln w="6350">
+            <a:solidFill>
+              <a:srgbClr val="DCDCDC"/>
+            </a:solidFill>
+          </a:ln>
+        </p:spPr>
+        <p:txBody>
+          <a:bodyPr wrap="square" anchor="ctr" lIns="73152" tIns="36576" rIns="73152" bIns="36576">
+            <a:normAutofit/>
+          </a:bodyPr>
+          <a:lstStyle/>
+          <a:p>
+            <a:pPr marL="0" indent="0" lvl="0" algn="ctr">
+              <a:lnSpc>
+                <a:spcPct val="92000"/>
+              </a:lnSpc>
+              <a:buNone/>
+            </a:pPr>
+            <a:r>
+              <a:rPr lang="es-ES" sz="1000" b="1" i="0" dirty="0">
+                <a:solidFill>
+                  <a:srgbClr val="123A5E"/>
+                </a:solidFill>
+                <a:latin typeface="Calibri"/>
+                <a:cs typeface="Calibri"/>
+              </a:rPr>
+              <a:t>+$5.200.160</a:t>
+            </a:r>
+          </a:p>
+        </p:txBody>
+      </p:sp>
+      <p:sp>
+        <p:nvSpPr>
+          <p:cNvPr id="55" name="td"/>
+          <p:cNvSpPr/>
+          <p:nvPr/>
+        </p:nvSpPr>
+        <p:spPr>
+          <a:xfrm>
+            <a:off x="10533888" y="5138928"/>
+            <a:ext cx="960120" cy="548640"/>
+          </a:xfrm>
+          <a:prstGeom prst="rect">
+            <a:avLst/>
+          </a:prstGeom>
+          <a:solidFill>
+            <a:srgbClr val="FFFFFF"/>
+          </a:solidFill>
+          <a:ln w="6350">
+            <a:solidFill>
+              <a:srgbClr val="DCDCDC"/>
+            </a:solidFill>
+          </a:ln>
+        </p:spPr>
+        <p:txBody>
+          <a:bodyPr wrap="square" anchor="ctr" lIns="73152" tIns="36576" rIns="73152" bIns="36576">
+            <a:normAutofit/>
+          </a:bodyPr>
+          <a:lstStyle/>
+          <a:p>
+            <a:pPr marL="0" indent="0" lvl="0" algn="ctr">
+              <a:lnSpc>
+                <a:spcPct val="92000"/>
+              </a:lnSpc>
+              <a:buNone/>
+            </a:pPr>
+            <a:r>
+              <a:rPr lang="es-ES" sz="1000" b="1" i="0" dirty="0">
+                <a:solidFill>
+                  <a:srgbClr val="123A5E"/>
+                </a:solidFill>
+                <a:latin typeface="Calibri"/>
+                <a:cs typeface="Calibri"/>
+              </a:rPr>
+              <a:t>+30%</a:t>
+            </a:r>
+          </a:p>
+        </p:txBody>
+      </p:sp>
+      <p:sp>
+        <p:nvSpPr>
+          <p:cNvPr id="56" name="reco"/>
+          <p:cNvSpPr/>
+          <p:nvPr/>
+        </p:nvSpPr>
+        <p:spPr>
+          <a:xfrm>
+            <a:off x="566928" y="4590288"/>
+            <a:ext cx="10927080" cy="548640"/>
+          </a:xfrm>
+          <a:prstGeom prst="rect">
+            <a:avLst/>
+          </a:prstGeom>
+          <a:noFill/>
+          <a:ln w="22225">
+            <a:solidFill>
+              <a:srgbClr val="E8711E"/>
+            </a:solidFill>
+          </a:ln>
+        </p:spPr>
+        <p:txBody>
+          <a:bodyPr/>
+          <a:lstStyle/>
+          <a:p>
+            <a:endParaRPr lang="es-ES"/>
+          </a:p>
+        </p:txBody>
+      </p:sp>
+      <p:sp>
+        <p:nvSpPr>
+          <p:cNvPr id="57" name="sp"/>
+          <p:cNvSpPr/>
+          <p:nvPr/>
+        </p:nvSpPr>
+        <p:spPr>
+          <a:xfrm>
+            <a:off x="566928" y="5760720"/>
+            <a:ext cx="11064240" cy="566928"/>
+          </a:xfrm>
+          <a:prstGeom prst="roundRect">
+            <a:avLst/>
+          </a:prstGeom>
+          <a:solidFill>
+            <a:srgbClr val="262626"/>
+          </a:solidFill>
+          <a:ln>
+            <a:noFill/>
           </a:ln>
           <a:effectLst>
             <a:outerShdw blurRad="50000" dist="25000" dir="5400000" rotWithShape="0">
@@ -6355,95 +7746,16 @@
       </p:sp>
       <p:sp>
         <p:nvSpPr>
-          <p:cNvPr id="28" name="tb"/>
-          <p:cNvSpPr txBox="1"/>
-          <p:nvPr/>
-        </p:nvSpPr>
-        <p:spPr>
-          <a:xfrm>
-            <a:off x="6172200" y="3877056"/>
-            <a:ext cx="1524000" cy="365760"/>
-          </a:xfrm>
-          <a:prstGeom prst="rect">
-            <a:avLst/>
-          </a:prstGeom>
-          <a:noFill/>
-        </p:spPr>
-        <p:txBody>
-          <a:bodyPr wrap="square" anchor="t" lIns="73152" tIns="36576" rIns="73152" bIns="36576">
-            <a:normAutofit/>
-          </a:bodyPr>
-          <a:lstStyle/>
-          <a:p>
-            <a:pPr marL="0" indent="0" lvl="0" algn="ctr">
-              <a:buNone/>
-            </a:pPr>
-            <a:r>
-              <a:rPr lang="es-ES" sz="1050" b="1" i="0" dirty="0">
-                <a:solidFill>
-                  <a:srgbClr val="1C5A8C"/>
-                </a:solidFill>
-                <a:latin typeface="Calibri"/>
-                <a:cs typeface="Calibri"/>
-              </a:rPr>
-              <a:t>JULIO</a:t>
-            </a:r>
-          </a:p>
-        </p:txBody>
-      </p:sp>
-      <p:sp>
-        <p:nvSpPr>
-          <p:cNvPr id="29" name="tb"/>
-          <p:cNvSpPr txBox="1"/>
-          <p:nvPr/>
-        </p:nvSpPr>
-        <p:spPr>
-          <a:xfrm>
-            <a:off x="6227064" y="4224528"/>
-            <a:ext cx="1414272" cy="822960"/>
-          </a:xfrm>
-          <a:prstGeom prst="rect">
-            <a:avLst/>
-          </a:prstGeom>
-          <a:noFill/>
-        </p:spPr>
-        <p:txBody>
-          <a:bodyPr wrap="square" anchor="t" lIns="73152" tIns="36576" rIns="73152" bIns="36576">
-            <a:normAutofit/>
-          </a:bodyPr>
-          <a:lstStyle/>
-          <a:p>
-            <a:pPr marL="0" indent="0" lvl="0" algn="ctr">
-              <a:lnSpc>
-                <a:spcPct val="98000"/>
-              </a:lnSpc>
-              <a:buNone/>
-            </a:pPr>
-            <a:r>
-              <a:rPr lang="es-ES" sz="1150" b="0" i="0" dirty="0">
-                <a:solidFill>
-                  <a:srgbClr val="333333"/>
-                </a:solidFill>
-                <a:latin typeface="Calibri"/>
-                <a:cs typeface="Calibri"/>
-              </a:rPr>
-              <a:t>Implementacion Agente IA</a:t>
-            </a:r>
-          </a:p>
-        </p:txBody>
-      </p:sp>
-      <p:sp>
-        <p:nvSpPr>
-          <p:cNvPr id="30" name="sp"/>
-          <p:cNvSpPr/>
-          <p:nvPr/>
-        </p:nvSpPr>
-        <p:spPr>
-          <a:xfrm>
-            <a:off x="8412480" y="3218688"/>
-            <a:ext cx="457200" cy="457200"/>
-          </a:xfrm>
-          <a:prstGeom prst="ellipse">
+          <p:cNvPr id="58" name="sp"/>
+          <p:cNvSpPr/>
+          <p:nvPr/>
+        </p:nvSpPr>
+        <p:spPr>
+          <a:xfrm>
+            <a:off x="566928" y="5760720"/>
+            <a:ext cx="128016" cy="566928"/>
+          </a:xfrm>
+          <a:prstGeom prst="rect">
             <a:avLst/>
           </a:prstGeom>
           <a:solidFill>
@@ -6454,75 +7766,71 @@
           </a:ln>
         </p:spPr>
         <p:txBody>
+          <a:bodyPr/>
+          <a:lstStyle/>
+          <a:p>
+            <a:endParaRPr lang="es-ES"/>
+          </a:p>
+        </p:txBody>
+      </p:sp>
+      <p:sp>
+        <p:nvSpPr>
+          <p:cNvPr id="59" name="tb"/>
+          <p:cNvSpPr txBox="1"/>
+          <p:nvPr/>
+        </p:nvSpPr>
+        <p:spPr>
+          <a:xfrm>
+            <a:off x="896112" y="5824728"/>
+            <a:ext cx="10607040" cy="502920"/>
+          </a:xfrm>
+          <a:prstGeom prst="rect">
+            <a:avLst/>
+          </a:prstGeom>
+          <a:noFill/>
+        </p:spPr>
+        <p:txBody>
           <a:bodyPr wrap="square" anchor="ctr" lIns="73152" tIns="36576" rIns="73152" bIns="36576">
             <a:normAutofit/>
           </a:bodyPr>
           <a:lstStyle/>
           <a:p>
-            <a:pPr marL="0" indent="0" lvl="0" algn="ctr">
-              <a:buNone/>
-            </a:pPr>
-            <a:r>
-              <a:rPr lang="es-ES" sz="1500" b="1" i="0" dirty="0">
-                <a:solidFill>
-                  <a:srgbClr val="FFFFFF"/>
-                </a:solidFill>
-                <a:latin typeface="Calibri"/>
-                <a:cs typeface="Calibri"/>
-              </a:rPr>
-              <a:t>~</a:t>
-            </a:r>
-          </a:p>
-        </p:txBody>
-      </p:sp>
-      <p:sp>
-        <p:nvSpPr>
-          <p:cNvPr id="31" name="sp"/>
-          <p:cNvSpPr/>
-          <p:nvPr/>
-        </p:nvSpPr>
-        <p:spPr>
-          <a:xfrm>
-            <a:off x="7879080" y="1737360"/>
-            <a:ext cx="1524000" cy="1371600"/>
-          </a:xfrm>
-          <a:prstGeom prst="roundRect">
-            <a:avLst/>
-          </a:prstGeom>
-          <a:solidFill>
-            <a:srgbClr val="FFFFFF"/>
-          </a:solidFill>
-          <a:ln w="9525">
-            <a:solidFill>
-              <a:srgbClr val="DCDCDC"/>
-            </a:solidFill>
-          </a:ln>
-          <a:effectLst>
-            <a:outerShdw blurRad="50000" dist="25000" dir="5400000" rotWithShape="0">
-              <a:srgbClr val="000000">
-                <a:alpha val="20000"/>
-              </a:srgbClr>
-            </a:outerShdw>
-          </a:effectLst>
-        </p:spPr>
-        <p:txBody>
-          <a:bodyPr/>
-          <a:lstStyle/>
-          <a:p>
-            <a:endParaRPr lang="es-ES"/>
-          </a:p>
-        </p:txBody>
-      </p:sp>
-      <p:sp>
-        <p:nvSpPr>
-          <p:cNvPr id="32" name="tb"/>
+            <a:pPr marL="0" indent="0" lvl="0" algn="l">
+              <a:buNone/>
+            </a:pPr>
+            <a:r>
+              <a:rPr lang="es-ES" sz="1000" b="1" i="0" spc="120" dirty="0">
+                <a:solidFill>
+                  <a:srgbClr val="E8711E"/>
+                </a:solidFill>
+                <a:latin typeface="Calibri"/>
+                <a:cs typeface="Calibri"/>
+              </a:rPr>
+              <a:t>CONCLUSION   </a:t>
+            </a:r>
+            <a:r>
+              <a:rPr lang="es-ES" sz="1000" b="0" i="0" dirty="0">
+                <a:solidFill>
+                  <a:srgbClr val="E6EDF3"/>
+                </a:solidFill>
+                <a:latin typeface="Calibri"/>
+                <a:cs typeface="Calibri"/>
+              </a:rPr>
+              <a:t>Punto de equilibrio en ~65% de efectividad. En el escenario moderado (70%) el beneficio neto es ~$1,3M CLP/ano (ROI +7%) y a 85% sube a ~$5,2M (ROI +30%). Inversion unica de normalizacion: $301.320 (40 HHEE). Calculo conservador: no incluye CX, ventas recuperadas ni menor inventario inmovilizado.</a:t>
+            </a:r>
+          </a:p>
+        </p:txBody>
+      </p:sp>
+      <p:sp>
+        <p:nvSpPr>
+          <p:cNvPr id="60" name="tb"/>
           <p:cNvSpPr txBox="1"/>
           <p:nvPr/>
         </p:nvSpPr>
         <p:spPr>
           <a:xfrm>
-            <a:off x="7879080" y="1865376"/>
-            <a:ext cx="1524000" cy="365760"/>
+            <a:off x="548640" y="6400800"/>
+            <a:ext cx="10058400" cy="365760"/>
           </a:xfrm>
           <a:prstGeom prst="rect">
             <a:avLst/>
@@ -6535,411 +7843,18 @@
           </a:bodyPr>
           <a:lstStyle/>
           <a:p>
-            <a:pPr marL="0" indent="0" lvl="0" algn="ctr">
-              <a:buNone/>
-            </a:pPr>
-            <a:r>
-              <a:rPr lang="es-ES" sz="1050" b="1" i="0" dirty="0">
-                <a:solidFill>
-                  <a:srgbClr val="E8711E"/>
-                </a:solidFill>
-                <a:latin typeface="Calibri"/>
-                <a:cs typeface="Calibri"/>
-              </a:rPr>
-              <a:t>AGO - SEP</a:t>
-            </a:r>
-          </a:p>
-        </p:txBody>
-      </p:sp>
-      <p:sp>
-        <p:nvSpPr>
-          <p:cNvPr id="33" name="tb"/>
-          <p:cNvSpPr txBox="1"/>
-          <p:nvPr/>
-        </p:nvSpPr>
-        <p:spPr>
-          <a:xfrm>
-            <a:off x="7933944" y="2212848"/>
-            <a:ext cx="1414272" cy="822960"/>
-          </a:xfrm>
-          <a:prstGeom prst="rect">
-            <a:avLst/>
-          </a:prstGeom>
-          <a:noFill/>
-        </p:spPr>
-        <p:txBody>
-          <a:bodyPr wrap="square" anchor="t" lIns="73152" tIns="36576" rIns="73152" bIns="36576">
-            <a:normAutofit/>
-          </a:bodyPr>
-          <a:lstStyle/>
-          <a:p>
-            <a:pPr marL="0" indent="0" lvl="0" algn="ctr">
-              <a:lnSpc>
-                <a:spcPct val="98000"/>
-              </a:lnSpc>
-              <a:buNone/>
-            </a:pPr>
-            <a:r>
-              <a:rPr lang="es-ES" sz="1150" b="0" i="0" dirty="0">
-                <a:solidFill>
-                  <a:srgbClr val="333333"/>
-                </a:solidFill>
-                <a:latin typeface="Calibri"/>
-                <a:cs typeface="Calibri"/>
-              </a:rPr>
-              <a:t>Expansion Same Day RM</a:t>
-            </a:r>
-          </a:p>
-        </p:txBody>
-      </p:sp>
-      <p:sp>
-        <p:nvSpPr>
-          <p:cNvPr id="34" name="sp"/>
-          <p:cNvSpPr/>
-          <p:nvPr/>
-        </p:nvSpPr>
-        <p:spPr>
-          <a:xfrm>
-            <a:off x="8631936" y="3108960"/>
-            <a:ext cx="18288" cy="320040"/>
-          </a:xfrm>
-          <a:prstGeom prst="rect">
-            <a:avLst/>
-          </a:prstGeom>
-          <a:solidFill>
-            <a:srgbClr val="E8711E"/>
-          </a:solidFill>
-          <a:ln>
-            <a:noFill/>
-          </a:ln>
-        </p:spPr>
-        <p:txBody>
-          <a:bodyPr/>
-          <a:lstStyle/>
-          <a:p>
-            <a:endParaRPr lang="es-ES"/>
-          </a:p>
-        </p:txBody>
-      </p:sp>
-      <p:sp>
-        <p:nvSpPr>
-          <p:cNvPr id="35" name="sp"/>
-          <p:cNvSpPr/>
-          <p:nvPr/>
-        </p:nvSpPr>
-        <p:spPr>
-          <a:xfrm>
-            <a:off x="10119360" y="3218688"/>
-            <a:ext cx="457200" cy="457200"/>
-          </a:xfrm>
-          <a:prstGeom prst="ellipse">
-            <a:avLst/>
-          </a:prstGeom>
-          <a:solidFill>
-            <a:srgbClr val="E8711E"/>
-          </a:solidFill>
-          <a:ln>
-            <a:noFill/>
-          </a:ln>
-        </p:spPr>
-        <p:txBody>
-          <a:bodyPr wrap="square" anchor="ctr" lIns="73152" tIns="36576" rIns="73152" bIns="36576">
-            <a:normAutofit/>
-          </a:bodyPr>
-          <a:lstStyle/>
-          <a:p>
-            <a:pPr marL="0" indent="0" lvl="0" algn="ctr">
-              <a:buNone/>
-            </a:pPr>
-            <a:r>
-              <a:rPr lang="es-ES" sz="1500" b="1" i="0" dirty="0">
-                <a:solidFill>
-                  <a:srgbClr val="FFFFFF"/>
-                </a:solidFill>
-                <a:latin typeface="Calibri"/>
-                <a:cs typeface="Calibri"/>
-              </a:rPr>
-              <a:t>~</a:t>
-            </a:r>
-          </a:p>
-        </p:txBody>
-      </p:sp>
-      <p:sp>
-        <p:nvSpPr>
-          <p:cNvPr id="36" name="sp"/>
-          <p:cNvSpPr/>
-          <p:nvPr/>
-        </p:nvSpPr>
-        <p:spPr>
-          <a:xfrm>
-            <a:off x="10338816" y="3429000"/>
-            <a:ext cx="18288" cy="320040"/>
-          </a:xfrm>
-          <a:prstGeom prst="rect">
-            <a:avLst/>
-          </a:prstGeom>
-          <a:solidFill>
-            <a:srgbClr val="E8711E"/>
-          </a:solidFill>
-          <a:ln>
-            <a:noFill/>
-          </a:ln>
-        </p:spPr>
-        <p:txBody>
-          <a:bodyPr/>
-          <a:lstStyle/>
-          <a:p>
-            <a:endParaRPr lang="es-ES"/>
-          </a:p>
-        </p:txBody>
-      </p:sp>
-      <p:sp>
-        <p:nvSpPr>
-          <p:cNvPr id="37" name="sp"/>
-          <p:cNvSpPr/>
-          <p:nvPr/>
-        </p:nvSpPr>
-        <p:spPr>
-          <a:xfrm>
-            <a:off x="9585960" y="3749040"/>
-            <a:ext cx="1524000" cy="1371600"/>
-          </a:xfrm>
-          <a:prstGeom prst="roundRect">
-            <a:avLst/>
-          </a:prstGeom>
-          <a:solidFill>
-            <a:srgbClr val="FFFFFF"/>
-          </a:solidFill>
-          <a:ln w="9525">
-            <a:solidFill>
-              <a:srgbClr val="DCDCDC"/>
-            </a:solidFill>
-          </a:ln>
-          <a:effectLst>
-            <a:outerShdw blurRad="50000" dist="25000" dir="5400000" rotWithShape="0">
-              <a:srgbClr val="000000">
-                <a:alpha val="20000"/>
-              </a:srgbClr>
-            </a:outerShdw>
-          </a:effectLst>
-        </p:spPr>
-        <p:txBody>
-          <a:bodyPr/>
-          <a:lstStyle/>
-          <a:p>
-            <a:endParaRPr lang="es-ES"/>
-          </a:p>
-        </p:txBody>
-      </p:sp>
-      <p:sp>
-        <p:nvSpPr>
-          <p:cNvPr id="38" name="tb"/>
-          <p:cNvSpPr txBox="1"/>
-          <p:nvPr/>
-        </p:nvSpPr>
-        <p:spPr>
-          <a:xfrm>
-            <a:off x="9585960" y="3877056"/>
-            <a:ext cx="1524000" cy="365760"/>
-          </a:xfrm>
-          <a:prstGeom prst="rect">
-            <a:avLst/>
-          </a:prstGeom>
-          <a:noFill/>
-        </p:spPr>
-        <p:txBody>
-          <a:bodyPr wrap="square" anchor="t" lIns="73152" tIns="36576" rIns="73152" bIns="36576">
-            <a:normAutofit/>
-          </a:bodyPr>
-          <a:lstStyle/>
-          <a:p>
-            <a:pPr marL="0" indent="0" lvl="0" algn="ctr">
-              <a:buNone/>
-            </a:pPr>
-            <a:r>
-              <a:rPr lang="es-ES" sz="1050" b="1" i="0" dirty="0">
-                <a:solidFill>
-                  <a:srgbClr val="E8711E"/>
-                </a:solidFill>
-                <a:latin typeface="Calibri"/>
-                <a:cs typeface="Calibri"/>
-              </a:rPr>
-              <a:t>SEP - OCT</a:t>
-            </a:r>
-          </a:p>
-        </p:txBody>
-      </p:sp>
-      <p:sp>
-        <p:nvSpPr>
-          <p:cNvPr id="39" name="tb"/>
-          <p:cNvSpPr txBox="1"/>
-          <p:nvPr/>
-        </p:nvSpPr>
-        <p:spPr>
-          <a:xfrm>
-            <a:off x="9640824" y="4224528"/>
-            <a:ext cx="1414272" cy="822960"/>
-          </a:xfrm>
-          <a:prstGeom prst="rect">
-            <a:avLst/>
-          </a:prstGeom>
-          <a:noFill/>
-        </p:spPr>
-        <p:txBody>
-          <a:bodyPr wrap="square" anchor="t" lIns="73152" tIns="36576" rIns="73152" bIns="36576">
-            <a:normAutofit/>
-          </a:bodyPr>
-          <a:lstStyle/>
-          <a:p>
-            <a:pPr marL="0" indent="0" lvl="0" algn="ctr">
-              <a:lnSpc>
-                <a:spcPct val="98000"/>
-              </a:lnSpc>
-              <a:buNone/>
-            </a:pPr>
-            <a:r>
-              <a:rPr lang="es-ES" sz="1150" b="0" i="0" dirty="0">
-                <a:solidFill>
-                  <a:srgbClr val="333333"/>
-                </a:solidFill>
-                <a:latin typeface="Calibri"/>
-                <a:cs typeface="Calibri"/>
-              </a:rPr>
-              <a:t>Proyecto Omnicanalidad Retail</a:t>
-            </a:r>
-          </a:p>
-        </p:txBody>
-      </p:sp>
-      <p:sp>
-        <p:nvSpPr>
-          <p:cNvPr id="40" name="sp"/>
-          <p:cNvSpPr/>
-          <p:nvPr/>
-        </p:nvSpPr>
-        <p:spPr>
-          <a:xfrm>
-            <a:off x="566928" y="5897880"/>
-            <a:ext cx="256032" cy="256032"/>
-          </a:xfrm>
-          <a:prstGeom prst="ellipse">
-            <a:avLst/>
-          </a:prstGeom>
-          <a:solidFill>
-            <a:srgbClr val="123A5E"/>
-          </a:solidFill>
-          <a:ln>
-            <a:noFill/>
-          </a:ln>
-        </p:spPr>
-        <p:txBody>
-          <a:bodyPr/>
-          <a:lstStyle/>
-          <a:p>
-            <a:endParaRPr lang="es-ES"/>
-          </a:p>
-        </p:txBody>
-      </p:sp>
-      <p:sp>
-        <p:nvSpPr>
-          <p:cNvPr id="41" name="tb"/>
-          <p:cNvSpPr txBox="1"/>
-          <p:nvPr/>
-        </p:nvSpPr>
-        <p:spPr>
-          <a:xfrm>
-            <a:off x="868680" y="5852160"/>
-            <a:ext cx="2743200" cy="365760"/>
-          </a:xfrm>
-          <a:prstGeom prst="rect">
-            <a:avLst/>
-          </a:prstGeom>
-          <a:noFill/>
-        </p:spPr>
-        <p:txBody>
-          <a:bodyPr wrap="square" anchor="t" lIns="73152" tIns="36576" rIns="73152" bIns="36576">
-            <a:normAutofit/>
-          </a:bodyPr>
-          <a:lstStyle/>
-          <a:p>
             <a:pPr marL="0" indent="0" lvl="0" algn="l">
               <a:buNone/>
             </a:pPr>
             <a:r>
-              <a:rPr lang="es-ES" sz="1050" b="0" i="0" dirty="0">
+              <a:rPr lang="es-ES" sz="900" b="0" i="0" dirty="0">
                 <a:solidFill>
                   <a:srgbClr val="6B6B6B"/>
                 </a:solidFill>
                 <a:latin typeface="Calibri"/>
                 <a:cs typeface="Calibri"/>
               </a:rPr>
-              <a:t>Completado</a:t>
-            </a:r>
-          </a:p>
-        </p:txBody>
-      </p:sp>
-      <p:sp>
-        <p:nvSpPr>
-          <p:cNvPr id="42" name="sp"/>
-          <p:cNvSpPr/>
-          <p:nvPr/>
-        </p:nvSpPr>
-        <p:spPr>
-          <a:xfrm>
-            <a:off x="2468880" y="5897880"/>
-            <a:ext cx="256032" cy="256032"/>
-          </a:xfrm>
-          <a:prstGeom prst="ellipse">
-            <a:avLst/>
-          </a:prstGeom>
-          <a:solidFill>
-            <a:srgbClr val="E8711E"/>
-          </a:solidFill>
-          <a:ln>
-            <a:noFill/>
-          </a:ln>
-        </p:spPr>
-        <p:txBody>
-          <a:bodyPr/>
-          <a:lstStyle/>
-          <a:p>
-            <a:endParaRPr lang="es-ES"/>
-          </a:p>
-        </p:txBody>
-      </p:sp>
-      <p:sp>
-        <p:nvSpPr>
-          <p:cNvPr id="43" name="tb"/>
-          <p:cNvSpPr txBox="1"/>
-          <p:nvPr/>
-        </p:nvSpPr>
-        <p:spPr>
-          <a:xfrm>
-            <a:off x="2770632" y="5852160"/>
-            <a:ext cx="2743200" cy="365760"/>
-          </a:xfrm>
-          <a:prstGeom prst="rect">
-            <a:avLst/>
-          </a:prstGeom>
-          <a:noFill/>
-        </p:spPr>
-        <p:txBody>
-          <a:bodyPr wrap="square" anchor="t" lIns="73152" tIns="36576" rIns="73152" bIns="36576">
-            <a:normAutofit/>
-          </a:bodyPr>
-          <a:lstStyle/>
-          <a:p>
-            <a:pPr marL="0" indent="0" lvl="0" algn="l">
-              <a:buNone/>
-            </a:pPr>
-            <a:r>
-              <a:rPr lang="es-ES" sz="1050" b="0" i="0" dirty="0">
-                <a:solidFill>
-                  <a:srgbClr val="6B6B6B"/>
-                </a:solidFill>
-                <a:latin typeface="Calibri"/>
-                <a:cs typeface="Calibri"/>
-              </a:rPr>
-              <a:t>En curso / planificado</a:t>
+              <a:t>CAV  |  Programa de Transformacion Omnicanal y Ultima Milla</a:t>
             </a:r>
           </a:p>
         </p:txBody>
@@ -7111,7 +8026,7 @@
                 <a:latin typeface="Calibri"/>
                 <a:cs typeface="Calibri"/>
               </a:rPr>
-              <a:t>RESULTADOS EN CUATRO DIMENSIONES</a:t>
+              <a:t>HOJA DE RUTA DEL PROGRAMA</a:t>
             </a:r>
           </a:p>
         </p:txBody>
@@ -7149,7 +8064,7 @@
                 <a:latin typeface="Calibri"/>
                 <a:cs typeface="Calibri"/>
               </a:rPr>
-              <a:t>Impacto Esperado</a:t>
+              <a:t>Roadmap</a:t>
             </a:r>
           </a:p>
         </p:txBody>
@@ -7193,6 +8108,1585 @@
                 <a:cs typeface="Calibri"/>
               </a:rPr>
               <a:t>6</a:t>
+            </a:r>
+          </a:p>
+        </p:txBody>
+      </p:sp>
+      <p:sp>
+        <p:nvSpPr>
+          <p:cNvPr id="8" name="rule"/>
+          <p:cNvSpPr/>
+          <p:nvPr/>
+        </p:nvSpPr>
+        <p:spPr>
+          <a:xfrm>
+            <a:off x="0" y="1207008"/>
+            <a:ext cx="12192000" cy="45720"/>
+          </a:xfrm>
+          <a:prstGeom prst="rect">
+            <a:avLst/>
+          </a:prstGeom>
+          <a:solidFill>
+            <a:srgbClr val="E8711E"/>
+          </a:solidFill>
+          <a:ln>
+            <a:noFill/>
+          </a:ln>
+        </p:spPr>
+        <p:txBody>
+          <a:bodyPr/>
+          <a:lstStyle/>
+          <a:p>
+            <a:endParaRPr lang="es-ES"/>
+          </a:p>
+        </p:txBody>
+      </p:sp>
+      <p:sp>
+        <p:nvSpPr>
+          <p:cNvPr id="9" name="sp"/>
+          <p:cNvSpPr/>
+          <p:nvPr/>
+        </p:nvSpPr>
+        <p:spPr>
+          <a:xfrm>
+            <a:off x="822960" y="3429000"/>
+            <a:ext cx="10515600" cy="45720"/>
+          </a:xfrm>
+          <a:prstGeom prst="rect">
+            <a:avLst/>
+          </a:prstGeom>
+          <a:solidFill>
+            <a:srgbClr val="DCDCDC"/>
+          </a:solidFill>
+          <a:ln>
+            <a:noFill/>
+          </a:ln>
+        </p:spPr>
+        <p:txBody>
+          <a:bodyPr/>
+          <a:lstStyle/>
+          <a:p>
+            <a:endParaRPr lang="es-ES"/>
+          </a:p>
+        </p:txBody>
+      </p:sp>
+      <p:sp>
+        <p:nvSpPr>
+          <p:cNvPr id="10" name="sp"/>
+          <p:cNvSpPr/>
+          <p:nvPr/>
+        </p:nvSpPr>
+        <p:spPr>
+          <a:xfrm>
+            <a:off x="1584960" y="3218688"/>
+            <a:ext cx="457200" cy="457200"/>
+          </a:xfrm>
+          <a:prstGeom prst="ellipse">
+            <a:avLst/>
+          </a:prstGeom>
+          <a:solidFill>
+            <a:srgbClr val="123A5E"/>
+          </a:solidFill>
+          <a:ln>
+            <a:noFill/>
+          </a:ln>
+        </p:spPr>
+        <p:txBody>
+          <a:bodyPr wrap="square" anchor="ctr" lIns="73152" tIns="36576" rIns="73152" bIns="36576">
+            <a:normAutofit/>
+          </a:bodyPr>
+          <a:lstStyle/>
+          <a:p>
+            <a:pPr marL="0" indent="0" lvl="0" algn="ctr">
+              <a:buNone/>
+            </a:pPr>
+            <a:r>
+              <a:rPr lang="es-ES" sz="1500" b="1" i="0" dirty="0">
+                <a:solidFill>
+                  <a:srgbClr val="FFFFFF"/>
+                </a:solidFill>
+                <a:latin typeface="Calibri"/>
+                <a:cs typeface="Calibri"/>
+              </a:rPr>
+              <a:t>✓</a:t>
+            </a:r>
+          </a:p>
+        </p:txBody>
+      </p:sp>
+      <p:sp>
+        <p:nvSpPr>
+          <p:cNvPr id="11" name="sp"/>
+          <p:cNvSpPr/>
+          <p:nvPr/>
+        </p:nvSpPr>
+        <p:spPr>
+          <a:xfrm>
+            <a:off x="1051560" y="1737360"/>
+            <a:ext cx="1524000" cy="1371600"/>
+          </a:xfrm>
+          <a:prstGeom prst="roundRect">
+            <a:avLst/>
+          </a:prstGeom>
+          <a:solidFill>
+            <a:srgbClr val="FFFFFF"/>
+          </a:solidFill>
+          <a:ln w="9525">
+            <a:solidFill>
+              <a:srgbClr val="DCDCDC"/>
+            </a:solidFill>
+          </a:ln>
+          <a:effectLst>
+            <a:outerShdw blurRad="50000" dist="25000" dir="5400000" rotWithShape="0">
+              <a:srgbClr val="000000">
+                <a:alpha val="20000"/>
+              </a:srgbClr>
+            </a:outerShdw>
+          </a:effectLst>
+        </p:spPr>
+        <p:txBody>
+          <a:bodyPr/>
+          <a:lstStyle/>
+          <a:p>
+            <a:endParaRPr lang="es-ES"/>
+          </a:p>
+        </p:txBody>
+      </p:sp>
+      <p:sp>
+        <p:nvSpPr>
+          <p:cNvPr id="12" name="tb"/>
+          <p:cNvSpPr txBox="1"/>
+          <p:nvPr/>
+        </p:nvSpPr>
+        <p:spPr>
+          <a:xfrm>
+            <a:off x="1051560" y="1865376"/>
+            <a:ext cx="1524000" cy="365760"/>
+          </a:xfrm>
+          <a:prstGeom prst="rect">
+            <a:avLst/>
+          </a:prstGeom>
+          <a:noFill/>
+        </p:spPr>
+        <p:txBody>
+          <a:bodyPr wrap="square" anchor="t" lIns="73152" tIns="36576" rIns="73152" bIns="36576">
+            <a:normAutofit/>
+          </a:bodyPr>
+          <a:lstStyle/>
+          <a:p>
+            <a:pPr marL="0" indent="0" lvl="0" algn="ctr">
+              <a:buNone/>
+            </a:pPr>
+            <a:r>
+              <a:rPr lang="es-ES" sz="1050" b="1" i="0" dirty="0">
+                <a:solidFill>
+                  <a:srgbClr val="123A5E"/>
+                </a:solidFill>
+                <a:latin typeface="Calibri"/>
+                <a:cs typeface="Calibri"/>
+              </a:rPr>
+              <a:t>MAY - JUN</a:t>
+            </a:r>
+          </a:p>
+        </p:txBody>
+      </p:sp>
+      <p:sp>
+        <p:nvSpPr>
+          <p:cNvPr id="13" name="tb"/>
+          <p:cNvSpPr txBox="1"/>
+          <p:nvPr/>
+        </p:nvSpPr>
+        <p:spPr>
+          <a:xfrm>
+            <a:off x="1106424" y="2212848"/>
+            <a:ext cx="1414272" cy="822960"/>
+          </a:xfrm>
+          <a:prstGeom prst="rect">
+            <a:avLst/>
+          </a:prstGeom>
+          <a:noFill/>
+        </p:spPr>
+        <p:txBody>
+          <a:bodyPr wrap="square" anchor="t" lIns="73152" tIns="36576" rIns="73152" bIns="36576">
+            <a:normAutofit/>
+          </a:bodyPr>
+          <a:lstStyle/>
+          <a:p>
+            <a:pPr marL="0" indent="0" lvl="0" algn="ctr">
+              <a:lnSpc>
+                <a:spcPct val="98000"/>
+              </a:lnSpc>
+              <a:buNone/>
+            </a:pPr>
+            <a:r>
+              <a:rPr lang="es-ES" sz="1150" b="0" i="0" dirty="0">
+                <a:solidFill>
+                  <a:srgbClr val="333333"/>
+                </a:solidFill>
+                <a:latin typeface="Calibri"/>
+                <a:cs typeface="Calibri"/>
+              </a:rPr>
+              <a:t>Evaluacion IA SimpliRoute</a:t>
+            </a:r>
+          </a:p>
+        </p:txBody>
+      </p:sp>
+      <p:sp>
+        <p:nvSpPr>
+          <p:cNvPr id="14" name="sp"/>
+          <p:cNvSpPr/>
+          <p:nvPr/>
+        </p:nvSpPr>
+        <p:spPr>
+          <a:xfrm>
+            <a:off x="1804416" y="3108960"/>
+            <a:ext cx="18288" cy="320040"/>
+          </a:xfrm>
+          <a:prstGeom prst="rect">
+            <a:avLst/>
+          </a:prstGeom>
+          <a:solidFill>
+            <a:srgbClr val="123A5E"/>
+          </a:solidFill>
+          <a:ln>
+            <a:noFill/>
+          </a:ln>
+        </p:spPr>
+        <p:txBody>
+          <a:bodyPr/>
+          <a:lstStyle/>
+          <a:p>
+            <a:endParaRPr lang="es-ES"/>
+          </a:p>
+        </p:txBody>
+      </p:sp>
+      <p:sp>
+        <p:nvSpPr>
+          <p:cNvPr id="15" name="sp"/>
+          <p:cNvSpPr/>
+          <p:nvPr/>
+        </p:nvSpPr>
+        <p:spPr>
+          <a:xfrm>
+            <a:off x="3291840" y="3218688"/>
+            <a:ext cx="457200" cy="457200"/>
+          </a:xfrm>
+          <a:prstGeom prst="ellipse">
+            <a:avLst/>
+          </a:prstGeom>
+          <a:solidFill>
+            <a:srgbClr val="123A5E"/>
+          </a:solidFill>
+          <a:ln>
+            <a:noFill/>
+          </a:ln>
+        </p:spPr>
+        <p:txBody>
+          <a:bodyPr wrap="square" anchor="ctr" lIns="73152" tIns="36576" rIns="73152" bIns="36576">
+            <a:normAutofit/>
+          </a:bodyPr>
+          <a:lstStyle/>
+          <a:p>
+            <a:pPr marL="0" indent="0" lvl="0" algn="ctr">
+              <a:buNone/>
+            </a:pPr>
+            <a:r>
+              <a:rPr lang="es-ES" sz="1500" b="1" i="0" dirty="0">
+                <a:solidFill>
+                  <a:srgbClr val="FFFFFF"/>
+                </a:solidFill>
+                <a:latin typeface="Calibri"/>
+                <a:cs typeface="Calibri"/>
+              </a:rPr>
+              <a:t>✓</a:t>
+            </a:r>
+          </a:p>
+        </p:txBody>
+      </p:sp>
+      <p:sp>
+        <p:nvSpPr>
+          <p:cNvPr id="16" name="sp"/>
+          <p:cNvSpPr/>
+          <p:nvPr/>
+        </p:nvSpPr>
+        <p:spPr>
+          <a:xfrm>
+            <a:off x="3511296" y="3429000"/>
+            <a:ext cx="18288" cy="320040"/>
+          </a:xfrm>
+          <a:prstGeom prst="rect">
+            <a:avLst/>
+          </a:prstGeom>
+          <a:solidFill>
+            <a:srgbClr val="123A5E"/>
+          </a:solidFill>
+          <a:ln>
+            <a:noFill/>
+          </a:ln>
+        </p:spPr>
+        <p:txBody>
+          <a:bodyPr/>
+          <a:lstStyle/>
+          <a:p>
+            <a:endParaRPr lang="es-ES"/>
+          </a:p>
+        </p:txBody>
+      </p:sp>
+      <p:sp>
+        <p:nvSpPr>
+          <p:cNvPr id="17" name="sp"/>
+          <p:cNvSpPr/>
+          <p:nvPr/>
+        </p:nvSpPr>
+        <p:spPr>
+          <a:xfrm>
+            <a:off x="2758440" y="3749040"/>
+            <a:ext cx="1524000" cy="1371600"/>
+          </a:xfrm>
+          <a:prstGeom prst="roundRect">
+            <a:avLst/>
+          </a:prstGeom>
+          <a:solidFill>
+            <a:srgbClr val="FFFFFF"/>
+          </a:solidFill>
+          <a:ln w="9525">
+            <a:solidFill>
+              <a:srgbClr val="DCDCDC"/>
+            </a:solidFill>
+          </a:ln>
+          <a:effectLst>
+            <a:outerShdw blurRad="50000" dist="25000" dir="5400000" rotWithShape="0">
+              <a:srgbClr val="000000">
+                <a:alpha val="20000"/>
+              </a:srgbClr>
+            </a:outerShdw>
+          </a:effectLst>
+        </p:spPr>
+        <p:txBody>
+          <a:bodyPr/>
+          <a:lstStyle/>
+          <a:p>
+            <a:endParaRPr lang="es-ES"/>
+          </a:p>
+        </p:txBody>
+      </p:sp>
+      <p:sp>
+        <p:nvSpPr>
+          <p:cNvPr id="18" name="tb"/>
+          <p:cNvSpPr txBox="1"/>
+          <p:nvPr/>
+        </p:nvSpPr>
+        <p:spPr>
+          <a:xfrm>
+            <a:off x="2758440" y="3877056"/>
+            <a:ext cx="1524000" cy="365760"/>
+          </a:xfrm>
+          <a:prstGeom prst="rect">
+            <a:avLst/>
+          </a:prstGeom>
+          <a:noFill/>
+        </p:spPr>
+        <p:txBody>
+          <a:bodyPr wrap="square" anchor="t" lIns="73152" tIns="36576" rIns="73152" bIns="36576">
+            <a:normAutofit/>
+          </a:bodyPr>
+          <a:lstStyle/>
+          <a:p>
+            <a:pPr marL="0" indent="0" lvl="0" algn="ctr">
+              <a:buNone/>
+            </a:pPr>
+            <a:r>
+              <a:rPr lang="es-ES" sz="1050" b="1" i="0" dirty="0">
+                <a:solidFill>
+                  <a:srgbClr val="123A5E"/>
+                </a:solidFill>
+                <a:latin typeface="Calibri"/>
+                <a:cs typeface="Calibri"/>
+              </a:rPr>
+              <a:t>JUNIO</a:t>
+            </a:r>
+          </a:p>
+        </p:txBody>
+      </p:sp>
+      <p:sp>
+        <p:nvSpPr>
+          <p:cNvPr id="19" name="tb"/>
+          <p:cNvSpPr txBox="1"/>
+          <p:nvPr/>
+        </p:nvSpPr>
+        <p:spPr>
+          <a:xfrm>
+            <a:off x="2813304" y="4224528"/>
+            <a:ext cx="1414272" cy="822960"/>
+          </a:xfrm>
+          <a:prstGeom prst="rect">
+            <a:avLst/>
+          </a:prstGeom>
+          <a:noFill/>
+        </p:spPr>
+        <p:txBody>
+          <a:bodyPr wrap="square" anchor="t" lIns="73152" tIns="36576" rIns="73152" bIns="36576">
+            <a:normAutofit/>
+          </a:bodyPr>
+          <a:lstStyle/>
+          <a:p>
+            <a:pPr marL="0" indent="0" lvl="0" algn="ctr">
+              <a:lnSpc>
+                <a:spcPct val="98000"/>
+              </a:lnSpc>
+              <a:buNone/>
+            </a:pPr>
+            <a:r>
+              <a:rPr lang="es-ES" sz="1150" b="0" i="0" dirty="0">
+                <a:solidFill>
+                  <a:srgbClr val="333333"/>
+                </a:solidFill>
+                <a:latin typeface="Calibri"/>
+                <a:cs typeface="Calibri"/>
+              </a:rPr>
+              <a:t>Correccion masiva base de clientes</a:t>
+            </a:r>
+          </a:p>
+        </p:txBody>
+      </p:sp>
+      <p:sp>
+        <p:nvSpPr>
+          <p:cNvPr id="20" name="sp"/>
+          <p:cNvSpPr/>
+          <p:nvPr/>
+        </p:nvSpPr>
+        <p:spPr>
+          <a:xfrm>
+            <a:off x="4998720" y="3218688"/>
+            <a:ext cx="457200" cy="457200"/>
+          </a:xfrm>
+          <a:prstGeom prst="ellipse">
+            <a:avLst/>
+          </a:prstGeom>
+          <a:solidFill>
+            <a:srgbClr val="1C5A8C"/>
+          </a:solidFill>
+          <a:ln>
+            <a:noFill/>
+          </a:ln>
+        </p:spPr>
+        <p:txBody>
+          <a:bodyPr wrap="square" anchor="ctr" lIns="73152" tIns="36576" rIns="73152" bIns="36576">
+            <a:normAutofit/>
+          </a:bodyPr>
+          <a:lstStyle/>
+          <a:p>
+            <a:pPr marL="0" indent="0" lvl="0" algn="ctr">
+              <a:buNone/>
+            </a:pPr>
+            <a:r>
+              <a:rPr lang="es-ES" sz="1500" b="1" i="0" dirty="0">
+                <a:solidFill>
+                  <a:srgbClr val="FFFFFF"/>
+                </a:solidFill>
+                <a:latin typeface="Calibri"/>
+                <a:cs typeface="Calibri"/>
+              </a:rPr>
+              <a:t>✓</a:t>
+            </a:r>
+          </a:p>
+        </p:txBody>
+      </p:sp>
+      <p:sp>
+        <p:nvSpPr>
+          <p:cNvPr id="21" name="sp"/>
+          <p:cNvSpPr/>
+          <p:nvPr/>
+        </p:nvSpPr>
+        <p:spPr>
+          <a:xfrm>
+            <a:off x="4465320" y="1737360"/>
+            <a:ext cx="1524000" cy="1371600"/>
+          </a:xfrm>
+          <a:prstGeom prst="roundRect">
+            <a:avLst/>
+          </a:prstGeom>
+          <a:solidFill>
+            <a:srgbClr val="FFFFFF"/>
+          </a:solidFill>
+          <a:ln w="9525">
+            <a:solidFill>
+              <a:srgbClr val="DCDCDC"/>
+            </a:solidFill>
+          </a:ln>
+          <a:effectLst>
+            <a:outerShdw blurRad="50000" dist="25000" dir="5400000" rotWithShape="0">
+              <a:srgbClr val="000000">
+                <a:alpha val="20000"/>
+              </a:srgbClr>
+            </a:outerShdw>
+          </a:effectLst>
+        </p:spPr>
+        <p:txBody>
+          <a:bodyPr/>
+          <a:lstStyle/>
+          <a:p>
+            <a:endParaRPr lang="es-ES"/>
+          </a:p>
+        </p:txBody>
+      </p:sp>
+      <p:sp>
+        <p:nvSpPr>
+          <p:cNvPr id="22" name="tb"/>
+          <p:cNvSpPr txBox="1"/>
+          <p:nvPr/>
+        </p:nvSpPr>
+        <p:spPr>
+          <a:xfrm>
+            <a:off x="4465320" y="1865376"/>
+            <a:ext cx="1524000" cy="365760"/>
+          </a:xfrm>
+          <a:prstGeom prst="rect">
+            <a:avLst/>
+          </a:prstGeom>
+          <a:noFill/>
+        </p:spPr>
+        <p:txBody>
+          <a:bodyPr wrap="square" anchor="t" lIns="73152" tIns="36576" rIns="73152" bIns="36576">
+            <a:normAutofit/>
+          </a:bodyPr>
+          <a:lstStyle/>
+          <a:p>
+            <a:pPr marL="0" indent="0" lvl="0" algn="ctr">
+              <a:buNone/>
+            </a:pPr>
+            <a:r>
+              <a:rPr lang="es-ES" sz="1050" b="1" i="0" dirty="0">
+                <a:solidFill>
+                  <a:srgbClr val="1C5A8C"/>
+                </a:solidFill>
+                <a:latin typeface="Calibri"/>
+                <a:cs typeface="Calibri"/>
+              </a:rPr>
+              <a:t>JUN - JUL</a:t>
+            </a:r>
+          </a:p>
+        </p:txBody>
+      </p:sp>
+      <p:sp>
+        <p:nvSpPr>
+          <p:cNvPr id="23" name="tb"/>
+          <p:cNvSpPr txBox="1"/>
+          <p:nvPr/>
+        </p:nvSpPr>
+        <p:spPr>
+          <a:xfrm>
+            <a:off x="4520184" y="2212848"/>
+            <a:ext cx="1414272" cy="822960"/>
+          </a:xfrm>
+          <a:prstGeom prst="rect">
+            <a:avLst/>
+          </a:prstGeom>
+          <a:noFill/>
+        </p:spPr>
+        <p:txBody>
+          <a:bodyPr wrap="square" anchor="t" lIns="73152" tIns="36576" rIns="73152" bIns="36576">
+            <a:normAutofit/>
+          </a:bodyPr>
+          <a:lstStyle/>
+          <a:p>
+            <a:pPr marL="0" indent="0" lvl="0" algn="ctr">
+              <a:lnSpc>
+                <a:spcPct val="98000"/>
+              </a:lnSpc>
+              <a:buNone/>
+            </a:pPr>
+            <a:r>
+              <a:rPr lang="es-ES" sz="1150" b="0" i="0" dirty="0">
+                <a:solidFill>
+                  <a:srgbClr val="333333"/>
+                </a:solidFill>
+                <a:latin typeface="Calibri"/>
+                <a:cs typeface="Calibri"/>
+              </a:rPr>
+              <a:t>Desarrollo formularios normalizados</a:t>
+            </a:r>
+          </a:p>
+        </p:txBody>
+      </p:sp>
+      <p:sp>
+        <p:nvSpPr>
+          <p:cNvPr id="24" name="sp"/>
+          <p:cNvSpPr/>
+          <p:nvPr/>
+        </p:nvSpPr>
+        <p:spPr>
+          <a:xfrm>
+            <a:off x="5218176" y="3108960"/>
+            <a:ext cx="18288" cy="320040"/>
+          </a:xfrm>
+          <a:prstGeom prst="rect">
+            <a:avLst/>
+          </a:prstGeom>
+          <a:solidFill>
+            <a:srgbClr val="1C5A8C"/>
+          </a:solidFill>
+          <a:ln>
+            <a:noFill/>
+          </a:ln>
+        </p:spPr>
+        <p:txBody>
+          <a:bodyPr/>
+          <a:lstStyle/>
+          <a:p>
+            <a:endParaRPr lang="es-ES"/>
+          </a:p>
+        </p:txBody>
+      </p:sp>
+      <p:sp>
+        <p:nvSpPr>
+          <p:cNvPr id="25" name="sp"/>
+          <p:cNvSpPr/>
+          <p:nvPr/>
+        </p:nvSpPr>
+        <p:spPr>
+          <a:xfrm>
+            <a:off x="6705600" y="3218688"/>
+            <a:ext cx="457200" cy="457200"/>
+          </a:xfrm>
+          <a:prstGeom prst="ellipse">
+            <a:avLst/>
+          </a:prstGeom>
+          <a:solidFill>
+            <a:srgbClr val="1C5A8C"/>
+          </a:solidFill>
+          <a:ln>
+            <a:noFill/>
+          </a:ln>
+        </p:spPr>
+        <p:txBody>
+          <a:bodyPr wrap="square" anchor="ctr" lIns="73152" tIns="36576" rIns="73152" bIns="36576">
+            <a:normAutofit/>
+          </a:bodyPr>
+          <a:lstStyle/>
+          <a:p>
+            <a:pPr marL="0" indent="0" lvl="0" algn="ctr">
+              <a:buNone/>
+            </a:pPr>
+            <a:r>
+              <a:rPr lang="es-ES" sz="1500" b="1" i="0" dirty="0">
+                <a:solidFill>
+                  <a:srgbClr val="FFFFFF"/>
+                </a:solidFill>
+                <a:latin typeface="Calibri"/>
+                <a:cs typeface="Calibri"/>
+              </a:rPr>
+              <a:t>✓</a:t>
+            </a:r>
+          </a:p>
+        </p:txBody>
+      </p:sp>
+      <p:sp>
+        <p:nvSpPr>
+          <p:cNvPr id="26" name="sp"/>
+          <p:cNvSpPr/>
+          <p:nvPr/>
+        </p:nvSpPr>
+        <p:spPr>
+          <a:xfrm>
+            <a:off x="6925056" y="3429000"/>
+            <a:ext cx="18288" cy="320040"/>
+          </a:xfrm>
+          <a:prstGeom prst="rect">
+            <a:avLst/>
+          </a:prstGeom>
+          <a:solidFill>
+            <a:srgbClr val="1C5A8C"/>
+          </a:solidFill>
+          <a:ln>
+            <a:noFill/>
+          </a:ln>
+        </p:spPr>
+        <p:txBody>
+          <a:bodyPr/>
+          <a:lstStyle/>
+          <a:p>
+            <a:endParaRPr lang="es-ES"/>
+          </a:p>
+        </p:txBody>
+      </p:sp>
+      <p:sp>
+        <p:nvSpPr>
+          <p:cNvPr id="27" name="sp"/>
+          <p:cNvSpPr/>
+          <p:nvPr/>
+        </p:nvSpPr>
+        <p:spPr>
+          <a:xfrm>
+            <a:off x="6172200" y="3749040"/>
+            <a:ext cx="1524000" cy="1371600"/>
+          </a:xfrm>
+          <a:prstGeom prst="roundRect">
+            <a:avLst/>
+          </a:prstGeom>
+          <a:solidFill>
+            <a:srgbClr val="FFFFFF"/>
+          </a:solidFill>
+          <a:ln w="9525">
+            <a:solidFill>
+              <a:srgbClr val="DCDCDC"/>
+            </a:solidFill>
+          </a:ln>
+          <a:effectLst>
+            <a:outerShdw blurRad="50000" dist="25000" dir="5400000" rotWithShape="0">
+              <a:srgbClr val="000000">
+                <a:alpha val="20000"/>
+              </a:srgbClr>
+            </a:outerShdw>
+          </a:effectLst>
+        </p:spPr>
+        <p:txBody>
+          <a:bodyPr/>
+          <a:lstStyle/>
+          <a:p>
+            <a:endParaRPr lang="es-ES"/>
+          </a:p>
+        </p:txBody>
+      </p:sp>
+      <p:sp>
+        <p:nvSpPr>
+          <p:cNvPr id="28" name="tb"/>
+          <p:cNvSpPr txBox="1"/>
+          <p:nvPr/>
+        </p:nvSpPr>
+        <p:spPr>
+          <a:xfrm>
+            <a:off x="6172200" y="3877056"/>
+            <a:ext cx="1524000" cy="365760"/>
+          </a:xfrm>
+          <a:prstGeom prst="rect">
+            <a:avLst/>
+          </a:prstGeom>
+          <a:noFill/>
+        </p:spPr>
+        <p:txBody>
+          <a:bodyPr wrap="square" anchor="t" lIns="73152" tIns="36576" rIns="73152" bIns="36576">
+            <a:normAutofit/>
+          </a:bodyPr>
+          <a:lstStyle/>
+          <a:p>
+            <a:pPr marL="0" indent="0" lvl="0" algn="ctr">
+              <a:buNone/>
+            </a:pPr>
+            <a:r>
+              <a:rPr lang="es-ES" sz="1050" b="1" i="0" dirty="0">
+                <a:solidFill>
+                  <a:srgbClr val="1C5A8C"/>
+                </a:solidFill>
+                <a:latin typeface="Calibri"/>
+                <a:cs typeface="Calibri"/>
+              </a:rPr>
+              <a:t>JULIO</a:t>
+            </a:r>
+          </a:p>
+        </p:txBody>
+      </p:sp>
+      <p:sp>
+        <p:nvSpPr>
+          <p:cNvPr id="29" name="tb"/>
+          <p:cNvSpPr txBox="1"/>
+          <p:nvPr/>
+        </p:nvSpPr>
+        <p:spPr>
+          <a:xfrm>
+            <a:off x="6227064" y="4224528"/>
+            <a:ext cx="1414272" cy="822960"/>
+          </a:xfrm>
+          <a:prstGeom prst="rect">
+            <a:avLst/>
+          </a:prstGeom>
+          <a:noFill/>
+        </p:spPr>
+        <p:txBody>
+          <a:bodyPr wrap="square" anchor="t" lIns="73152" tIns="36576" rIns="73152" bIns="36576">
+            <a:normAutofit/>
+          </a:bodyPr>
+          <a:lstStyle/>
+          <a:p>
+            <a:pPr marL="0" indent="0" lvl="0" algn="ctr">
+              <a:lnSpc>
+                <a:spcPct val="98000"/>
+              </a:lnSpc>
+              <a:buNone/>
+            </a:pPr>
+            <a:r>
+              <a:rPr lang="es-ES" sz="1150" b="0" i="0" dirty="0">
+                <a:solidFill>
+                  <a:srgbClr val="333333"/>
+                </a:solidFill>
+                <a:latin typeface="Calibri"/>
+                <a:cs typeface="Calibri"/>
+              </a:rPr>
+              <a:t>Implementacion Agente IA</a:t>
+            </a:r>
+          </a:p>
+        </p:txBody>
+      </p:sp>
+      <p:sp>
+        <p:nvSpPr>
+          <p:cNvPr id="30" name="sp"/>
+          <p:cNvSpPr/>
+          <p:nvPr/>
+        </p:nvSpPr>
+        <p:spPr>
+          <a:xfrm>
+            <a:off x="8412480" y="3218688"/>
+            <a:ext cx="457200" cy="457200"/>
+          </a:xfrm>
+          <a:prstGeom prst="ellipse">
+            <a:avLst/>
+          </a:prstGeom>
+          <a:solidFill>
+            <a:srgbClr val="E8711E"/>
+          </a:solidFill>
+          <a:ln>
+            <a:noFill/>
+          </a:ln>
+        </p:spPr>
+        <p:txBody>
+          <a:bodyPr wrap="square" anchor="ctr" lIns="73152" tIns="36576" rIns="73152" bIns="36576">
+            <a:normAutofit/>
+          </a:bodyPr>
+          <a:lstStyle/>
+          <a:p>
+            <a:pPr marL="0" indent="0" lvl="0" algn="ctr">
+              <a:buNone/>
+            </a:pPr>
+            <a:r>
+              <a:rPr lang="es-ES" sz="1500" b="1" i="0" dirty="0">
+                <a:solidFill>
+                  <a:srgbClr val="FFFFFF"/>
+                </a:solidFill>
+                <a:latin typeface="Calibri"/>
+                <a:cs typeface="Calibri"/>
+              </a:rPr>
+              <a:t>~</a:t>
+            </a:r>
+          </a:p>
+        </p:txBody>
+      </p:sp>
+      <p:sp>
+        <p:nvSpPr>
+          <p:cNvPr id="31" name="sp"/>
+          <p:cNvSpPr/>
+          <p:nvPr/>
+        </p:nvSpPr>
+        <p:spPr>
+          <a:xfrm>
+            <a:off x="7879080" y="1737360"/>
+            <a:ext cx="1524000" cy="1371600"/>
+          </a:xfrm>
+          <a:prstGeom prst="roundRect">
+            <a:avLst/>
+          </a:prstGeom>
+          <a:solidFill>
+            <a:srgbClr val="FFFFFF"/>
+          </a:solidFill>
+          <a:ln w="9525">
+            <a:solidFill>
+              <a:srgbClr val="DCDCDC"/>
+            </a:solidFill>
+          </a:ln>
+          <a:effectLst>
+            <a:outerShdw blurRad="50000" dist="25000" dir="5400000" rotWithShape="0">
+              <a:srgbClr val="000000">
+                <a:alpha val="20000"/>
+              </a:srgbClr>
+            </a:outerShdw>
+          </a:effectLst>
+        </p:spPr>
+        <p:txBody>
+          <a:bodyPr/>
+          <a:lstStyle/>
+          <a:p>
+            <a:endParaRPr lang="es-ES"/>
+          </a:p>
+        </p:txBody>
+      </p:sp>
+      <p:sp>
+        <p:nvSpPr>
+          <p:cNvPr id="32" name="tb"/>
+          <p:cNvSpPr txBox="1"/>
+          <p:nvPr/>
+        </p:nvSpPr>
+        <p:spPr>
+          <a:xfrm>
+            <a:off x="7879080" y="1865376"/>
+            <a:ext cx="1524000" cy="365760"/>
+          </a:xfrm>
+          <a:prstGeom prst="rect">
+            <a:avLst/>
+          </a:prstGeom>
+          <a:noFill/>
+        </p:spPr>
+        <p:txBody>
+          <a:bodyPr wrap="square" anchor="t" lIns="73152" tIns="36576" rIns="73152" bIns="36576">
+            <a:normAutofit/>
+          </a:bodyPr>
+          <a:lstStyle/>
+          <a:p>
+            <a:pPr marL="0" indent="0" lvl="0" algn="ctr">
+              <a:buNone/>
+            </a:pPr>
+            <a:r>
+              <a:rPr lang="es-ES" sz="1050" b="1" i="0" dirty="0">
+                <a:solidFill>
+                  <a:srgbClr val="E8711E"/>
+                </a:solidFill>
+                <a:latin typeface="Calibri"/>
+                <a:cs typeface="Calibri"/>
+              </a:rPr>
+              <a:t>AGO - SEP</a:t>
+            </a:r>
+          </a:p>
+        </p:txBody>
+      </p:sp>
+      <p:sp>
+        <p:nvSpPr>
+          <p:cNvPr id="33" name="tb"/>
+          <p:cNvSpPr txBox="1"/>
+          <p:nvPr/>
+        </p:nvSpPr>
+        <p:spPr>
+          <a:xfrm>
+            <a:off x="7933944" y="2212848"/>
+            <a:ext cx="1414272" cy="822960"/>
+          </a:xfrm>
+          <a:prstGeom prst="rect">
+            <a:avLst/>
+          </a:prstGeom>
+          <a:noFill/>
+        </p:spPr>
+        <p:txBody>
+          <a:bodyPr wrap="square" anchor="t" lIns="73152" tIns="36576" rIns="73152" bIns="36576">
+            <a:normAutofit/>
+          </a:bodyPr>
+          <a:lstStyle/>
+          <a:p>
+            <a:pPr marL="0" indent="0" lvl="0" algn="ctr">
+              <a:lnSpc>
+                <a:spcPct val="98000"/>
+              </a:lnSpc>
+              <a:buNone/>
+            </a:pPr>
+            <a:r>
+              <a:rPr lang="es-ES" sz="1150" b="0" i="0" dirty="0">
+                <a:solidFill>
+                  <a:srgbClr val="333333"/>
+                </a:solidFill>
+                <a:latin typeface="Calibri"/>
+                <a:cs typeface="Calibri"/>
+              </a:rPr>
+              <a:t>Expansion Same Day RM</a:t>
+            </a:r>
+          </a:p>
+        </p:txBody>
+      </p:sp>
+      <p:sp>
+        <p:nvSpPr>
+          <p:cNvPr id="34" name="sp"/>
+          <p:cNvSpPr/>
+          <p:nvPr/>
+        </p:nvSpPr>
+        <p:spPr>
+          <a:xfrm>
+            <a:off x="8631936" y="3108960"/>
+            <a:ext cx="18288" cy="320040"/>
+          </a:xfrm>
+          <a:prstGeom prst="rect">
+            <a:avLst/>
+          </a:prstGeom>
+          <a:solidFill>
+            <a:srgbClr val="E8711E"/>
+          </a:solidFill>
+          <a:ln>
+            <a:noFill/>
+          </a:ln>
+        </p:spPr>
+        <p:txBody>
+          <a:bodyPr/>
+          <a:lstStyle/>
+          <a:p>
+            <a:endParaRPr lang="es-ES"/>
+          </a:p>
+        </p:txBody>
+      </p:sp>
+      <p:sp>
+        <p:nvSpPr>
+          <p:cNvPr id="35" name="sp"/>
+          <p:cNvSpPr/>
+          <p:nvPr/>
+        </p:nvSpPr>
+        <p:spPr>
+          <a:xfrm>
+            <a:off x="10119360" y="3218688"/>
+            <a:ext cx="457200" cy="457200"/>
+          </a:xfrm>
+          <a:prstGeom prst="ellipse">
+            <a:avLst/>
+          </a:prstGeom>
+          <a:solidFill>
+            <a:srgbClr val="E8711E"/>
+          </a:solidFill>
+          <a:ln>
+            <a:noFill/>
+          </a:ln>
+        </p:spPr>
+        <p:txBody>
+          <a:bodyPr wrap="square" anchor="ctr" lIns="73152" tIns="36576" rIns="73152" bIns="36576">
+            <a:normAutofit/>
+          </a:bodyPr>
+          <a:lstStyle/>
+          <a:p>
+            <a:pPr marL="0" indent="0" lvl="0" algn="ctr">
+              <a:buNone/>
+            </a:pPr>
+            <a:r>
+              <a:rPr lang="es-ES" sz="1500" b="1" i="0" dirty="0">
+                <a:solidFill>
+                  <a:srgbClr val="FFFFFF"/>
+                </a:solidFill>
+                <a:latin typeface="Calibri"/>
+                <a:cs typeface="Calibri"/>
+              </a:rPr>
+              <a:t>~</a:t>
+            </a:r>
+          </a:p>
+        </p:txBody>
+      </p:sp>
+      <p:sp>
+        <p:nvSpPr>
+          <p:cNvPr id="36" name="sp"/>
+          <p:cNvSpPr/>
+          <p:nvPr/>
+        </p:nvSpPr>
+        <p:spPr>
+          <a:xfrm>
+            <a:off x="10338816" y="3429000"/>
+            <a:ext cx="18288" cy="320040"/>
+          </a:xfrm>
+          <a:prstGeom prst="rect">
+            <a:avLst/>
+          </a:prstGeom>
+          <a:solidFill>
+            <a:srgbClr val="E8711E"/>
+          </a:solidFill>
+          <a:ln>
+            <a:noFill/>
+          </a:ln>
+        </p:spPr>
+        <p:txBody>
+          <a:bodyPr/>
+          <a:lstStyle/>
+          <a:p>
+            <a:endParaRPr lang="es-ES"/>
+          </a:p>
+        </p:txBody>
+      </p:sp>
+      <p:sp>
+        <p:nvSpPr>
+          <p:cNvPr id="37" name="sp"/>
+          <p:cNvSpPr/>
+          <p:nvPr/>
+        </p:nvSpPr>
+        <p:spPr>
+          <a:xfrm>
+            <a:off x="9585960" y="3749040"/>
+            <a:ext cx="1524000" cy="1371600"/>
+          </a:xfrm>
+          <a:prstGeom prst="roundRect">
+            <a:avLst/>
+          </a:prstGeom>
+          <a:solidFill>
+            <a:srgbClr val="FFFFFF"/>
+          </a:solidFill>
+          <a:ln w="9525">
+            <a:solidFill>
+              <a:srgbClr val="DCDCDC"/>
+            </a:solidFill>
+          </a:ln>
+          <a:effectLst>
+            <a:outerShdw blurRad="50000" dist="25000" dir="5400000" rotWithShape="0">
+              <a:srgbClr val="000000">
+                <a:alpha val="20000"/>
+              </a:srgbClr>
+            </a:outerShdw>
+          </a:effectLst>
+        </p:spPr>
+        <p:txBody>
+          <a:bodyPr/>
+          <a:lstStyle/>
+          <a:p>
+            <a:endParaRPr lang="es-ES"/>
+          </a:p>
+        </p:txBody>
+      </p:sp>
+      <p:sp>
+        <p:nvSpPr>
+          <p:cNvPr id="38" name="tb"/>
+          <p:cNvSpPr txBox="1"/>
+          <p:nvPr/>
+        </p:nvSpPr>
+        <p:spPr>
+          <a:xfrm>
+            <a:off x="9585960" y="3877056"/>
+            <a:ext cx="1524000" cy="365760"/>
+          </a:xfrm>
+          <a:prstGeom prst="rect">
+            <a:avLst/>
+          </a:prstGeom>
+          <a:noFill/>
+        </p:spPr>
+        <p:txBody>
+          <a:bodyPr wrap="square" anchor="t" lIns="73152" tIns="36576" rIns="73152" bIns="36576">
+            <a:normAutofit/>
+          </a:bodyPr>
+          <a:lstStyle/>
+          <a:p>
+            <a:pPr marL="0" indent="0" lvl="0" algn="ctr">
+              <a:buNone/>
+            </a:pPr>
+            <a:r>
+              <a:rPr lang="es-ES" sz="1050" b="1" i="0" dirty="0">
+                <a:solidFill>
+                  <a:srgbClr val="E8711E"/>
+                </a:solidFill>
+                <a:latin typeface="Calibri"/>
+                <a:cs typeface="Calibri"/>
+              </a:rPr>
+              <a:t>SEP - OCT</a:t>
+            </a:r>
+          </a:p>
+        </p:txBody>
+      </p:sp>
+      <p:sp>
+        <p:nvSpPr>
+          <p:cNvPr id="39" name="tb"/>
+          <p:cNvSpPr txBox="1"/>
+          <p:nvPr/>
+        </p:nvSpPr>
+        <p:spPr>
+          <a:xfrm>
+            <a:off x="9640824" y="4224528"/>
+            <a:ext cx="1414272" cy="822960"/>
+          </a:xfrm>
+          <a:prstGeom prst="rect">
+            <a:avLst/>
+          </a:prstGeom>
+          <a:noFill/>
+        </p:spPr>
+        <p:txBody>
+          <a:bodyPr wrap="square" anchor="t" lIns="73152" tIns="36576" rIns="73152" bIns="36576">
+            <a:normAutofit/>
+          </a:bodyPr>
+          <a:lstStyle/>
+          <a:p>
+            <a:pPr marL="0" indent="0" lvl="0" algn="ctr">
+              <a:lnSpc>
+                <a:spcPct val="98000"/>
+              </a:lnSpc>
+              <a:buNone/>
+            </a:pPr>
+            <a:r>
+              <a:rPr lang="es-ES" sz="1150" b="0" i="0" dirty="0">
+                <a:solidFill>
+                  <a:srgbClr val="333333"/>
+                </a:solidFill>
+                <a:latin typeface="Calibri"/>
+                <a:cs typeface="Calibri"/>
+              </a:rPr>
+              <a:t>Proyecto Omnicanalidad Retail</a:t>
+            </a:r>
+          </a:p>
+        </p:txBody>
+      </p:sp>
+      <p:sp>
+        <p:nvSpPr>
+          <p:cNvPr id="40" name="sp"/>
+          <p:cNvSpPr/>
+          <p:nvPr/>
+        </p:nvSpPr>
+        <p:spPr>
+          <a:xfrm>
+            <a:off x="566928" y="5897880"/>
+            <a:ext cx="256032" cy="256032"/>
+          </a:xfrm>
+          <a:prstGeom prst="ellipse">
+            <a:avLst/>
+          </a:prstGeom>
+          <a:solidFill>
+            <a:srgbClr val="123A5E"/>
+          </a:solidFill>
+          <a:ln>
+            <a:noFill/>
+          </a:ln>
+        </p:spPr>
+        <p:txBody>
+          <a:bodyPr/>
+          <a:lstStyle/>
+          <a:p>
+            <a:endParaRPr lang="es-ES"/>
+          </a:p>
+        </p:txBody>
+      </p:sp>
+      <p:sp>
+        <p:nvSpPr>
+          <p:cNvPr id="41" name="tb"/>
+          <p:cNvSpPr txBox="1"/>
+          <p:nvPr/>
+        </p:nvSpPr>
+        <p:spPr>
+          <a:xfrm>
+            <a:off x="868680" y="5852160"/>
+            <a:ext cx="2743200" cy="365760"/>
+          </a:xfrm>
+          <a:prstGeom prst="rect">
+            <a:avLst/>
+          </a:prstGeom>
+          <a:noFill/>
+        </p:spPr>
+        <p:txBody>
+          <a:bodyPr wrap="square" anchor="t" lIns="73152" tIns="36576" rIns="73152" bIns="36576">
+            <a:normAutofit/>
+          </a:bodyPr>
+          <a:lstStyle/>
+          <a:p>
+            <a:pPr marL="0" indent="0" lvl="0" algn="l">
+              <a:buNone/>
+            </a:pPr>
+            <a:r>
+              <a:rPr lang="es-ES" sz="1050" b="0" i="0" dirty="0">
+                <a:solidFill>
+                  <a:srgbClr val="6B6B6B"/>
+                </a:solidFill>
+                <a:latin typeface="Calibri"/>
+                <a:cs typeface="Calibri"/>
+              </a:rPr>
+              <a:t>Completado</a:t>
+            </a:r>
+          </a:p>
+        </p:txBody>
+      </p:sp>
+      <p:sp>
+        <p:nvSpPr>
+          <p:cNvPr id="42" name="sp"/>
+          <p:cNvSpPr/>
+          <p:nvPr/>
+        </p:nvSpPr>
+        <p:spPr>
+          <a:xfrm>
+            <a:off x="2468880" y="5897880"/>
+            <a:ext cx="256032" cy="256032"/>
+          </a:xfrm>
+          <a:prstGeom prst="ellipse">
+            <a:avLst/>
+          </a:prstGeom>
+          <a:solidFill>
+            <a:srgbClr val="E8711E"/>
+          </a:solidFill>
+          <a:ln>
+            <a:noFill/>
+          </a:ln>
+        </p:spPr>
+        <p:txBody>
+          <a:bodyPr/>
+          <a:lstStyle/>
+          <a:p>
+            <a:endParaRPr lang="es-ES"/>
+          </a:p>
+        </p:txBody>
+      </p:sp>
+      <p:sp>
+        <p:nvSpPr>
+          <p:cNvPr id="43" name="tb"/>
+          <p:cNvSpPr txBox="1"/>
+          <p:nvPr/>
+        </p:nvSpPr>
+        <p:spPr>
+          <a:xfrm>
+            <a:off x="2770632" y="5852160"/>
+            <a:ext cx="2743200" cy="365760"/>
+          </a:xfrm>
+          <a:prstGeom prst="rect">
+            <a:avLst/>
+          </a:prstGeom>
+          <a:noFill/>
+        </p:spPr>
+        <p:txBody>
+          <a:bodyPr wrap="square" anchor="t" lIns="73152" tIns="36576" rIns="73152" bIns="36576">
+            <a:normAutofit/>
+          </a:bodyPr>
+          <a:lstStyle/>
+          <a:p>
+            <a:pPr marL="0" indent="0" lvl="0" algn="l">
+              <a:buNone/>
+            </a:pPr>
+            <a:r>
+              <a:rPr lang="es-ES" sz="1050" b="0" i="0" dirty="0">
+                <a:solidFill>
+                  <a:srgbClr val="6B6B6B"/>
+                </a:solidFill>
+                <a:latin typeface="Calibri"/>
+                <a:cs typeface="Calibri"/>
+              </a:rPr>
+              <a:t>En curso / planificado</a:t>
+            </a:r>
+          </a:p>
+        </p:txBody>
+      </p:sp>
+    </p:spTree>
+  </p:cSld>
+  <p:clrMapOvr>
+    <a:masterClrMapping/>
+  </p:clrMapOvr>
+</p:sld>
+</file>
+
+<file path=ppt/slides/slide7.xml><?xml version="1.0" encoding="utf-8"?>
+<p:sld xmlns:a="http://schemas.openxmlformats.org/drawingml/2006/main" xmlns:r="http://schemas.openxmlformats.org/officeDocument/2006/relationships" xmlns:p="http://schemas.openxmlformats.org/presentationml/2006/main">
+  <p:cSld>
+    <p:bg>
+      <p:bgPr>
+        <a:solidFill>
+          <a:srgbClr val="FFFFFF"/>
+        </a:solidFill>
+        <a:effectLst/>
+      </p:bgPr>
+    </p:bg>
+    <p:spTree>
+      <p:nvGrpSpPr>
+        <p:cNvPr id="1" name=""/>
+        <p:cNvGrpSpPr/>
+        <p:nvPr/>
+      </p:nvGrpSpPr>
+      <p:grpSpPr>
+        <a:xfrm>
+          <a:off x="0" y="0"/>
+          <a:ext cx="0" cy="0"/>
+          <a:chOff x="0" y="0"/>
+          <a:chExt cx="0" cy="0"/>
+        </a:xfrm>
+      </p:grpSpPr>
+      <p:sp>
+        <p:nvSpPr>
+          <p:cNvPr id="2" name="band"/>
+          <p:cNvSpPr/>
+          <p:nvPr/>
+        </p:nvSpPr>
+        <p:spPr>
+          <a:xfrm>
+            <a:off x="0" y="0"/>
+            <a:ext cx="12192000" cy="1207008"/>
+          </a:xfrm>
+          <a:prstGeom prst="rect">
+            <a:avLst/>
+          </a:prstGeom>
+          <a:solidFill>
+            <a:srgbClr val="3A3A3A"/>
+          </a:solidFill>
+          <a:ln>
+            <a:noFill/>
+          </a:ln>
+        </p:spPr>
+        <p:txBody>
+          <a:bodyPr/>
+          <a:lstStyle/>
+          <a:p>
+            <a:endParaRPr lang="es-ES"/>
+          </a:p>
+        </p:txBody>
+      </p:sp>
+      <p:sp>
+        <p:nvSpPr>
+          <p:cNvPr id="3" name="logoring"/>
+          <p:cNvSpPr/>
+          <p:nvPr/>
+        </p:nvSpPr>
+        <p:spPr>
+          <a:xfrm>
+            <a:off x="10561320" y="164592"/>
+            <a:ext cx="868680" cy="868680"/>
+          </a:xfrm>
+          <a:prstGeom prst="ellipse">
+            <a:avLst/>
+          </a:prstGeom>
+          <a:solidFill>
+            <a:srgbClr val="FFFFFF"/>
+          </a:solidFill>
+          <a:ln>
+            <a:noFill/>
+          </a:ln>
+        </p:spPr>
+        <p:txBody>
+          <a:bodyPr/>
+          <a:lstStyle/>
+          <a:p>
+            <a:endParaRPr lang="es-ES"/>
+          </a:p>
+        </p:txBody>
+      </p:sp>
+      <p:sp>
+        <p:nvSpPr>
+          <p:cNvPr id="4" name="logo"/>
+          <p:cNvSpPr/>
+          <p:nvPr/>
+        </p:nvSpPr>
+        <p:spPr>
+          <a:xfrm>
+            <a:off x="10635157" y="238429"/>
+            <a:ext cx="721006" cy="721006"/>
+          </a:xfrm>
+          <a:prstGeom prst="ellipse">
+            <a:avLst/>
+          </a:prstGeom>
+          <a:solidFill>
+            <a:srgbClr val="D71920"/>
+          </a:solidFill>
+          <a:ln>
+            <a:noFill/>
+          </a:ln>
+        </p:spPr>
+        <p:txBody>
+          <a:bodyPr wrap="square" anchor="ctr" lIns="73152" tIns="36576" rIns="73152" bIns="36576">
+            <a:normAutofit/>
+          </a:bodyPr>
+          <a:lstStyle/>
+          <a:p>
+            <a:pPr marL="0" indent="0" lvl="0" algn="ctr">
+              <a:buNone/>
+            </a:pPr>
+            <a:r>
+              <a:rPr lang="es-ES" sz="1500" b="1" i="0" spc="120" dirty="0">
+                <a:solidFill>
+                  <a:srgbClr val="FFFFFF"/>
+                </a:solidFill>
+                <a:latin typeface="Calibri"/>
+                <a:cs typeface="Calibri"/>
+              </a:rPr>
+              <a:t>CAV</a:t>
+            </a:r>
+          </a:p>
+        </p:txBody>
+      </p:sp>
+      <p:sp>
+        <p:nvSpPr>
+          <p:cNvPr id="5" name="tb"/>
+          <p:cNvSpPr txBox="1"/>
+          <p:nvPr/>
+        </p:nvSpPr>
+        <p:spPr>
+          <a:xfrm>
+            <a:off x="548640" y="182880"/>
+            <a:ext cx="9601200" cy="365760"/>
+          </a:xfrm>
+          <a:prstGeom prst="rect">
+            <a:avLst/>
+          </a:prstGeom>
+          <a:noFill/>
+        </p:spPr>
+        <p:txBody>
+          <a:bodyPr wrap="square" anchor="t" lIns="73152" tIns="36576" rIns="73152" bIns="36576">
+            <a:normAutofit/>
+          </a:bodyPr>
+          <a:lstStyle/>
+          <a:p>
+            <a:pPr marL="0" indent="0" lvl="0" algn="l">
+              <a:buNone/>
+            </a:pPr>
+            <a:r>
+              <a:rPr lang="es-ES" sz="1050" b="1" i="0" spc="200" dirty="0">
+                <a:solidFill>
+                  <a:srgbClr val="E8711E"/>
+                </a:solidFill>
+                <a:latin typeface="Calibri"/>
+                <a:cs typeface="Calibri"/>
+              </a:rPr>
+              <a:t>RESULTADOS EN CUATRO DIMENSIONES</a:t>
+            </a:r>
+          </a:p>
+        </p:txBody>
+      </p:sp>
+      <p:sp>
+        <p:nvSpPr>
+          <p:cNvPr id="6" name="tb"/>
+          <p:cNvSpPr txBox="1"/>
+          <p:nvPr/>
+        </p:nvSpPr>
+        <p:spPr>
+          <a:xfrm>
+            <a:off x="530352" y="457200"/>
+            <a:ext cx="9692640" cy="731520"/>
+          </a:xfrm>
+          <a:prstGeom prst="rect">
+            <a:avLst/>
+          </a:prstGeom>
+          <a:noFill/>
+        </p:spPr>
+        <p:txBody>
+          <a:bodyPr wrap="square" anchor="t" lIns="73152" tIns="36576" rIns="73152" bIns="36576">
+            <a:normAutofit/>
+          </a:bodyPr>
+          <a:lstStyle/>
+          <a:p>
+            <a:pPr marL="0" indent="0" lvl="0" algn="l">
+              <a:buNone/>
+            </a:pPr>
+            <a:r>
+              <a:rPr lang="es-ES" sz="2600" b="1" i="0" dirty="0">
+                <a:solidFill>
+                  <a:srgbClr val="FFFFFF"/>
+                </a:solidFill>
+                <a:latin typeface="Calibri"/>
+                <a:cs typeface="Calibri"/>
+              </a:rPr>
+              <a:t>Impacto Esperado</a:t>
+            </a:r>
+          </a:p>
+        </p:txBody>
+      </p:sp>
+      <p:sp>
+        <p:nvSpPr>
+          <p:cNvPr id="7" name="sp"/>
+          <p:cNvSpPr/>
+          <p:nvPr/>
+        </p:nvSpPr>
+        <p:spPr>
+          <a:xfrm>
+            <a:off x="566928" y="1371600"/>
+            <a:ext cx="420624" cy="420624"/>
+          </a:xfrm>
+          <a:prstGeom prst="ellipse">
+            <a:avLst/>
+          </a:prstGeom>
+          <a:solidFill>
+            <a:srgbClr val="E8711E"/>
+          </a:solidFill>
+          <a:ln>
+            <a:noFill/>
+          </a:ln>
+        </p:spPr>
+        <p:txBody>
+          <a:bodyPr wrap="square" anchor="ctr" lIns="73152" tIns="36576" rIns="73152" bIns="36576">
+            <a:normAutofit/>
+          </a:bodyPr>
+          <a:lstStyle/>
+          <a:p>
+            <a:pPr marL="0" indent="0" lvl="0" algn="ctr">
+              <a:buNone/>
+            </a:pPr>
+            <a:r>
+              <a:rPr lang="es-ES" sz="1300" b="1" i="0" dirty="0">
+                <a:solidFill>
+                  <a:srgbClr val="FFFFFF"/>
+                </a:solidFill>
+                <a:latin typeface="Calibri"/>
+                <a:cs typeface="Calibri"/>
+              </a:rPr>
+              <a:t>7</a:t>
             </a:r>
           </a:p>
         </p:txBody>

</xml_diff>